<commit_message>
Reworked some docs and added sources to the PP
</commit_message>
<xml_diff>
--- a/docs/Endpraesentation/DAPI_FractalCore_Endpraesentation.pptx
+++ b/docs/Endpraesentation/DAPI_FractalCore_Endpraesentation.pptx
@@ -1,11 +1,11 @@
 
 <file path=ppt/presentation.xml><?xml version="1.0" encoding="utf-8"?>
-<p:presentation xmlns:a="http://schemas.openxmlformats.org/drawingml/2006/main" xmlns:r="http://schemas.openxmlformats.org/officeDocument/2006/relationships" xmlns:p="http://schemas.openxmlformats.org/presentationml/2006/main" saveSubsetFonts="1" autoCompressPictures="0">
+<p:presentation xmlns:a="http://schemas.openxmlformats.org/drawingml/2006/main" xmlns:r="http://schemas.openxmlformats.org/officeDocument/2006/relationships" xmlns:p="http://schemas.openxmlformats.org/presentationml/2006/main" showSpecialPlsOnTitleSld="0" saveSubsetFonts="1" autoCompressPictures="0">
   <p:sldMasterIdLst>
     <p:sldMasterId id="2147483648" r:id="rId1"/>
   </p:sldMasterIdLst>
   <p:notesMasterIdLst>
-    <p:notesMasterId r:id="rId23"/>
+    <p:notesMasterId r:id="rId24"/>
   </p:notesMasterIdLst>
   <p:sldIdLst>
     <p:sldId id="256" r:id="rId2"/>
@@ -29,6 +29,7 @@
     <p:sldId id="279" r:id="rId20"/>
     <p:sldId id="280" r:id="rId21"/>
     <p:sldId id="273" r:id="rId22"/>
+    <p:sldId id="281" r:id="rId23"/>
   </p:sldIdLst>
   <p:sldSz cx="12192000" cy="6858000"/>
   <p:notesSz cx="6858000" cy="9144000"/>
@@ -217,7 +218,7 @@
           <a:p>
             <a:fld id="{25690DA4-8E7E-0941-AA18-ABC55D37EF0E}" type="datetimeFigureOut">
               <a:rPr lang="de-DE" smtClean="0"/>
-              <a:t>14.06.26</a:t>
+              <a:t>15.06.26</a:t>
             </a:fld>
             <a:endParaRPr lang="de-DE"/>
           </a:p>
@@ -576,6 +577,295 @@
   <p:cSld>
     <p:spTree>
       <p:nvGrpSpPr>
+        <p:cNvPr id="1" name=""/>
+        <p:cNvGrpSpPr/>
+        <p:nvPr/>
+      </p:nvGrpSpPr>
+      <p:grpSpPr>
+        <a:xfrm>
+          <a:off x="0" y="0"/>
+          <a:ext cx="0" cy="0"/>
+          <a:chOff x="0" y="0"/>
+          <a:chExt cx="0" cy="0"/>
+        </a:xfrm>
+      </p:grpSpPr>
+      <p:sp>
+        <p:nvSpPr>
+          <p:cNvPr id="2" name="Folienbildplatzhalter 1"/>
+          <p:cNvSpPr>
+            <a:spLocks noGrp="1" noRot="1" noChangeAspect="1"/>
+          </p:cNvSpPr>
+          <p:nvPr>
+            <p:ph type="sldImg"/>
+          </p:nvPr>
+        </p:nvSpPr>
+        <p:spPr/>
+      </p:sp>
+      <p:sp>
+        <p:nvSpPr>
+          <p:cNvPr id="3" name="Notizenplatzhalter 2"/>
+          <p:cNvSpPr>
+            <a:spLocks noGrp="1"/>
+          </p:cNvSpPr>
+          <p:nvPr>
+            <p:ph type="body" idx="1"/>
+          </p:nvPr>
+        </p:nvSpPr>
+        <p:spPr/>
+        <p:txBody>
+          <a:bodyPr/>
+          <a:lstStyle/>
+          <a:p>
+            <a:r>
+              <a:rPr lang="de-DE"/>
+              <a:t>FPGA: 303 Takte, da jede Iteration 3 Stages </a:t>
+            </a:r>
+            <a:r>
+              <a:rPr lang="de-DE">
+                <a:sym typeface="Wingdings" pitchFamily="2" charset="2"/>
+              </a:rPr>
+              <a:t> 300 Takte + 3 Takte für eine Iteration in der das Ergebnis weggeschrieben wird und neue Startwerte geladen werden</a:t>
+            </a:r>
+            <a:endParaRPr lang="de-DE"/>
+          </a:p>
+        </p:txBody>
+      </p:sp>
+      <p:sp>
+        <p:nvSpPr>
+          <p:cNvPr id="4" name="Foliennummernplatzhalter 3"/>
+          <p:cNvSpPr>
+            <a:spLocks noGrp="1"/>
+          </p:cNvSpPr>
+          <p:nvPr>
+            <p:ph type="sldNum" sz="quarter" idx="5"/>
+          </p:nvPr>
+        </p:nvSpPr>
+        <p:spPr/>
+        <p:txBody>
+          <a:bodyPr/>
+          <a:lstStyle/>
+          <a:p>
+            <a:fld id="{BA036D80-E674-C74A-9C41-C7D9BE4A5ABE}" type="slidenum">
+              <a:rPr lang="de-DE" smtClean="0"/>
+              <a:t>14</a:t>
+            </a:fld>
+            <a:endParaRPr lang="de-DE"/>
+          </a:p>
+        </p:txBody>
+      </p:sp>
+    </p:spTree>
+    <p:extLst>
+      <p:ext uri="{BB962C8B-B14F-4D97-AF65-F5344CB8AC3E}">
+        <p14:creationId xmlns:p14="http://schemas.microsoft.com/office/powerpoint/2010/main" val="3492991489"/>
+      </p:ext>
+    </p:extLst>
+  </p:cSld>
+  <p:clrMapOvr>
+    <a:masterClrMapping/>
+  </p:clrMapOvr>
+</p:notes>
+</file>
+
+<file path=ppt/notesSlides/notesSlide11.xml><?xml version="1.0" encoding="utf-8"?>
+<p:notes xmlns:a="http://schemas.openxmlformats.org/drawingml/2006/main" xmlns:r="http://schemas.openxmlformats.org/officeDocument/2006/relationships" xmlns:p="http://schemas.openxmlformats.org/presentationml/2006/main">
+  <p:cSld>
+    <p:spTree>
+      <p:nvGrpSpPr>
+        <p:cNvPr id="1" name=""/>
+        <p:cNvGrpSpPr/>
+        <p:nvPr/>
+      </p:nvGrpSpPr>
+      <p:grpSpPr>
+        <a:xfrm>
+          <a:off x="0" y="0"/>
+          <a:ext cx="0" cy="0"/>
+          <a:chOff x="0" y="0"/>
+          <a:chExt cx="0" cy="0"/>
+        </a:xfrm>
+      </p:grpSpPr>
+      <p:sp>
+        <p:nvSpPr>
+          <p:cNvPr id="2" name="Folienbildplatzhalter 1"/>
+          <p:cNvSpPr>
+            <a:spLocks noGrp="1" noRot="1" noChangeAspect="1"/>
+          </p:cNvSpPr>
+          <p:nvPr>
+            <p:ph type="sldImg"/>
+          </p:nvPr>
+        </p:nvSpPr>
+        <p:spPr/>
+      </p:sp>
+      <p:sp>
+        <p:nvSpPr>
+          <p:cNvPr id="3" name="Notizenplatzhalter 2"/>
+          <p:cNvSpPr>
+            <a:spLocks noGrp="1"/>
+          </p:cNvSpPr>
+          <p:nvPr>
+            <p:ph type="body" idx="1"/>
+          </p:nvPr>
+        </p:nvSpPr>
+        <p:spPr/>
+        <p:txBody>
+          <a:bodyPr/>
+          <a:lstStyle/>
+          <a:p>
+            <a:endParaRPr lang="de-DE" dirty="0"/>
+          </a:p>
+        </p:txBody>
+      </p:sp>
+      <p:sp>
+        <p:nvSpPr>
+          <p:cNvPr id="4" name="Foliennummernplatzhalter 3"/>
+          <p:cNvSpPr>
+            <a:spLocks noGrp="1"/>
+          </p:cNvSpPr>
+          <p:nvPr>
+            <p:ph type="sldNum" sz="quarter" idx="5"/>
+          </p:nvPr>
+        </p:nvSpPr>
+        <p:spPr/>
+        <p:txBody>
+          <a:bodyPr/>
+          <a:lstStyle/>
+          <a:p>
+            <a:fld id="{BA036D80-E674-C74A-9C41-C7D9BE4A5ABE}" type="slidenum">
+              <a:rPr lang="de-DE" smtClean="0"/>
+              <a:t>15</a:t>
+            </a:fld>
+            <a:endParaRPr lang="de-DE"/>
+          </a:p>
+        </p:txBody>
+      </p:sp>
+    </p:spTree>
+    <p:extLst>
+      <p:ext uri="{BB962C8B-B14F-4D97-AF65-F5344CB8AC3E}">
+        <p14:creationId xmlns:p14="http://schemas.microsoft.com/office/powerpoint/2010/main" val="868709162"/>
+      </p:ext>
+    </p:extLst>
+  </p:cSld>
+  <p:clrMapOvr>
+    <a:masterClrMapping/>
+  </p:clrMapOvr>
+</p:notes>
+</file>
+
+<file path=ppt/notesSlides/notesSlide12.xml><?xml version="1.0" encoding="utf-8"?>
+<p:notes xmlns:a="http://schemas.openxmlformats.org/drawingml/2006/main" xmlns:r="http://schemas.openxmlformats.org/officeDocument/2006/relationships" xmlns:p="http://schemas.openxmlformats.org/presentationml/2006/main">
+  <p:cSld>
+    <p:spTree>
+      <p:nvGrpSpPr>
+        <p:cNvPr id="1" name="">
+          <a:extLst>
+            <a:ext uri="{FF2B5EF4-FFF2-40B4-BE49-F238E27FC236}">
+              <a16:creationId xmlns:a16="http://schemas.microsoft.com/office/drawing/2014/main" id="{73F557C5-2C3B-8A6E-713E-EAA61041BBAB}"/>
+            </a:ext>
+          </a:extLst>
+        </p:cNvPr>
+        <p:cNvGrpSpPr/>
+        <p:nvPr/>
+      </p:nvGrpSpPr>
+      <p:grpSpPr>
+        <a:xfrm>
+          <a:off x="0" y="0"/>
+          <a:ext cx="0" cy="0"/>
+          <a:chOff x="0" y="0"/>
+          <a:chExt cx="0" cy="0"/>
+        </a:xfrm>
+      </p:grpSpPr>
+      <p:sp>
+        <p:nvSpPr>
+          <p:cNvPr id="2" name="Folienbildplatzhalter 1">
+            <a:extLst>
+              <a:ext uri="{FF2B5EF4-FFF2-40B4-BE49-F238E27FC236}">
+                <a16:creationId xmlns:a16="http://schemas.microsoft.com/office/drawing/2014/main" id="{CC5F904F-B20D-517A-10C4-167EB057C28F}"/>
+              </a:ext>
+            </a:extLst>
+          </p:cNvPr>
+          <p:cNvSpPr>
+            <a:spLocks noGrp="1" noRot="1" noChangeAspect="1"/>
+          </p:cNvSpPr>
+          <p:nvPr>
+            <p:ph type="sldImg"/>
+          </p:nvPr>
+        </p:nvSpPr>
+        <p:spPr/>
+      </p:sp>
+      <p:sp>
+        <p:nvSpPr>
+          <p:cNvPr id="3" name="Notizenplatzhalter 2">
+            <a:extLst>
+              <a:ext uri="{FF2B5EF4-FFF2-40B4-BE49-F238E27FC236}">
+                <a16:creationId xmlns:a16="http://schemas.microsoft.com/office/drawing/2014/main" id="{5E2BCFB3-4CE1-A872-534B-290564D52C6F}"/>
+              </a:ext>
+            </a:extLst>
+          </p:cNvPr>
+          <p:cNvSpPr>
+            <a:spLocks noGrp="1"/>
+          </p:cNvSpPr>
+          <p:nvPr>
+            <p:ph type="body" idx="1"/>
+          </p:nvPr>
+        </p:nvSpPr>
+        <p:spPr/>
+        <p:txBody>
+          <a:bodyPr/>
+          <a:lstStyle/>
+          <a:p>
+            <a:r>
+              <a:rPr lang="de-DE" dirty="0"/>
+              <a:t>Entspricht der Gliederung</a:t>
+            </a:r>
+          </a:p>
+        </p:txBody>
+      </p:sp>
+      <p:sp>
+        <p:nvSpPr>
+          <p:cNvPr id="4" name="Foliennummernplatzhalter 3">
+            <a:extLst>
+              <a:ext uri="{FF2B5EF4-FFF2-40B4-BE49-F238E27FC236}">
+                <a16:creationId xmlns:a16="http://schemas.microsoft.com/office/drawing/2014/main" id="{9B905205-3ECE-18EF-6A19-980DD241A1E2}"/>
+              </a:ext>
+            </a:extLst>
+          </p:cNvPr>
+          <p:cNvSpPr>
+            <a:spLocks noGrp="1"/>
+          </p:cNvSpPr>
+          <p:nvPr>
+            <p:ph type="sldNum" sz="quarter" idx="5"/>
+          </p:nvPr>
+        </p:nvSpPr>
+        <p:spPr/>
+        <p:txBody>
+          <a:bodyPr/>
+          <a:lstStyle/>
+          <a:p>
+            <a:fld id="{BA036D80-E674-C74A-9C41-C7D9BE4A5ABE}" type="slidenum">
+              <a:rPr lang="de-DE" smtClean="0"/>
+              <a:t>16</a:t>
+            </a:fld>
+            <a:endParaRPr lang="de-DE"/>
+          </a:p>
+        </p:txBody>
+      </p:sp>
+    </p:spTree>
+    <p:extLst>
+      <p:ext uri="{BB962C8B-B14F-4D97-AF65-F5344CB8AC3E}">
+        <p14:creationId xmlns:p14="http://schemas.microsoft.com/office/powerpoint/2010/main" val="3838864188"/>
+      </p:ext>
+    </p:extLst>
+  </p:cSld>
+  <p:clrMapOvr>
+    <a:masterClrMapping/>
+  </p:clrMapOvr>
+</p:notes>
+</file>
+
+<file path=ppt/notesSlides/notesSlide13.xml><?xml version="1.0" encoding="utf-8"?>
+<p:notes xmlns:a="http://schemas.openxmlformats.org/drawingml/2006/main" xmlns:r="http://schemas.openxmlformats.org/officeDocument/2006/relationships" xmlns:p="http://schemas.openxmlformats.org/presentationml/2006/main">
+  <p:cSld>
+    <p:spTree>
+      <p:nvGrpSpPr>
         <p:cNvPr id="1" name="">
           <a:extLst>
             <a:ext uri="{FF2B5EF4-FFF2-40B4-BE49-F238E27FC236}">
@@ -682,7 +972,7 @@
 </p:notes>
 </file>
 
-<file path=ppt/notesSlides/notesSlide11.xml><?xml version="1.0" encoding="utf-8"?>
+<file path=ppt/notesSlides/notesSlide14.xml><?xml version="1.0" encoding="utf-8"?>
 <p:notes xmlns:a="http://schemas.openxmlformats.org/drawingml/2006/main" xmlns:r="http://schemas.openxmlformats.org/officeDocument/2006/relationships" xmlns:p="http://schemas.openxmlformats.org/presentationml/2006/main">
   <p:cSld>
     <p:spTree>
@@ -1128,17 +1418,7 @@
           <a:bodyPr/>
           <a:lstStyle/>
           <a:p>
-            <a:r>
-              <a:rPr lang="de-DE" dirty="0"/>
-              <a:t>NICHT AUF DEN AUFBAU EINGEHEN!</a:t>
-            </a:r>
-            <a:br>
-              <a:rPr lang="de-DE" dirty="0"/>
-            </a:br>
-            <a:r>
-              <a:rPr lang="de-DE" dirty="0"/>
-              <a:t>NUR GROB MIT CRC VERGLEICHEN!</a:t>
-            </a:r>
+            <a:endParaRPr lang="de-DE" dirty="0"/>
           </a:p>
         </p:txBody>
       </p:sp>
@@ -1159,6 +1439,184 @@
           <a:p>
             <a:fld id="{BA036D80-E674-C74A-9C41-C7D9BE4A5ABE}" type="slidenum">
               <a:rPr lang="de-DE" smtClean="0"/>
+              <a:t>5</a:t>
+            </a:fld>
+            <a:endParaRPr lang="de-DE"/>
+          </a:p>
+        </p:txBody>
+      </p:sp>
+    </p:spTree>
+    <p:extLst>
+      <p:ext uri="{BB962C8B-B14F-4D97-AF65-F5344CB8AC3E}">
+        <p14:creationId xmlns:p14="http://schemas.microsoft.com/office/powerpoint/2010/main" val="2930359199"/>
+      </p:ext>
+    </p:extLst>
+  </p:cSld>
+  <p:clrMapOvr>
+    <a:masterClrMapping/>
+  </p:clrMapOvr>
+</p:notes>
+</file>
+
+<file path=ppt/notesSlides/notesSlide6.xml><?xml version="1.0" encoding="utf-8"?>
+<p:notes xmlns:a="http://schemas.openxmlformats.org/drawingml/2006/main" xmlns:r="http://schemas.openxmlformats.org/officeDocument/2006/relationships" xmlns:p="http://schemas.openxmlformats.org/presentationml/2006/main">
+  <p:cSld>
+    <p:spTree>
+      <p:nvGrpSpPr>
+        <p:cNvPr id="1" name=""/>
+        <p:cNvGrpSpPr/>
+        <p:nvPr/>
+      </p:nvGrpSpPr>
+      <p:grpSpPr>
+        <a:xfrm>
+          <a:off x="0" y="0"/>
+          <a:ext cx="0" cy="0"/>
+          <a:chOff x="0" y="0"/>
+          <a:chExt cx="0" cy="0"/>
+        </a:xfrm>
+      </p:grpSpPr>
+      <p:sp>
+        <p:nvSpPr>
+          <p:cNvPr id="2" name="Folienbildplatzhalter 1"/>
+          <p:cNvSpPr>
+            <a:spLocks noGrp="1" noRot="1" noChangeAspect="1"/>
+          </p:cNvSpPr>
+          <p:nvPr>
+            <p:ph type="sldImg"/>
+          </p:nvPr>
+        </p:nvSpPr>
+        <p:spPr/>
+      </p:sp>
+      <p:sp>
+        <p:nvSpPr>
+          <p:cNvPr id="3" name="Notizenplatzhalter 2"/>
+          <p:cNvSpPr>
+            <a:spLocks noGrp="1"/>
+          </p:cNvSpPr>
+          <p:nvPr>
+            <p:ph type="body" idx="1"/>
+          </p:nvPr>
+        </p:nvSpPr>
+        <p:spPr/>
+        <p:txBody>
+          <a:bodyPr/>
+          <a:lstStyle/>
+          <a:p>
+            <a:endParaRPr lang="de-DE" dirty="0"/>
+          </a:p>
+        </p:txBody>
+      </p:sp>
+      <p:sp>
+        <p:nvSpPr>
+          <p:cNvPr id="4" name="Foliennummernplatzhalter 3"/>
+          <p:cNvSpPr>
+            <a:spLocks noGrp="1"/>
+          </p:cNvSpPr>
+          <p:nvPr>
+            <p:ph type="sldNum" sz="quarter" idx="5"/>
+          </p:nvPr>
+        </p:nvSpPr>
+        <p:spPr/>
+        <p:txBody>
+          <a:bodyPr/>
+          <a:lstStyle/>
+          <a:p>
+            <a:fld id="{BA036D80-E674-C74A-9C41-C7D9BE4A5ABE}" type="slidenum">
+              <a:rPr lang="de-DE" smtClean="0"/>
+              <a:t>6</a:t>
+            </a:fld>
+            <a:endParaRPr lang="de-DE"/>
+          </a:p>
+        </p:txBody>
+      </p:sp>
+    </p:spTree>
+    <p:extLst>
+      <p:ext uri="{BB962C8B-B14F-4D97-AF65-F5344CB8AC3E}">
+        <p14:creationId xmlns:p14="http://schemas.microsoft.com/office/powerpoint/2010/main" val="3760591123"/>
+      </p:ext>
+    </p:extLst>
+  </p:cSld>
+  <p:clrMapOvr>
+    <a:masterClrMapping/>
+  </p:clrMapOvr>
+</p:notes>
+</file>
+
+<file path=ppt/notesSlides/notesSlide7.xml><?xml version="1.0" encoding="utf-8"?>
+<p:notes xmlns:a="http://schemas.openxmlformats.org/drawingml/2006/main" xmlns:r="http://schemas.openxmlformats.org/officeDocument/2006/relationships" xmlns:p="http://schemas.openxmlformats.org/presentationml/2006/main">
+  <p:cSld>
+    <p:spTree>
+      <p:nvGrpSpPr>
+        <p:cNvPr id="1" name=""/>
+        <p:cNvGrpSpPr/>
+        <p:nvPr/>
+      </p:nvGrpSpPr>
+      <p:grpSpPr>
+        <a:xfrm>
+          <a:off x="0" y="0"/>
+          <a:ext cx="0" cy="0"/>
+          <a:chOff x="0" y="0"/>
+          <a:chExt cx="0" cy="0"/>
+        </a:xfrm>
+      </p:grpSpPr>
+      <p:sp>
+        <p:nvSpPr>
+          <p:cNvPr id="2" name="Folienbildplatzhalter 1"/>
+          <p:cNvSpPr>
+            <a:spLocks noGrp="1" noRot="1" noChangeAspect="1"/>
+          </p:cNvSpPr>
+          <p:nvPr>
+            <p:ph type="sldImg"/>
+          </p:nvPr>
+        </p:nvSpPr>
+        <p:spPr/>
+      </p:sp>
+      <p:sp>
+        <p:nvSpPr>
+          <p:cNvPr id="3" name="Notizenplatzhalter 2"/>
+          <p:cNvSpPr>
+            <a:spLocks noGrp="1"/>
+          </p:cNvSpPr>
+          <p:nvPr>
+            <p:ph type="body" idx="1"/>
+          </p:nvPr>
+        </p:nvSpPr>
+        <p:spPr/>
+        <p:txBody>
+          <a:bodyPr/>
+          <a:lstStyle/>
+          <a:p>
+            <a:r>
+              <a:rPr lang="de-DE" dirty="0"/>
+              <a:t>NICHT AUF DEN AUFBAU EINGEHEN!</a:t>
+            </a:r>
+            <a:br>
+              <a:rPr lang="de-DE" dirty="0"/>
+            </a:br>
+            <a:r>
+              <a:rPr lang="de-DE" dirty="0"/>
+              <a:t>NUR GROB MIT CRC VERGLEICHEN!</a:t>
+            </a:r>
+          </a:p>
+        </p:txBody>
+      </p:sp>
+      <p:sp>
+        <p:nvSpPr>
+          <p:cNvPr id="4" name="Foliennummernplatzhalter 3"/>
+          <p:cNvSpPr>
+            <a:spLocks noGrp="1"/>
+          </p:cNvSpPr>
+          <p:nvPr>
+            <p:ph type="sldNum" sz="quarter" idx="5"/>
+          </p:nvPr>
+        </p:nvSpPr>
+        <p:spPr/>
+        <p:txBody>
+          <a:bodyPr/>
+          <a:lstStyle/>
+          <a:p>
+            <a:fld id="{BA036D80-E674-C74A-9C41-C7D9BE4A5ABE}" type="slidenum">
+              <a:rPr lang="de-DE" smtClean="0"/>
               <a:t>8</a:t>
             </a:fld>
             <a:endParaRPr lang="de-DE"/>
@@ -1178,7 +1636,7 @@
 </p:notes>
 </file>
 
-<file path=ppt/notesSlides/notesSlide6.xml><?xml version="1.0" encoding="utf-8"?>
+<file path=ppt/notesSlides/notesSlide8.xml><?xml version="1.0" encoding="utf-8"?>
 <p:notes xmlns:a="http://schemas.openxmlformats.org/drawingml/2006/main" xmlns:r="http://schemas.openxmlformats.org/officeDocument/2006/relationships" xmlns:p="http://schemas.openxmlformats.org/presentationml/2006/main">
   <p:cSld>
     <p:spTree>
@@ -1289,7 +1747,7 @@
 </p:notes>
 </file>
 
-<file path=ppt/notesSlides/notesSlide7.xml><?xml version="1.0" encoding="utf-8"?>
+<file path=ppt/notesSlides/notesSlide9.xml><?xml version="1.0" encoding="utf-8"?>
 <p:notes xmlns:a="http://schemas.openxmlformats.org/drawingml/2006/main" xmlns:r="http://schemas.openxmlformats.org/officeDocument/2006/relationships" xmlns:p="http://schemas.openxmlformats.org/presentationml/2006/main">
   <p:cSld>
     <p:spTree>
@@ -1333,17 +1791,7 @@
           <a:bodyPr/>
           <a:lstStyle/>
           <a:p>
-            <a:r>
-              <a:rPr lang="de-DE"/>
-              <a:t>FPGA: 303 Takte, da jede Iteration 3 Stages </a:t>
-            </a:r>
-            <a:r>
-              <a:rPr lang="de-DE">
-                <a:sym typeface="Wingdings" pitchFamily="2" charset="2"/>
-              </a:rPr>
-              <a:t> 300 Takte + 3 Takte für eine Iteration in der das Ergebnis weggeschrieben wird und neue Startwerte geladen werden</a:t>
-            </a:r>
-            <a:endParaRPr lang="de-DE"/>
+            <a:endParaRPr lang="de-DE" dirty="0"/>
           </a:p>
         </p:txBody>
       </p:sp>
@@ -1364,7 +1812,7 @@
           <a:p>
             <a:fld id="{BA036D80-E674-C74A-9C41-C7D9BE4A5ABE}" type="slidenum">
               <a:rPr lang="de-DE" smtClean="0"/>
-              <a:t>14</a:t>
+              <a:t>12</a:t>
             </a:fld>
             <a:endParaRPr lang="de-DE"/>
           </a:p>
@@ -1373,202 +1821,7 @@
     </p:spTree>
     <p:extLst>
       <p:ext uri="{BB962C8B-B14F-4D97-AF65-F5344CB8AC3E}">
-        <p14:creationId xmlns:p14="http://schemas.microsoft.com/office/powerpoint/2010/main" val="3492991489"/>
-      </p:ext>
-    </p:extLst>
-  </p:cSld>
-  <p:clrMapOvr>
-    <a:masterClrMapping/>
-  </p:clrMapOvr>
-</p:notes>
-</file>
-
-<file path=ppt/notesSlides/notesSlide8.xml><?xml version="1.0" encoding="utf-8"?>
-<p:notes xmlns:a="http://schemas.openxmlformats.org/drawingml/2006/main" xmlns:r="http://schemas.openxmlformats.org/officeDocument/2006/relationships" xmlns:p="http://schemas.openxmlformats.org/presentationml/2006/main">
-  <p:cSld>
-    <p:spTree>
-      <p:nvGrpSpPr>
-        <p:cNvPr id="1" name=""/>
-        <p:cNvGrpSpPr/>
-        <p:nvPr/>
-      </p:nvGrpSpPr>
-      <p:grpSpPr>
-        <a:xfrm>
-          <a:off x="0" y="0"/>
-          <a:ext cx="0" cy="0"/>
-          <a:chOff x="0" y="0"/>
-          <a:chExt cx="0" cy="0"/>
-        </a:xfrm>
-      </p:grpSpPr>
-      <p:sp>
-        <p:nvSpPr>
-          <p:cNvPr id="2" name="Folienbildplatzhalter 1"/>
-          <p:cNvSpPr>
-            <a:spLocks noGrp="1" noRot="1" noChangeAspect="1"/>
-          </p:cNvSpPr>
-          <p:nvPr>
-            <p:ph type="sldImg"/>
-          </p:nvPr>
-        </p:nvSpPr>
-        <p:spPr/>
-      </p:sp>
-      <p:sp>
-        <p:nvSpPr>
-          <p:cNvPr id="3" name="Notizenplatzhalter 2"/>
-          <p:cNvSpPr>
-            <a:spLocks noGrp="1"/>
-          </p:cNvSpPr>
-          <p:nvPr>
-            <p:ph type="body" idx="1"/>
-          </p:nvPr>
-        </p:nvSpPr>
-        <p:spPr/>
-        <p:txBody>
-          <a:bodyPr/>
-          <a:lstStyle/>
-          <a:p>
-            <a:endParaRPr lang="de-DE" dirty="0"/>
-          </a:p>
-        </p:txBody>
-      </p:sp>
-      <p:sp>
-        <p:nvSpPr>
-          <p:cNvPr id="4" name="Foliennummernplatzhalter 3"/>
-          <p:cNvSpPr>
-            <a:spLocks noGrp="1"/>
-          </p:cNvSpPr>
-          <p:nvPr>
-            <p:ph type="sldNum" sz="quarter" idx="5"/>
-          </p:nvPr>
-        </p:nvSpPr>
-        <p:spPr/>
-        <p:txBody>
-          <a:bodyPr/>
-          <a:lstStyle/>
-          <a:p>
-            <a:fld id="{BA036D80-E674-C74A-9C41-C7D9BE4A5ABE}" type="slidenum">
-              <a:rPr lang="de-DE" smtClean="0"/>
-              <a:t>15</a:t>
-            </a:fld>
-            <a:endParaRPr lang="de-DE"/>
-          </a:p>
-        </p:txBody>
-      </p:sp>
-    </p:spTree>
-    <p:extLst>
-      <p:ext uri="{BB962C8B-B14F-4D97-AF65-F5344CB8AC3E}">
-        <p14:creationId xmlns:p14="http://schemas.microsoft.com/office/powerpoint/2010/main" val="868709162"/>
-      </p:ext>
-    </p:extLst>
-  </p:cSld>
-  <p:clrMapOvr>
-    <a:masterClrMapping/>
-  </p:clrMapOvr>
-</p:notes>
-</file>
-
-<file path=ppt/notesSlides/notesSlide9.xml><?xml version="1.0" encoding="utf-8"?>
-<p:notes xmlns:a="http://schemas.openxmlformats.org/drawingml/2006/main" xmlns:r="http://schemas.openxmlformats.org/officeDocument/2006/relationships" xmlns:p="http://schemas.openxmlformats.org/presentationml/2006/main">
-  <p:cSld>
-    <p:spTree>
-      <p:nvGrpSpPr>
-        <p:cNvPr id="1" name="">
-          <a:extLst>
-            <a:ext uri="{FF2B5EF4-FFF2-40B4-BE49-F238E27FC236}">
-              <a16:creationId xmlns:a16="http://schemas.microsoft.com/office/drawing/2014/main" id="{73F557C5-2C3B-8A6E-713E-EAA61041BBAB}"/>
-            </a:ext>
-          </a:extLst>
-        </p:cNvPr>
-        <p:cNvGrpSpPr/>
-        <p:nvPr/>
-      </p:nvGrpSpPr>
-      <p:grpSpPr>
-        <a:xfrm>
-          <a:off x="0" y="0"/>
-          <a:ext cx="0" cy="0"/>
-          <a:chOff x="0" y="0"/>
-          <a:chExt cx="0" cy="0"/>
-        </a:xfrm>
-      </p:grpSpPr>
-      <p:sp>
-        <p:nvSpPr>
-          <p:cNvPr id="2" name="Folienbildplatzhalter 1">
-            <a:extLst>
-              <a:ext uri="{FF2B5EF4-FFF2-40B4-BE49-F238E27FC236}">
-                <a16:creationId xmlns:a16="http://schemas.microsoft.com/office/drawing/2014/main" id="{CC5F904F-B20D-517A-10C4-167EB057C28F}"/>
-              </a:ext>
-            </a:extLst>
-          </p:cNvPr>
-          <p:cNvSpPr>
-            <a:spLocks noGrp="1" noRot="1" noChangeAspect="1"/>
-          </p:cNvSpPr>
-          <p:nvPr>
-            <p:ph type="sldImg"/>
-          </p:nvPr>
-        </p:nvSpPr>
-        <p:spPr/>
-      </p:sp>
-      <p:sp>
-        <p:nvSpPr>
-          <p:cNvPr id="3" name="Notizenplatzhalter 2">
-            <a:extLst>
-              <a:ext uri="{FF2B5EF4-FFF2-40B4-BE49-F238E27FC236}">
-                <a16:creationId xmlns:a16="http://schemas.microsoft.com/office/drawing/2014/main" id="{5E2BCFB3-4CE1-A872-534B-290564D52C6F}"/>
-              </a:ext>
-            </a:extLst>
-          </p:cNvPr>
-          <p:cNvSpPr>
-            <a:spLocks noGrp="1"/>
-          </p:cNvSpPr>
-          <p:nvPr>
-            <p:ph type="body" idx="1"/>
-          </p:nvPr>
-        </p:nvSpPr>
-        <p:spPr/>
-        <p:txBody>
-          <a:bodyPr/>
-          <a:lstStyle/>
-          <a:p>
-            <a:r>
-              <a:rPr lang="de-DE" dirty="0"/>
-              <a:t>Entspricht der Gliederung</a:t>
-            </a:r>
-          </a:p>
-        </p:txBody>
-      </p:sp>
-      <p:sp>
-        <p:nvSpPr>
-          <p:cNvPr id="4" name="Foliennummernplatzhalter 3">
-            <a:extLst>
-              <a:ext uri="{FF2B5EF4-FFF2-40B4-BE49-F238E27FC236}">
-                <a16:creationId xmlns:a16="http://schemas.microsoft.com/office/drawing/2014/main" id="{9B905205-3ECE-18EF-6A19-980DD241A1E2}"/>
-              </a:ext>
-            </a:extLst>
-          </p:cNvPr>
-          <p:cNvSpPr>
-            <a:spLocks noGrp="1"/>
-          </p:cNvSpPr>
-          <p:nvPr>
-            <p:ph type="sldNum" sz="quarter" idx="5"/>
-          </p:nvPr>
-        </p:nvSpPr>
-        <p:spPr/>
-        <p:txBody>
-          <a:bodyPr/>
-          <a:lstStyle/>
-          <a:p>
-            <a:fld id="{BA036D80-E674-C74A-9C41-C7D9BE4A5ABE}" type="slidenum">
-              <a:rPr lang="de-DE" smtClean="0"/>
-              <a:t>16</a:t>
-            </a:fld>
-            <a:endParaRPr lang="de-DE"/>
-          </a:p>
-        </p:txBody>
-      </p:sp>
-    </p:spTree>
-    <p:extLst>
-      <p:ext uri="{BB962C8B-B14F-4D97-AF65-F5344CB8AC3E}">
-        <p14:creationId xmlns:p14="http://schemas.microsoft.com/office/powerpoint/2010/main" val="3838864188"/>
+        <p14:creationId xmlns:p14="http://schemas.microsoft.com/office/powerpoint/2010/main" val="1854896208"/>
       </p:ext>
     </p:extLst>
   </p:cSld>
@@ -1723,9 +1976,9 @@
           <a:bodyPr/>
           <a:lstStyle/>
           <a:p>
-            <a:fld id="{98E44DE7-3285-8D44-BCA8-8E65601213C7}" type="datetimeFigureOut">
+            <a:fld id="{E6DFA5A1-A813-7B43-85D4-C153DE6EEC5D}" type="datetime1">
               <a:rPr lang="de-DE" smtClean="0"/>
-              <a:t>14.06.26</a:t>
+              <a:t>15.06.26</a:t>
             </a:fld>
             <a:endParaRPr lang="de-DE"/>
           </a:p>
@@ -1921,9 +2174,9 @@
           <a:bodyPr/>
           <a:lstStyle/>
           <a:p>
-            <a:fld id="{98E44DE7-3285-8D44-BCA8-8E65601213C7}" type="datetimeFigureOut">
+            <a:fld id="{85A7F633-92B1-A640-B682-55DDF7097609}" type="datetime1">
               <a:rPr lang="de-DE" smtClean="0"/>
-              <a:t>14.06.26</a:t>
+              <a:t>15.06.26</a:t>
             </a:fld>
             <a:endParaRPr lang="de-DE"/>
           </a:p>
@@ -2129,9 +2382,9 @@
           <a:bodyPr/>
           <a:lstStyle/>
           <a:p>
-            <a:fld id="{98E44DE7-3285-8D44-BCA8-8E65601213C7}" type="datetimeFigureOut">
+            <a:fld id="{6B0DB9B7-7C2A-CA43-A176-0C82CB77F997}" type="datetime1">
               <a:rPr lang="de-DE" smtClean="0"/>
-              <a:t>14.06.26</a:t>
+              <a:t>15.06.26</a:t>
             </a:fld>
             <a:endParaRPr lang="de-DE"/>
           </a:p>
@@ -2322,14 +2575,19 @@
             <p:ph type="dt" sz="half" idx="10"/>
           </p:nvPr>
         </p:nvSpPr>
-        <p:spPr/>
+        <p:spPr>
+          <a:xfrm>
+            <a:off x="838200" y="6481040"/>
+            <a:ext cx="2743200" cy="365125"/>
+          </a:xfrm>
+        </p:spPr>
         <p:txBody>
           <a:bodyPr/>
           <a:lstStyle/>
           <a:p>
-            <a:fld id="{98E44DE7-3285-8D44-BCA8-8E65601213C7}" type="datetimeFigureOut">
+            <a:fld id="{04634442-C186-E94E-B304-D4E0857BF857}" type="datetime1">
               <a:rPr lang="de-DE" smtClean="0"/>
-              <a:t>14.06.26</a:t>
+              <a:t>15.06.26</a:t>
             </a:fld>
             <a:endParaRPr lang="de-DE"/>
           </a:p>
@@ -2351,12 +2609,17 @@
             <p:ph type="ftr" sz="quarter" idx="11"/>
           </p:nvPr>
         </p:nvSpPr>
-        <p:spPr/>
+        <p:spPr>
+          <a:xfrm>
+            <a:off x="4038600" y="6481039"/>
+            <a:ext cx="4114800" cy="365125"/>
+          </a:xfrm>
+        </p:spPr>
         <p:txBody>
           <a:bodyPr/>
           <a:lstStyle/>
           <a:p>
-            <a:endParaRPr lang="de-DE"/>
+            <a:endParaRPr lang="de-DE" dirty="0"/>
           </a:p>
         </p:txBody>
       </p:sp>
@@ -2376,7 +2639,12 @@
             <p:ph type="sldNum" sz="quarter" idx="12"/>
           </p:nvPr>
         </p:nvSpPr>
-        <p:spPr/>
+        <p:spPr>
+          <a:xfrm>
+            <a:off x="8610600" y="6481039"/>
+            <a:ext cx="2743200" cy="365125"/>
+          </a:xfrm>
+        </p:spPr>
         <p:txBody>
           <a:bodyPr/>
           <a:lstStyle/>
@@ -2385,7 +2653,7 @@
               <a:rPr lang="de-DE" smtClean="0"/>
               <a:t>‹Nr.›</a:t>
             </a:fld>
-            <a:endParaRPr lang="de-DE"/>
+            <a:endParaRPr lang="de-DE" dirty="0"/>
           </a:p>
         </p:txBody>
       </p:sp>
@@ -2602,9 +2870,9 @@
           <a:bodyPr/>
           <a:lstStyle/>
           <a:p>
-            <a:fld id="{98E44DE7-3285-8D44-BCA8-8E65601213C7}" type="datetimeFigureOut">
+            <a:fld id="{3ACE65F1-39AD-D942-81CC-A8B185C49E41}" type="datetime1">
               <a:rPr lang="de-DE" smtClean="0"/>
-              <a:t>14.06.26</a:t>
+              <a:t>15.06.26</a:t>
             </a:fld>
             <a:endParaRPr lang="de-DE"/>
           </a:p>
@@ -2867,9 +3135,9 @@
           <a:bodyPr/>
           <a:lstStyle/>
           <a:p>
-            <a:fld id="{98E44DE7-3285-8D44-BCA8-8E65601213C7}" type="datetimeFigureOut">
+            <a:fld id="{15B311CB-D684-6D4F-A48A-21B70AE7BE5E}" type="datetime1">
               <a:rPr lang="de-DE" smtClean="0"/>
-              <a:t>14.06.26</a:t>
+              <a:t>15.06.26</a:t>
             </a:fld>
             <a:endParaRPr lang="de-DE"/>
           </a:p>
@@ -3279,9 +3547,9 @@
           <a:bodyPr/>
           <a:lstStyle/>
           <a:p>
-            <a:fld id="{98E44DE7-3285-8D44-BCA8-8E65601213C7}" type="datetimeFigureOut">
+            <a:fld id="{1F54E48E-21DA-704B-B06E-619E9794DDDC}" type="datetime1">
               <a:rPr lang="de-DE" smtClean="0"/>
-              <a:t>14.06.26</a:t>
+              <a:t>15.06.26</a:t>
             </a:fld>
             <a:endParaRPr lang="de-DE"/>
           </a:p>
@@ -3420,9 +3688,9 @@
           <a:bodyPr/>
           <a:lstStyle/>
           <a:p>
-            <a:fld id="{98E44DE7-3285-8D44-BCA8-8E65601213C7}" type="datetimeFigureOut">
+            <a:fld id="{4DB5E8C2-ED39-FA4A-892C-5D69F297ACBF}" type="datetime1">
               <a:rPr lang="de-DE" smtClean="0"/>
-              <a:t>14.06.26</a:t>
+              <a:t>15.06.26</a:t>
             </a:fld>
             <a:endParaRPr lang="de-DE"/>
           </a:p>
@@ -3533,9 +3801,9 @@
           <a:bodyPr/>
           <a:lstStyle/>
           <a:p>
-            <a:fld id="{98E44DE7-3285-8D44-BCA8-8E65601213C7}" type="datetimeFigureOut">
+            <a:fld id="{ECC4A7F1-D4D8-1545-AA93-BB835A9F7A8B}" type="datetime1">
               <a:rPr lang="de-DE" smtClean="0"/>
-              <a:t>14.06.26</a:t>
+              <a:t>15.06.26</a:t>
             </a:fld>
             <a:endParaRPr lang="de-DE"/>
           </a:p>
@@ -3844,9 +4112,9 @@
           <a:bodyPr/>
           <a:lstStyle/>
           <a:p>
-            <a:fld id="{98E44DE7-3285-8D44-BCA8-8E65601213C7}" type="datetimeFigureOut">
+            <a:fld id="{A04B4EF1-1BB5-A140-8507-2D8B6A510087}" type="datetime1">
               <a:rPr lang="de-DE" smtClean="0"/>
-              <a:t>14.06.26</a:t>
+              <a:t>15.06.26</a:t>
             </a:fld>
             <a:endParaRPr lang="de-DE"/>
           </a:p>
@@ -4132,9 +4400,9 @@
           <a:bodyPr/>
           <a:lstStyle/>
           <a:p>
-            <a:fld id="{98E44DE7-3285-8D44-BCA8-8E65601213C7}" type="datetimeFigureOut">
+            <a:fld id="{C33BA3A3-CA4A-E644-9084-D797594CB804}" type="datetime1">
               <a:rPr lang="de-DE" smtClean="0"/>
-              <a:t>14.06.26</a:t>
+              <a:t>15.06.26</a:t>
             </a:fld>
             <a:endParaRPr lang="de-DE"/>
           </a:p>
@@ -4373,9 +4641,9 @@
             </a:lvl1pPr>
           </a:lstStyle>
           <a:p>
-            <a:fld id="{98E44DE7-3285-8D44-BCA8-8E65601213C7}" type="datetimeFigureOut">
+            <a:fld id="{A7D163E4-7209-8D4B-B12D-5159794EF612}" type="datetime1">
               <a:rPr lang="de-DE" smtClean="0"/>
-              <a:t>14.06.26</a:t>
+              <a:t>15.06.26</a:t>
             </a:fld>
             <a:endParaRPr lang="de-DE"/>
           </a:p>
@@ -4492,6 +4760,7 @@
     <p:sldLayoutId id="2147483658" r:id="rId10"/>
     <p:sldLayoutId id="2147483659" r:id="rId11"/>
   </p:sldLayoutIdLst>
+  <p:hf hdr="0" ftr="0" dt="0"/>
   <p:txStyles>
     <p:titleStyle>
       <a:lvl1pPr algn="l" defTabSz="914400" rtl="0" eaLnBrk="1" latinLnBrk="0" hangingPunct="1">
@@ -7229,6 +7498,35 @@
           </a:p>
         </p:txBody>
       </p:sp>
+      <p:sp>
+        <p:nvSpPr>
+          <p:cNvPr id="9" name="Foliennummernplatzhalter 8">
+            <a:extLst>
+              <a:ext uri="{FF2B5EF4-FFF2-40B4-BE49-F238E27FC236}">
+                <a16:creationId xmlns:a16="http://schemas.microsoft.com/office/drawing/2014/main" id="{E600E28D-B405-0408-A30C-FE3B423FEE18}"/>
+              </a:ext>
+            </a:extLst>
+          </p:cNvPr>
+          <p:cNvSpPr>
+            <a:spLocks noGrp="1"/>
+          </p:cNvSpPr>
+          <p:nvPr>
+            <p:ph type="sldNum" sz="quarter" idx="12"/>
+          </p:nvPr>
+        </p:nvSpPr>
+        <p:spPr/>
+        <p:txBody>
+          <a:bodyPr/>
+          <a:lstStyle/>
+          <a:p>
+            <a:fld id="{6C43980B-2C02-594B-9C73-A951FE425682}" type="slidenum">
+              <a:rPr lang="de-DE" smtClean="0"/>
+              <a:t>10</a:t>
+            </a:fld>
+            <a:endParaRPr lang="de-DE" dirty="0"/>
+          </a:p>
+        </p:txBody>
+      </p:sp>
     </p:spTree>
     <p:extLst>
       <p:ext uri="{BB962C8B-B14F-4D97-AF65-F5344CB8AC3E}">
@@ -9808,6 +10106,35 @@
           </a:p>
         </p:txBody>
       </p:sp>
+      <p:sp>
+        <p:nvSpPr>
+          <p:cNvPr id="9" name="Foliennummernplatzhalter 8">
+            <a:extLst>
+              <a:ext uri="{FF2B5EF4-FFF2-40B4-BE49-F238E27FC236}">
+                <a16:creationId xmlns:a16="http://schemas.microsoft.com/office/drawing/2014/main" id="{45321E21-DB94-FC9E-5341-84E7B13B65B1}"/>
+              </a:ext>
+            </a:extLst>
+          </p:cNvPr>
+          <p:cNvSpPr>
+            <a:spLocks noGrp="1"/>
+          </p:cNvSpPr>
+          <p:nvPr>
+            <p:ph type="sldNum" sz="quarter" idx="12"/>
+          </p:nvPr>
+        </p:nvSpPr>
+        <p:spPr/>
+        <p:txBody>
+          <a:bodyPr/>
+          <a:lstStyle/>
+          <a:p>
+            <a:fld id="{6C43980B-2C02-594B-9C73-A951FE425682}" type="slidenum">
+              <a:rPr lang="de-DE" smtClean="0"/>
+              <a:t>11</a:t>
+            </a:fld>
+            <a:endParaRPr lang="de-DE" dirty="0"/>
+          </a:p>
+        </p:txBody>
+      </p:sp>
     </p:spTree>
     <p:extLst>
       <p:ext uri="{BB962C8B-B14F-4D97-AF65-F5344CB8AC3E}">
@@ -10560,7 +10887,7 @@
                 <a:avLst/>
               </a:prstGeom>
               <a:blipFill>
-                <a:blip r:embed="rId2"/>
+                <a:blip r:embed="rId3"/>
                 <a:stretch>
                   <a:fillRect/>
                 </a:stretch>
@@ -10997,7 +11324,7 @@
                 <a:avLst/>
               </a:prstGeom>
               <a:blipFill>
-                <a:blip r:embed="rId3"/>
+                <a:blip r:embed="rId4"/>
                 <a:stretch>
                   <a:fillRect/>
                 </a:stretch>
@@ -11207,7 +11534,7 @@
                 <a:avLst/>
               </a:prstGeom>
               <a:blipFill>
-                <a:blip r:embed="rId4"/>
+                <a:blip r:embed="rId5"/>
                 <a:stretch>
                   <a:fillRect b="-12903"/>
                 </a:stretch>
@@ -11510,7 +11837,7 @@
                 <a:avLst/>
               </a:prstGeom>
               <a:blipFill>
-                <a:blip r:embed="rId5"/>
+                <a:blip r:embed="rId6"/>
                 <a:stretch>
                   <a:fillRect/>
                 </a:stretch>
@@ -11699,7 +12026,7 @@
                 <a:avLst/>
               </a:prstGeom>
               <a:blipFill>
-                <a:blip r:embed="rId6"/>
+                <a:blip r:embed="rId7"/>
                 <a:stretch>
                   <a:fillRect/>
                 </a:stretch>
@@ -11866,7 +12193,7 @@
                 <a:avLst/>
               </a:prstGeom>
               <a:blipFill>
-                <a:blip r:embed="rId7"/>
+                <a:blip r:embed="rId8"/>
                 <a:stretch>
                   <a:fillRect/>
                 </a:stretch>
@@ -12542,7 +12869,7 @@
                 <a:avLst/>
               </a:prstGeom>
               <a:blipFill>
-                <a:blip r:embed="rId8"/>
+                <a:blip r:embed="rId9"/>
                 <a:stretch>
                   <a:fillRect/>
                 </a:stretch>
@@ -12728,7 +13055,7 @@
                 <a:avLst/>
               </a:prstGeom>
               <a:blipFill>
-                <a:blip r:embed="rId9"/>
+                <a:blip r:embed="rId10"/>
                 <a:stretch>
                   <a:fillRect/>
                 </a:stretch>
@@ -12910,7 +13237,7 @@
                 <a:avLst/>
               </a:prstGeom>
               <a:blipFill>
-                <a:blip r:embed="rId10"/>
+                <a:blip r:embed="rId11"/>
                 <a:stretch>
                   <a:fillRect/>
                 </a:stretch>
@@ -13068,6 +13395,68 @@
             <a:r>
               <a:rPr lang="de-DE" sz="2400" b="1" dirty="0"/>
               <a:t>Core</a:t>
+            </a:r>
+          </a:p>
+        </p:txBody>
+      </p:sp>
+      <p:sp>
+        <p:nvSpPr>
+          <p:cNvPr id="13" name="Foliennummernplatzhalter 12">
+            <a:extLst>
+              <a:ext uri="{FF2B5EF4-FFF2-40B4-BE49-F238E27FC236}">
+                <a16:creationId xmlns:a16="http://schemas.microsoft.com/office/drawing/2014/main" id="{EF6706F5-8228-4CB3-83C8-2A95DA0EDD8E}"/>
+              </a:ext>
+            </a:extLst>
+          </p:cNvPr>
+          <p:cNvSpPr>
+            <a:spLocks noGrp="1"/>
+          </p:cNvSpPr>
+          <p:nvPr>
+            <p:ph type="sldNum" sz="quarter" idx="12"/>
+          </p:nvPr>
+        </p:nvSpPr>
+        <p:spPr/>
+        <p:txBody>
+          <a:bodyPr/>
+          <a:lstStyle/>
+          <a:p>
+            <a:fld id="{6C43980B-2C02-594B-9C73-A951FE425682}" type="slidenum">
+              <a:rPr lang="de-DE" smtClean="0"/>
+              <a:t>12</a:t>
+            </a:fld>
+            <a:endParaRPr lang="de-DE" dirty="0"/>
+          </a:p>
+        </p:txBody>
+      </p:sp>
+      <p:sp>
+        <p:nvSpPr>
+          <p:cNvPr id="15" name="Fußzeilenplatzhalter 14">
+            <a:extLst>
+              <a:ext uri="{FF2B5EF4-FFF2-40B4-BE49-F238E27FC236}">
+                <a16:creationId xmlns:a16="http://schemas.microsoft.com/office/drawing/2014/main" id="{5386D885-EA8E-C386-3FB8-9045C1937304}"/>
+              </a:ext>
+            </a:extLst>
+          </p:cNvPr>
+          <p:cNvSpPr>
+            <a:spLocks noGrp="1"/>
+          </p:cNvSpPr>
+          <p:nvPr>
+            <p:ph type="ftr" sz="quarter" idx="11"/>
+          </p:nvPr>
+        </p:nvSpPr>
+        <p:spPr>
+          <a:xfrm>
+            <a:off x="1264141" y="6500498"/>
+            <a:ext cx="9663718" cy="365125"/>
+          </a:xfrm>
+        </p:spPr>
+        <p:txBody>
+          <a:bodyPr/>
+          <a:lstStyle/>
+          <a:p>
+            <a:r>
+              <a:rPr lang="de-DE" dirty="0"/>
+              <a:t>[4]</a:t>
             </a:r>
           </a:p>
         </p:txBody>
@@ -17212,6 +17601,35 @@
           </a:p>
         </p:txBody>
       </p:sp>
+      <p:sp>
+        <p:nvSpPr>
+          <p:cNvPr id="5" name="Foliennummernplatzhalter 4">
+            <a:extLst>
+              <a:ext uri="{FF2B5EF4-FFF2-40B4-BE49-F238E27FC236}">
+                <a16:creationId xmlns:a16="http://schemas.microsoft.com/office/drawing/2014/main" id="{D88FB4B3-4AEF-CBB1-7341-41EED0C341B8}"/>
+              </a:ext>
+            </a:extLst>
+          </p:cNvPr>
+          <p:cNvSpPr>
+            <a:spLocks noGrp="1"/>
+          </p:cNvSpPr>
+          <p:nvPr>
+            <p:ph type="sldNum" sz="quarter" idx="12"/>
+          </p:nvPr>
+        </p:nvSpPr>
+        <p:spPr/>
+        <p:txBody>
+          <a:bodyPr/>
+          <a:lstStyle/>
+          <a:p>
+            <a:fld id="{6C43980B-2C02-594B-9C73-A951FE425682}" type="slidenum">
+              <a:rPr lang="de-DE" smtClean="0"/>
+              <a:t>13</a:t>
+            </a:fld>
+            <a:endParaRPr lang="de-DE" dirty="0"/>
+          </a:p>
+        </p:txBody>
+      </p:sp>
     </p:spTree>
     <p:extLst>
       <p:ext uri="{BB962C8B-B14F-4D97-AF65-F5344CB8AC3E}">
@@ -17979,6 +18397,35 @@
           </a:p>
         </p:txBody>
       </p:sp>
+      <p:sp>
+        <p:nvSpPr>
+          <p:cNvPr id="12" name="Foliennummernplatzhalter 11">
+            <a:extLst>
+              <a:ext uri="{FF2B5EF4-FFF2-40B4-BE49-F238E27FC236}">
+                <a16:creationId xmlns:a16="http://schemas.microsoft.com/office/drawing/2014/main" id="{0871AB4F-14E1-6805-823A-D91D2BE7AF30}"/>
+              </a:ext>
+            </a:extLst>
+          </p:cNvPr>
+          <p:cNvSpPr>
+            <a:spLocks noGrp="1"/>
+          </p:cNvSpPr>
+          <p:nvPr>
+            <p:ph type="sldNum" sz="quarter" idx="12"/>
+          </p:nvPr>
+        </p:nvSpPr>
+        <p:spPr/>
+        <p:txBody>
+          <a:bodyPr/>
+          <a:lstStyle/>
+          <a:p>
+            <a:fld id="{6C43980B-2C02-594B-9C73-A951FE425682}" type="slidenum">
+              <a:rPr lang="de-DE" smtClean="0"/>
+              <a:t>14</a:t>
+            </a:fld>
+            <a:endParaRPr lang="de-DE" dirty="0"/>
+          </a:p>
+        </p:txBody>
+      </p:sp>
     </p:spTree>
     <p:extLst>
       <p:ext uri="{BB962C8B-B14F-4D97-AF65-F5344CB8AC3E}">
@@ -18133,6 +18580,35 @@
           </a:p>
         </p:txBody>
       </p:sp>
+      <p:sp>
+        <p:nvSpPr>
+          <p:cNvPr id="4" name="Foliennummernplatzhalter 3">
+            <a:extLst>
+              <a:ext uri="{FF2B5EF4-FFF2-40B4-BE49-F238E27FC236}">
+                <a16:creationId xmlns:a16="http://schemas.microsoft.com/office/drawing/2014/main" id="{76709A9A-3B8F-E64A-ACFE-4D9AB0B08E98}"/>
+              </a:ext>
+            </a:extLst>
+          </p:cNvPr>
+          <p:cNvSpPr>
+            <a:spLocks noGrp="1"/>
+          </p:cNvSpPr>
+          <p:nvPr>
+            <p:ph type="sldNum" sz="quarter" idx="12"/>
+          </p:nvPr>
+        </p:nvSpPr>
+        <p:spPr/>
+        <p:txBody>
+          <a:bodyPr/>
+          <a:lstStyle/>
+          <a:p>
+            <a:fld id="{6C43980B-2C02-594B-9C73-A951FE425682}" type="slidenum">
+              <a:rPr lang="de-DE" smtClean="0"/>
+              <a:t>15</a:t>
+            </a:fld>
+            <a:endParaRPr lang="de-DE" dirty="0"/>
+          </a:p>
+        </p:txBody>
+      </p:sp>
     </p:spTree>
     <p:extLst>
       <p:ext uri="{BB962C8B-B14F-4D97-AF65-F5344CB8AC3E}">
@@ -18226,6 +18702,35 @@
           </a:prstGeom>
         </p:spPr>
       </p:pic>
+      <p:sp>
+        <p:nvSpPr>
+          <p:cNvPr id="4" name="Foliennummernplatzhalter 3">
+            <a:extLst>
+              <a:ext uri="{FF2B5EF4-FFF2-40B4-BE49-F238E27FC236}">
+                <a16:creationId xmlns:a16="http://schemas.microsoft.com/office/drawing/2014/main" id="{803E6945-ED2F-5E17-0940-E577F073E16A}"/>
+              </a:ext>
+            </a:extLst>
+          </p:cNvPr>
+          <p:cNvSpPr>
+            <a:spLocks noGrp="1"/>
+          </p:cNvSpPr>
+          <p:nvPr>
+            <p:ph type="sldNum" sz="quarter" idx="12"/>
+          </p:nvPr>
+        </p:nvSpPr>
+        <p:spPr/>
+        <p:txBody>
+          <a:bodyPr/>
+          <a:lstStyle/>
+          <a:p>
+            <a:fld id="{6C43980B-2C02-594B-9C73-A951FE425682}" type="slidenum">
+              <a:rPr lang="de-DE" smtClean="0"/>
+              <a:t>16</a:t>
+            </a:fld>
+            <a:endParaRPr lang="de-DE" dirty="0"/>
+          </a:p>
+        </p:txBody>
+      </p:sp>
     </p:spTree>
     <p:extLst>
       <p:ext uri="{BB962C8B-B14F-4D97-AF65-F5344CB8AC3E}">
@@ -18315,6 +18820,35 @@
               <a:rPr lang="de-DE"/>
               <a:t>PLATZHALTER FOLIEN THOMAS</a:t>
             </a:r>
+          </a:p>
+        </p:txBody>
+      </p:sp>
+      <p:sp>
+        <p:nvSpPr>
+          <p:cNvPr id="5" name="Foliennummernplatzhalter 4">
+            <a:extLst>
+              <a:ext uri="{FF2B5EF4-FFF2-40B4-BE49-F238E27FC236}">
+                <a16:creationId xmlns:a16="http://schemas.microsoft.com/office/drawing/2014/main" id="{15BA7432-55AD-BF15-A200-71B9C392C6E6}"/>
+              </a:ext>
+            </a:extLst>
+          </p:cNvPr>
+          <p:cNvSpPr>
+            <a:spLocks noGrp="1"/>
+          </p:cNvSpPr>
+          <p:nvPr>
+            <p:ph type="sldNum" sz="quarter" idx="12"/>
+          </p:nvPr>
+        </p:nvSpPr>
+        <p:spPr/>
+        <p:txBody>
+          <a:bodyPr/>
+          <a:lstStyle/>
+          <a:p>
+            <a:fld id="{6C43980B-2C02-594B-9C73-A951FE425682}" type="slidenum">
+              <a:rPr lang="de-DE" smtClean="0"/>
+              <a:t>17</a:t>
+            </a:fld>
+            <a:endParaRPr lang="de-DE" dirty="0"/>
           </a:p>
         </p:txBody>
       </p:sp>
@@ -18411,6 +18945,35 @@
           </a:prstGeom>
         </p:spPr>
       </p:pic>
+      <p:sp>
+        <p:nvSpPr>
+          <p:cNvPr id="4" name="Foliennummernplatzhalter 3">
+            <a:extLst>
+              <a:ext uri="{FF2B5EF4-FFF2-40B4-BE49-F238E27FC236}">
+                <a16:creationId xmlns:a16="http://schemas.microsoft.com/office/drawing/2014/main" id="{128A7AEF-E6A9-7F75-E976-51766D21D333}"/>
+              </a:ext>
+            </a:extLst>
+          </p:cNvPr>
+          <p:cNvSpPr>
+            <a:spLocks noGrp="1"/>
+          </p:cNvSpPr>
+          <p:nvPr>
+            <p:ph type="sldNum" sz="quarter" idx="12"/>
+          </p:nvPr>
+        </p:nvSpPr>
+        <p:spPr/>
+        <p:txBody>
+          <a:bodyPr/>
+          <a:lstStyle/>
+          <a:p>
+            <a:fld id="{6C43980B-2C02-594B-9C73-A951FE425682}" type="slidenum">
+              <a:rPr lang="de-DE" smtClean="0"/>
+              <a:t>18</a:t>
+            </a:fld>
+            <a:endParaRPr lang="de-DE" dirty="0"/>
+          </a:p>
+        </p:txBody>
+      </p:sp>
     </p:spTree>
     <p:extLst>
       <p:ext uri="{BB962C8B-B14F-4D97-AF65-F5344CB8AC3E}">
@@ -18503,6 +19066,35 @@
           </a:p>
         </p:txBody>
       </p:sp>
+      <p:sp>
+        <p:nvSpPr>
+          <p:cNvPr id="5" name="Foliennummernplatzhalter 4">
+            <a:extLst>
+              <a:ext uri="{FF2B5EF4-FFF2-40B4-BE49-F238E27FC236}">
+                <a16:creationId xmlns:a16="http://schemas.microsoft.com/office/drawing/2014/main" id="{C4EB4A93-4072-4650-9012-861B2F5AB581}"/>
+              </a:ext>
+            </a:extLst>
+          </p:cNvPr>
+          <p:cNvSpPr>
+            <a:spLocks noGrp="1"/>
+          </p:cNvSpPr>
+          <p:nvPr>
+            <p:ph type="sldNum" sz="quarter" idx="12"/>
+          </p:nvPr>
+        </p:nvSpPr>
+        <p:spPr/>
+        <p:txBody>
+          <a:bodyPr/>
+          <a:lstStyle/>
+          <a:p>
+            <a:fld id="{6C43980B-2C02-594B-9C73-A951FE425682}" type="slidenum">
+              <a:rPr lang="de-DE" smtClean="0"/>
+              <a:t>19</a:t>
+            </a:fld>
+            <a:endParaRPr lang="de-DE" dirty="0"/>
+          </a:p>
+        </p:txBody>
+      </p:sp>
     </p:spTree>
     <p:extLst>
       <p:ext uri="{BB962C8B-B14F-4D97-AF65-F5344CB8AC3E}">
@@ -18590,6 +19182,35 @@
           </a:prstGeom>
         </p:spPr>
       </p:pic>
+      <p:sp>
+        <p:nvSpPr>
+          <p:cNvPr id="4" name="Foliennummernplatzhalter 3">
+            <a:extLst>
+              <a:ext uri="{FF2B5EF4-FFF2-40B4-BE49-F238E27FC236}">
+                <a16:creationId xmlns:a16="http://schemas.microsoft.com/office/drawing/2014/main" id="{53405529-831B-213E-5F34-8F66C31A035B}"/>
+              </a:ext>
+            </a:extLst>
+          </p:cNvPr>
+          <p:cNvSpPr>
+            <a:spLocks noGrp="1"/>
+          </p:cNvSpPr>
+          <p:nvPr>
+            <p:ph type="sldNum" sz="quarter" idx="12"/>
+          </p:nvPr>
+        </p:nvSpPr>
+        <p:spPr/>
+        <p:txBody>
+          <a:bodyPr/>
+          <a:lstStyle/>
+          <a:p>
+            <a:fld id="{6C43980B-2C02-594B-9C73-A951FE425682}" type="slidenum">
+              <a:rPr lang="de-DE" smtClean="0"/>
+              <a:t>2</a:t>
+            </a:fld>
+            <a:endParaRPr lang="de-DE" dirty="0"/>
+          </a:p>
+        </p:txBody>
+      </p:sp>
     </p:spTree>
     <p:extLst>
       <p:ext uri="{BB962C8B-B14F-4D97-AF65-F5344CB8AC3E}">
@@ -18683,6 +19304,35 @@
           </a:prstGeom>
         </p:spPr>
       </p:pic>
+      <p:sp>
+        <p:nvSpPr>
+          <p:cNvPr id="4" name="Foliennummernplatzhalter 3">
+            <a:extLst>
+              <a:ext uri="{FF2B5EF4-FFF2-40B4-BE49-F238E27FC236}">
+                <a16:creationId xmlns:a16="http://schemas.microsoft.com/office/drawing/2014/main" id="{AD0DF6EF-19CE-71AE-3430-75A215A3AC09}"/>
+              </a:ext>
+            </a:extLst>
+          </p:cNvPr>
+          <p:cNvSpPr>
+            <a:spLocks noGrp="1"/>
+          </p:cNvSpPr>
+          <p:nvPr>
+            <p:ph type="sldNum" sz="quarter" idx="12"/>
+          </p:nvPr>
+        </p:nvSpPr>
+        <p:spPr/>
+        <p:txBody>
+          <a:bodyPr/>
+          <a:lstStyle/>
+          <a:p>
+            <a:fld id="{6C43980B-2C02-594B-9C73-A951FE425682}" type="slidenum">
+              <a:rPr lang="de-DE" smtClean="0"/>
+              <a:t>20</a:t>
+            </a:fld>
+            <a:endParaRPr lang="de-DE" dirty="0"/>
+          </a:p>
+        </p:txBody>
+      </p:sp>
     </p:spTree>
     <p:extLst>
       <p:ext uri="{BB962C8B-B14F-4D97-AF65-F5344CB8AC3E}">
@@ -20057,10 +20707,328 @@
           </a:graphicData>
         </a:graphic>
       </p:graphicFrame>
+      <p:sp>
+        <p:nvSpPr>
+          <p:cNvPr id="4" name="Foliennummernplatzhalter 3">
+            <a:extLst>
+              <a:ext uri="{FF2B5EF4-FFF2-40B4-BE49-F238E27FC236}">
+                <a16:creationId xmlns:a16="http://schemas.microsoft.com/office/drawing/2014/main" id="{EC12321B-1ABE-A1DE-E00A-8FC0BDB31597}"/>
+              </a:ext>
+            </a:extLst>
+          </p:cNvPr>
+          <p:cNvSpPr>
+            <a:spLocks noGrp="1"/>
+          </p:cNvSpPr>
+          <p:nvPr>
+            <p:ph type="sldNum" sz="quarter" idx="12"/>
+          </p:nvPr>
+        </p:nvSpPr>
+        <p:spPr/>
+        <p:txBody>
+          <a:bodyPr/>
+          <a:lstStyle/>
+          <a:p>
+            <a:fld id="{6C43980B-2C02-594B-9C73-A951FE425682}" type="slidenum">
+              <a:rPr lang="de-DE" smtClean="0"/>
+              <a:t>21</a:t>
+            </a:fld>
+            <a:endParaRPr lang="de-DE" dirty="0"/>
+          </a:p>
+        </p:txBody>
+      </p:sp>
     </p:spTree>
     <p:extLst>
       <p:ext uri="{BB962C8B-B14F-4D97-AF65-F5344CB8AC3E}">
         <p14:creationId xmlns:p14="http://schemas.microsoft.com/office/powerpoint/2010/main" val="2211268998"/>
+      </p:ext>
+    </p:extLst>
+  </p:cSld>
+  <p:clrMapOvr>
+    <a:masterClrMapping/>
+  </p:clrMapOvr>
+</p:sld>
+</file>
+
+<file path=ppt/slides/slide22.xml><?xml version="1.0" encoding="utf-8"?>
+<p:sld xmlns:a="http://schemas.openxmlformats.org/drawingml/2006/main" xmlns:r="http://schemas.openxmlformats.org/officeDocument/2006/relationships" xmlns:p="http://schemas.openxmlformats.org/presentationml/2006/main">
+  <p:cSld>
+    <p:spTree>
+      <p:nvGrpSpPr>
+        <p:cNvPr id="1" name=""/>
+        <p:cNvGrpSpPr/>
+        <p:nvPr/>
+      </p:nvGrpSpPr>
+      <p:grpSpPr>
+        <a:xfrm>
+          <a:off x="0" y="0"/>
+          <a:ext cx="0" cy="0"/>
+          <a:chOff x="0" y="0"/>
+          <a:chExt cx="0" cy="0"/>
+        </a:xfrm>
+      </p:grpSpPr>
+      <p:sp>
+        <p:nvSpPr>
+          <p:cNvPr id="2" name="Titel 1">
+            <a:extLst>
+              <a:ext uri="{FF2B5EF4-FFF2-40B4-BE49-F238E27FC236}">
+                <a16:creationId xmlns:a16="http://schemas.microsoft.com/office/drawing/2014/main" id="{32E31ECD-4C56-06C7-D350-99003145DB06}"/>
+              </a:ext>
+            </a:extLst>
+          </p:cNvPr>
+          <p:cNvSpPr>
+            <a:spLocks noGrp="1"/>
+          </p:cNvSpPr>
+          <p:nvPr>
+            <p:ph type="title"/>
+          </p:nvPr>
+        </p:nvSpPr>
+        <p:spPr/>
+        <p:txBody>
+          <a:bodyPr/>
+          <a:lstStyle/>
+          <a:p>
+            <a:r>
+              <a:rPr lang="de-DE" dirty="0"/>
+              <a:t>Literatur</a:t>
+            </a:r>
+          </a:p>
+        </p:txBody>
+      </p:sp>
+      <p:sp>
+        <p:nvSpPr>
+          <p:cNvPr id="3" name="Inhaltsplatzhalter 2">
+            <a:extLst>
+              <a:ext uri="{FF2B5EF4-FFF2-40B4-BE49-F238E27FC236}">
+                <a16:creationId xmlns:a16="http://schemas.microsoft.com/office/drawing/2014/main" id="{688FE007-6E0A-97B9-9737-2D8C83663ADA}"/>
+              </a:ext>
+            </a:extLst>
+          </p:cNvPr>
+          <p:cNvSpPr>
+            <a:spLocks noGrp="1"/>
+          </p:cNvSpPr>
+          <p:nvPr>
+            <p:ph idx="1"/>
+          </p:nvPr>
+        </p:nvSpPr>
+        <p:spPr/>
+        <p:txBody>
+          <a:bodyPr>
+            <a:normAutofit/>
+          </a:bodyPr>
+          <a:lstStyle/>
+          <a:p>
+            <a:r>
+              <a:rPr lang="de-DE" sz="1300" dirty="0"/>
+              <a:t>[1] G. Völkel, „Fraktale Geometrie: Julia Mengen”, Universität Ulm, 2007. </a:t>
+            </a:r>
+            <a:br>
+              <a:rPr lang="de-DE" sz="1300" dirty="0"/>
+            </a:br>
+            <a:r>
+              <a:rPr lang="de-DE" sz="1300" dirty="0">
+                <a:hlinkClick r:id="rId2"/>
+              </a:rPr>
+              <a:t>https://www.mathematik.uni-ulm.de/stochastik/lehre/ws06_07/seminar_fraktale/ausarbeitung_voelkel.pdf</a:t>
+            </a:r>
+            <a:r>
+              <a:rPr lang="de-DE" sz="1300" dirty="0"/>
+              <a:t> (Zugriff: 15.06.2026)</a:t>
+            </a:r>
+          </a:p>
+          <a:p>
+            <a:r>
+              <a:rPr lang="de-DE" sz="1300" dirty="0"/>
+              <a:t>[2] D. Datta, B. Datta und  H. S. Dutta, „Design and </a:t>
+            </a:r>
+            <a:r>
+              <a:rPr lang="de-DE" sz="1300" dirty="0" err="1"/>
+              <a:t>implementation</a:t>
+            </a:r>
+            <a:r>
+              <a:rPr lang="de-DE" sz="1300" dirty="0"/>
+              <a:t> </a:t>
+            </a:r>
+            <a:r>
+              <a:rPr lang="de-DE" sz="1300" dirty="0" err="1"/>
+              <a:t>of</a:t>
+            </a:r>
+            <a:r>
+              <a:rPr lang="de-DE" sz="1300" dirty="0"/>
+              <a:t> </a:t>
+            </a:r>
+            <a:r>
+              <a:rPr lang="de-DE" sz="1300" dirty="0" err="1"/>
+              <a:t>multibit</a:t>
+            </a:r>
+            <a:r>
+              <a:rPr lang="de-DE" sz="1300" dirty="0"/>
+              <a:t> LFSR on FPGA </a:t>
+            </a:r>
+            <a:r>
+              <a:rPr lang="de-DE" sz="1300" dirty="0" err="1"/>
+              <a:t>to</a:t>
+            </a:r>
+            <a:r>
+              <a:rPr lang="de-DE" sz="1300" dirty="0"/>
+              <a:t> </a:t>
+            </a:r>
+            <a:r>
+              <a:rPr lang="de-DE" sz="1300" dirty="0" err="1"/>
+              <a:t>generate</a:t>
+            </a:r>
+            <a:r>
+              <a:rPr lang="de-DE" sz="1300" dirty="0"/>
+              <a:t> </a:t>
+            </a:r>
+            <a:r>
+              <a:rPr lang="de-DE" sz="1300" dirty="0" err="1"/>
+              <a:t>pseudorandom</a:t>
+            </a:r>
+            <a:r>
+              <a:rPr lang="de-DE" sz="1300" dirty="0"/>
+              <a:t> </a:t>
+            </a:r>
+            <a:r>
+              <a:rPr lang="de-DE" sz="1300" dirty="0" err="1"/>
+              <a:t>sequence</a:t>
+            </a:r>
+            <a:r>
+              <a:rPr lang="de-DE" sz="1300" dirty="0"/>
+              <a:t> </a:t>
+            </a:r>
+            <a:r>
+              <a:rPr lang="de-DE" sz="1300" dirty="0" err="1"/>
+              <a:t>number</a:t>
+            </a:r>
+            <a:r>
+              <a:rPr lang="de-DE" sz="1300" dirty="0"/>
+              <a:t>”, 2017 Devices </a:t>
+            </a:r>
+            <a:r>
+              <a:rPr lang="de-DE" sz="1300" dirty="0" err="1"/>
+              <a:t>for</a:t>
+            </a:r>
+            <a:r>
+              <a:rPr lang="de-DE" sz="1300" dirty="0"/>
+              <a:t> Integrated Circuit (DevIC), Kalyani, India, pp. 346–349, 2017. </a:t>
+            </a:r>
+            <a:r>
+              <a:rPr lang="de-DE" sz="1300" dirty="0" err="1"/>
+              <a:t>doi</a:t>
+            </a:r>
+            <a:r>
+              <a:rPr lang="de-DE" sz="1300" dirty="0"/>
+              <a:t>: 10.1109/DEVIC.2017.8073966.</a:t>
+            </a:r>
+          </a:p>
+          <a:p>
+            <a:r>
+              <a:rPr lang="de-DE" sz="1300" dirty="0"/>
+              <a:t>[3] R. Merrick, </a:t>
+            </a:r>
+            <a:r>
+              <a:rPr lang="de-DE" sz="1300" i="1" dirty="0"/>
+              <a:t>Getting </a:t>
+            </a:r>
+            <a:r>
+              <a:rPr lang="de-DE" sz="1300" i="1" dirty="0" err="1"/>
+              <a:t>Started</a:t>
+            </a:r>
+            <a:r>
+              <a:rPr lang="de-DE" sz="1300" i="1" dirty="0"/>
+              <a:t> </a:t>
+            </a:r>
+            <a:r>
+              <a:rPr lang="de-DE" sz="1300" i="1" dirty="0" err="1"/>
+              <a:t>with</a:t>
+            </a:r>
+            <a:r>
+              <a:rPr lang="de-DE" sz="1300" i="1" dirty="0"/>
+              <a:t> FPGAs: Digital Circuit Design, </a:t>
+            </a:r>
+            <a:r>
+              <a:rPr lang="de-DE" sz="1300" i="1" dirty="0" err="1"/>
+              <a:t>Verilog</a:t>
+            </a:r>
+            <a:r>
+              <a:rPr lang="de-DE" sz="1300" i="1" dirty="0"/>
+              <a:t>, and VHDL </a:t>
+            </a:r>
+            <a:r>
+              <a:rPr lang="de-DE" sz="1300" i="1" dirty="0" err="1"/>
+              <a:t>for</a:t>
+            </a:r>
+            <a:r>
+              <a:rPr lang="de-DE" sz="1300" i="1" dirty="0"/>
+              <a:t> Beginners, </a:t>
+            </a:r>
+            <a:r>
+              <a:rPr lang="de-DE" sz="1300" i="1" dirty="0" err="1"/>
+              <a:t>No</a:t>
+            </a:r>
+            <a:r>
+              <a:rPr lang="de-DE" sz="1300" i="1" dirty="0"/>
+              <a:t> Starch Press, 2023.</a:t>
+            </a:r>
+          </a:p>
+          <a:p>
+            <a:r>
+              <a:rPr lang="de-DE" sz="1300" dirty="0"/>
+              <a:t>[4] Xilinx, „7 Series DSP48E1 Slice User Guide (UG 479)“, 2018. </a:t>
+            </a:r>
+            <a:br>
+              <a:rPr lang="de-DE" sz="1300" dirty="0"/>
+            </a:br>
+            <a:r>
+              <a:rPr lang="de-DE" sz="1300" dirty="0">
+                <a:hlinkClick r:id="rId3"/>
+              </a:rPr>
+              <a:t>https://docs.amd.com/v/u/en-US/ug479_7Series_DSP48E1</a:t>
+            </a:r>
+            <a:r>
+              <a:rPr lang="de-DE" sz="1300" dirty="0"/>
+              <a:t> (Zugriff: 15.06.2026)</a:t>
+            </a:r>
+            <a:endParaRPr lang="de-DE" sz="1300" b="1" dirty="0"/>
+          </a:p>
+          <a:p>
+            <a:endParaRPr lang="de-DE" sz="1300" dirty="0"/>
+          </a:p>
+        </p:txBody>
+      </p:sp>
+      <p:sp>
+        <p:nvSpPr>
+          <p:cNvPr id="4" name="Foliennummernplatzhalter 3">
+            <a:extLst>
+              <a:ext uri="{FF2B5EF4-FFF2-40B4-BE49-F238E27FC236}">
+                <a16:creationId xmlns:a16="http://schemas.microsoft.com/office/drawing/2014/main" id="{23AEC4AD-256C-75B3-7729-607793F94366}"/>
+              </a:ext>
+            </a:extLst>
+          </p:cNvPr>
+          <p:cNvSpPr>
+            <a:spLocks noGrp="1"/>
+          </p:cNvSpPr>
+          <p:nvPr>
+            <p:ph type="sldNum" sz="quarter" idx="12"/>
+          </p:nvPr>
+        </p:nvSpPr>
+        <p:spPr/>
+        <p:txBody>
+          <a:bodyPr/>
+          <a:lstStyle/>
+          <a:p>
+            <a:fld id="{6C43980B-2C02-594B-9C73-A951FE425682}" type="slidenum">
+              <a:rPr lang="de-DE" smtClean="0"/>
+              <a:t>22</a:t>
+            </a:fld>
+            <a:endParaRPr lang="de-DE" dirty="0"/>
+          </a:p>
+        </p:txBody>
+      </p:sp>
+    </p:spTree>
+    <p:extLst>
+      <p:ext uri="{BB962C8B-B14F-4D97-AF65-F5344CB8AC3E}">
+        <p14:creationId xmlns:p14="http://schemas.microsoft.com/office/powerpoint/2010/main" val="2810999719"/>
       </p:ext>
     </p:extLst>
   </p:cSld>
@@ -20150,6 +21118,35 @@
           </a:prstGeom>
         </p:spPr>
       </p:pic>
+      <p:sp>
+        <p:nvSpPr>
+          <p:cNvPr id="4" name="Foliennummernplatzhalter 3">
+            <a:extLst>
+              <a:ext uri="{FF2B5EF4-FFF2-40B4-BE49-F238E27FC236}">
+                <a16:creationId xmlns:a16="http://schemas.microsoft.com/office/drawing/2014/main" id="{24F440DB-B584-8D55-4A24-12ACE63DA1C0}"/>
+              </a:ext>
+            </a:extLst>
+          </p:cNvPr>
+          <p:cNvSpPr>
+            <a:spLocks noGrp="1"/>
+          </p:cNvSpPr>
+          <p:nvPr>
+            <p:ph type="sldNum" sz="quarter" idx="12"/>
+          </p:nvPr>
+        </p:nvSpPr>
+        <p:spPr/>
+        <p:txBody>
+          <a:bodyPr/>
+          <a:lstStyle/>
+          <a:p>
+            <a:fld id="{6C43980B-2C02-594B-9C73-A951FE425682}" type="slidenum">
+              <a:rPr lang="de-DE" smtClean="0"/>
+              <a:t>3</a:t>
+            </a:fld>
+            <a:endParaRPr lang="de-DE" dirty="0"/>
+          </a:p>
+        </p:txBody>
+      </p:sp>
     </p:spTree>
     <p:extLst>
       <p:ext uri="{BB962C8B-B14F-4D97-AF65-F5344CB8AC3E}">
@@ -20251,7 +21248,7 @@
                   <a:buNone/>
                 </a:pPr>
                 <a:r>
-                  <a:rPr lang="de-DE" sz="2100" b="0"/>
+                  <a:rPr lang="de-DE" sz="2100" b="0" dirty="0"/>
                   <a:t>Berechnung der Folge </a:t>
                 </a:r>
               </a:p>
@@ -20408,7 +21405,7 @@
                     </m:oMath>
                   </m:oMathPara>
                 </a14:m>
-                <a:endParaRPr lang="de-DE" sz="2100" b="0"/>
+                <a:endParaRPr lang="de-DE" sz="2100" b="0" dirty="0"/>
               </a:p>
               <a:p>
                 <a:pPr marL="0" indent="0">
@@ -20418,7 +21415,7 @@
                   <a:buNone/>
                 </a:pPr>
                 <a:r>
-                  <a:rPr lang="de-DE" sz="2100"/>
+                  <a:rPr lang="de-DE" sz="2100" dirty="0"/>
                   <a:t>bis zur Divergenz bei</a:t>
                 </a:r>
               </a:p>
@@ -20482,15 +21479,23 @@
                     </m:oMath>
                   </m:oMathPara>
                 </a14:m>
-                <a:endParaRPr lang="de-DE" sz="2100"/>
+                <a:endParaRPr lang="de-DE" sz="2100" dirty="0"/>
               </a:p>
               <a:p>
                 <a:pPr marL="0" indent="0">
                   <a:buNone/>
                 </a:pPr>
                 <a:r>
-                  <a:rPr lang="de-DE" sz="2100"/>
-                  <a:t>oder zur Konvergenz nach einer festgelegten maximalen Anzahl an Interationen </a:t>
+                  <a:rPr lang="de-DE" sz="2100" dirty="0"/>
+                  <a:t>oder zur Konvergenz nach einer festgelegten maximalen Anzahl an </a:t>
+                </a:r>
+                <a:r>
+                  <a:rPr lang="de-DE" sz="2100" dirty="0" err="1"/>
+                  <a:t>Interationen</a:t>
+                </a:r>
+                <a:r>
+                  <a:rPr lang="de-DE" sz="2100" dirty="0"/>
+                  <a:t> </a:t>
                 </a:r>
                 <a14:m>
                   <m:oMath xmlns:m="http://schemas.openxmlformats.org/officeDocument/2006/math">
@@ -20515,7 +21520,7 @@
                   </m:oMath>
                 </a14:m>
                 <a:r>
-                  <a:rPr lang="de-DE" sz="2100"/>
+                  <a:rPr lang="de-DE" sz="2100" dirty="0"/>
                   <a:t> für jeden Pixel des Bildes.</a:t>
                 </a:r>
               </a:p>
@@ -20618,6 +21623,68 @@
           </a:p>
         </p:txBody>
       </p:sp>
+      <p:sp>
+        <p:nvSpPr>
+          <p:cNvPr id="6" name="Foliennummernplatzhalter 5">
+            <a:extLst>
+              <a:ext uri="{FF2B5EF4-FFF2-40B4-BE49-F238E27FC236}">
+                <a16:creationId xmlns:a16="http://schemas.microsoft.com/office/drawing/2014/main" id="{54336AE1-15F2-B1B7-E359-6F5DC3539F9E}"/>
+              </a:ext>
+            </a:extLst>
+          </p:cNvPr>
+          <p:cNvSpPr>
+            <a:spLocks noGrp="1"/>
+          </p:cNvSpPr>
+          <p:nvPr>
+            <p:ph type="sldNum" sz="quarter" idx="12"/>
+          </p:nvPr>
+        </p:nvSpPr>
+        <p:spPr/>
+        <p:txBody>
+          <a:bodyPr/>
+          <a:lstStyle/>
+          <a:p>
+            <a:fld id="{6C43980B-2C02-594B-9C73-A951FE425682}" type="slidenum">
+              <a:rPr lang="de-DE" smtClean="0"/>
+              <a:t>4</a:t>
+            </a:fld>
+            <a:endParaRPr lang="de-DE" dirty="0"/>
+          </a:p>
+        </p:txBody>
+      </p:sp>
+      <p:sp>
+        <p:nvSpPr>
+          <p:cNvPr id="7" name="Fußzeilenplatzhalter 6">
+            <a:extLst>
+              <a:ext uri="{FF2B5EF4-FFF2-40B4-BE49-F238E27FC236}">
+                <a16:creationId xmlns:a16="http://schemas.microsoft.com/office/drawing/2014/main" id="{DED522EE-C212-A5D6-B2F4-B6A152D56B37}"/>
+              </a:ext>
+            </a:extLst>
+          </p:cNvPr>
+          <p:cNvSpPr>
+            <a:spLocks noGrp="1"/>
+          </p:cNvSpPr>
+          <p:nvPr>
+            <p:ph type="ftr" sz="quarter" idx="11"/>
+          </p:nvPr>
+        </p:nvSpPr>
+        <p:spPr>
+          <a:xfrm>
+            <a:off x="1288472" y="6492875"/>
+            <a:ext cx="9615055" cy="365125"/>
+          </a:xfrm>
+        </p:spPr>
+        <p:txBody>
+          <a:bodyPr/>
+          <a:lstStyle/>
+          <a:p>
+            <a:r>
+              <a:rPr lang="de-DE" dirty="0"/>
+              <a:t>[1]</a:t>
+            </a:r>
+          </a:p>
+        </p:txBody>
+      </p:sp>
     </p:spTree>
     <p:extLst>
       <p:ext uri="{BB962C8B-B14F-4D97-AF65-F5344CB8AC3E}">
@@ -20739,7 +21806,7 @@
           <p:nvPr/>
         </p:nvPicPr>
         <p:blipFill>
-          <a:blip r:embed="rId2"/>
+          <a:blip r:embed="rId3"/>
           <a:stretch>
             <a:fillRect/>
           </a:stretch>
@@ -21084,8 +22151,8 @@
           </a:p>
         </p:txBody>
       </p:sp>
-      <mc:AlternateContent xmlns:mc="http://schemas.openxmlformats.org/markup-compatibility/2006">
-        <mc:Choice xmlns:a14="http://schemas.microsoft.com/office/drawing/2010/main" Requires="a14">
+      <mc:AlternateContent xmlns:mc="http://schemas.openxmlformats.org/markup-compatibility/2006" xmlns:a14="http://schemas.microsoft.com/office/drawing/2010/main">
+        <mc:Choice Requires="a14">
           <p:sp>
             <p:nvSpPr>
               <p:cNvPr id="31" name="Textfeld 30">
@@ -21114,6 +22181,7 @@
               </a:bodyPr>
               <a:lstStyle/>
               <a:p>
+                <a:pPr/>
                 <a14:m>
                   <m:oMathPara xmlns:m="http://schemas.openxmlformats.org/officeDocument/2006/math">
                     <m:oMathParaPr>
@@ -21173,11 +22241,12 @@
                     </m:oMath>
                   </m:oMathPara>
                 </a14:m>
+                <a:endParaRPr/>
               </a:p>
             </p:txBody>
           </p:sp>
         </mc:Choice>
-        <mc:Fallback>
+        <mc:Fallback xmlns="">
           <p:sp>
             <p:nvSpPr>
               <p:cNvPr id="31" name="Textfeld 30">
@@ -21201,7 +22270,7 @@
                 <a:avLst/>
               </a:prstGeom>
               <a:blipFill>
-                <a:blip r:embed="rId3"/>
+                <a:blip r:embed="rId4"/>
                 <a:stretch>
                   <a:fillRect t="-8824" r="-3797" b="-26471"/>
                 </a:stretch>
@@ -21222,8 +22291,8 @@
           </p:sp>
         </mc:Fallback>
       </mc:AlternateContent>
-      <mc:AlternateContent xmlns:mc="http://schemas.openxmlformats.org/markup-compatibility/2006">
-        <mc:Choice xmlns:a14="http://schemas.microsoft.com/office/drawing/2010/main" Requires="a14">
+      <mc:AlternateContent xmlns:mc="http://schemas.openxmlformats.org/markup-compatibility/2006" xmlns:a14="http://schemas.microsoft.com/office/drawing/2010/main">
+        <mc:Choice Requires="a14">
           <p:sp>
             <p:nvSpPr>
               <p:cNvPr id="32" name="Textfeld 31">
@@ -21252,6 +22321,7 @@
               </a:bodyPr>
               <a:lstStyle/>
               <a:p>
+                <a:pPr/>
                 <a14:m>
                   <m:oMathPara xmlns:m="http://schemas.openxmlformats.org/officeDocument/2006/math">
                     <m:oMathParaPr>
@@ -21298,7 +22368,7 @@
                             <a:rPr lang="de-DE" sz="2100" b="0" i="1" dirty="0" smtClean="0">
                               <a:latin typeface="Cambria Math" panose="02040503050406030204" pitchFamily="18" charset="0"/>
                             </a:rPr>
-                            <m:t>-239</m:t>
+                            <m:t>−239</m:t>
                           </m:r>
                           <m:r>
                             <m:rPr>
@@ -21314,11 +22384,12 @@
                     </m:oMath>
                   </m:oMathPara>
                 </a14:m>
+                <a:endParaRPr/>
               </a:p>
             </p:txBody>
           </p:sp>
         </mc:Choice>
-        <mc:Fallback>
+        <mc:Fallback xmlns="">
           <p:sp>
             <p:nvSpPr>
               <p:cNvPr id="32" name="Textfeld 31">
@@ -21342,7 +22413,7 @@
                 <a:avLst/>
               </a:prstGeom>
               <a:blipFill>
-                <a:blip r:embed="rId4"/>
+                <a:blip r:embed="rId5"/>
                 <a:stretch>
                   <a:fillRect t="-9091" r="-4878" b="-30303"/>
                 </a:stretch>
@@ -21363,8 +22434,8 @@
           </p:sp>
         </mc:Fallback>
       </mc:AlternateContent>
-      <mc:AlternateContent xmlns:mc="http://schemas.openxmlformats.org/markup-compatibility/2006">
-        <mc:Choice xmlns:a14="http://schemas.microsoft.com/office/drawing/2010/main" Requires="a14">
+      <mc:AlternateContent xmlns:mc="http://schemas.openxmlformats.org/markup-compatibility/2006" xmlns:a14="http://schemas.microsoft.com/office/drawing/2010/main">
+        <mc:Choice Requires="a14">
           <p:sp>
             <p:nvSpPr>
               <p:cNvPr id="33" name="Textfeld 32">
@@ -21393,6 +22464,7 @@
               </a:bodyPr>
               <a:lstStyle/>
               <a:p>
+                <a:pPr/>
                 <a14:m>
                   <m:oMathPara xmlns:m="http://schemas.openxmlformats.org/officeDocument/2006/math">
                     <m:oMathParaPr>
@@ -21439,7 +22511,7 @@
                             <a:rPr lang="de-DE" sz="2100" b="0" i="1" dirty="0" smtClean="0">
                               <a:latin typeface="Cambria Math" panose="02040503050406030204" pitchFamily="18" charset="0"/>
                             </a:rPr>
-                            <m:t>-239</m:t>
+                            <m:t>−239</m:t>
                           </m:r>
                           <m:r>
                             <m:rPr>
@@ -21455,11 +22527,12 @@
                     </m:oMath>
                   </m:oMathPara>
                 </a14:m>
+                <a:endParaRPr/>
               </a:p>
             </p:txBody>
           </p:sp>
         </mc:Choice>
-        <mc:Fallback>
+        <mc:Fallback xmlns="">
           <p:sp>
             <p:nvSpPr>
               <p:cNvPr id="33" name="Textfeld 32">
@@ -21483,7 +22556,7 @@
                 <a:avLst/>
               </a:prstGeom>
               <a:blipFill>
-                <a:blip r:embed="rId5"/>
+                <a:blip r:embed="rId6"/>
                 <a:stretch>
                   <a:fillRect t="-9091" r="-4667" b="-30303"/>
                 </a:stretch>
@@ -21504,8 +22577,8 @@
           </p:sp>
         </mc:Fallback>
       </mc:AlternateContent>
-      <mc:AlternateContent xmlns:mc="http://schemas.openxmlformats.org/markup-compatibility/2006">
-        <mc:Choice xmlns:a14="http://schemas.microsoft.com/office/drawing/2010/main" Requires="a14">
+      <mc:AlternateContent xmlns:mc="http://schemas.openxmlformats.org/markup-compatibility/2006" xmlns:a14="http://schemas.microsoft.com/office/drawing/2010/main">
+        <mc:Choice Requires="a14">
           <p:sp>
             <p:nvSpPr>
               <p:cNvPr id="34" name="Textfeld 33">
@@ -21534,6 +22607,7 @@
               </a:bodyPr>
               <a:lstStyle/>
               <a:p>
+                <a:pPr/>
                 <a14:m>
                   <m:oMathPara xmlns:m="http://schemas.openxmlformats.org/officeDocument/2006/math">
                     <m:oMathParaPr>
@@ -21599,11 +22673,12 @@
                     </m:oMath>
                   </m:oMathPara>
                 </a14:m>
+                <a:endParaRPr/>
               </a:p>
             </p:txBody>
           </p:sp>
         </mc:Choice>
-        <mc:Fallback>
+        <mc:Fallback xmlns="">
           <p:sp>
             <p:nvSpPr>
               <p:cNvPr id="34" name="Textfeld 33">
@@ -21627,7 +22702,7 @@
                 <a:avLst/>
               </a:prstGeom>
               <a:blipFill>
-                <a:blip r:embed="rId6"/>
+                <a:blip r:embed="rId7"/>
                 <a:stretch>
                   <a:fillRect t="-9091" r="-4930" b="-30303"/>
                 </a:stretch>
@@ -21861,6 +22936,68 @@
           <a:p>
             <a:pPr algn="ctr"/>
             <a:endParaRPr lang="de-DE"/>
+          </a:p>
+        </p:txBody>
+      </p:sp>
+      <p:sp>
+        <p:nvSpPr>
+          <p:cNvPr id="6" name="Foliennummernplatzhalter 5">
+            <a:extLst>
+              <a:ext uri="{FF2B5EF4-FFF2-40B4-BE49-F238E27FC236}">
+                <a16:creationId xmlns:a16="http://schemas.microsoft.com/office/drawing/2014/main" id="{09BA9DA3-E009-A754-7CF1-19D93A5DB4CC}"/>
+              </a:ext>
+            </a:extLst>
+          </p:cNvPr>
+          <p:cNvSpPr>
+            <a:spLocks noGrp="1"/>
+          </p:cNvSpPr>
+          <p:nvPr>
+            <p:ph type="sldNum" sz="quarter" idx="12"/>
+          </p:nvPr>
+        </p:nvSpPr>
+        <p:spPr/>
+        <p:txBody>
+          <a:bodyPr/>
+          <a:lstStyle/>
+          <a:p>
+            <a:fld id="{6C43980B-2C02-594B-9C73-A951FE425682}" type="slidenum">
+              <a:rPr lang="de-DE" smtClean="0"/>
+              <a:t>5</a:t>
+            </a:fld>
+            <a:endParaRPr lang="de-DE" dirty="0"/>
+          </a:p>
+        </p:txBody>
+      </p:sp>
+      <p:sp>
+        <p:nvSpPr>
+          <p:cNvPr id="9" name="Fußzeilenplatzhalter 6">
+            <a:extLst>
+              <a:ext uri="{FF2B5EF4-FFF2-40B4-BE49-F238E27FC236}">
+                <a16:creationId xmlns:a16="http://schemas.microsoft.com/office/drawing/2014/main" id="{417384DA-4E77-8137-5AF8-BA3C2327E117}"/>
+              </a:ext>
+            </a:extLst>
+          </p:cNvPr>
+          <p:cNvSpPr>
+            <a:spLocks noGrp="1"/>
+          </p:cNvSpPr>
+          <p:nvPr>
+            <p:ph type="ftr" sz="quarter" idx="11"/>
+          </p:nvPr>
+        </p:nvSpPr>
+        <p:spPr>
+          <a:xfrm>
+            <a:off x="1288472" y="6492875"/>
+            <a:ext cx="9615055" cy="365125"/>
+          </a:xfrm>
+        </p:spPr>
+        <p:txBody>
+          <a:bodyPr/>
+          <a:lstStyle/>
+          <a:p>
+            <a:r>
+              <a:rPr lang="de-DE" dirty="0"/>
+              <a:t>[1]</a:t>
+            </a:r>
           </a:p>
         </p:txBody>
       </p:sp>
@@ -22121,7 +23258,7 @@
                 <a:ext cx="10515600" cy="517525"/>
               </a:xfrm>
               <a:blipFill>
-                <a:blip r:embed="rId2"/>
+                <a:blip r:embed="rId3"/>
                 <a:stretch>
                   <a:fillRect l="-724" t="-11905"/>
                 </a:stretch>
@@ -22157,7 +23294,7 @@
           <p:nvPr/>
         </p:nvPicPr>
         <p:blipFill>
-          <a:blip r:embed="rId3"/>
+          <a:blip r:embed="rId4"/>
           <a:stretch>
             <a:fillRect/>
           </a:stretch>
@@ -22172,6 +23309,68 @@
           </a:prstGeom>
         </p:spPr>
       </p:pic>
+      <p:sp>
+        <p:nvSpPr>
+          <p:cNvPr id="6" name="Foliennummernplatzhalter 5">
+            <a:extLst>
+              <a:ext uri="{FF2B5EF4-FFF2-40B4-BE49-F238E27FC236}">
+                <a16:creationId xmlns:a16="http://schemas.microsoft.com/office/drawing/2014/main" id="{A4F7225F-1D51-734E-83AB-308DF4B73372}"/>
+              </a:ext>
+            </a:extLst>
+          </p:cNvPr>
+          <p:cNvSpPr>
+            <a:spLocks noGrp="1"/>
+          </p:cNvSpPr>
+          <p:nvPr>
+            <p:ph type="sldNum" sz="quarter" idx="12"/>
+          </p:nvPr>
+        </p:nvSpPr>
+        <p:spPr/>
+        <p:txBody>
+          <a:bodyPr/>
+          <a:lstStyle/>
+          <a:p>
+            <a:fld id="{6C43980B-2C02-594B-9C73-A951FE425682}" type="slidenum">
+              <a:rPr lang="de-DE" smtClean="0"/>
+              <a:t>6</a:t>
+            </a:fld>
+            <a:endParaRPr lang="de-DE" dirty="0"/>
+          </a:p>
+        </p:txBody>
+      </p:sp>
+      <p:sp>
+        <p:nvSpPr>
+          <p:cNvPr id="8" name="Fußzeilenplatzhalter 6">
+            <a:extLst>
+              <a:ext uri="{FF2B5EF4-FFF2-40B4-BE49-F238E27FC236}">
+                <a16:creationId xmlns:a16="http://schemas.microsoft.com/office/drawing/2014/main" id="{1680BF89-DB0D-F9D2-4646-941D50CA3F02}"/>
+              </a:ext>
+            </a:extLst>
+          </p:cNvPr>
+          <p:cNvSpPr>
+            <a:spLocks noGrp="1"/>
+          </p:cNvSpPr>
+          <p:nvPr>
+            <p:ph type="ftr" sz="quarter" idx="11"/>
+          </p:nvPr>
+        </p:nvSpPr>
+        <p:spPr>
+          <a:xfrm>
+            <a:off x="1288472" y="6492875"/>
+            <a:ext cx="9615055" cy="365125"/>
+          </a:xfrm>
+        </p:spPr>
+        <p:txBody>
+          <a:bodyPr/>
+          <a:lstStyle/>
+          <a:p>
+            <a:r>
+              <a:rPr lang="de-DE" dirty="0"/>
+              <a:t>[1]</a:t>
+            </a:r>
+          </a:p>
+        </p:txBody>
+      </p:sp>
     </p:spTree>
     <p:extLst>
       <p:ext uri="{BB962C8B-B14F-4D97-AF65-F5344CB8AC3E}">
@@ -22823,6 +24022,35 @@
           </a:p>
         </p:txBody>
       </p:sp>
+      <p:sp>
+        <p:nvSpPr>
+          <p:cNvPr id="5" name="Foliennummernplatzhalter 4">
+            <a:extLst>
+              <a:ext uri="{FF2B5EF4-FFF2-40B4-BE49-F238E27FC236}">
+                <a16:creationId xmlns:a16="http://schemas.microsoft.com/office/drawing/2014/main" id="{576D5CC3-FBC3-6A76-C3B9-FF39C0A116CD}"/>
+              </a:ext>
+            </a:extLst>
+          </p:cNvPr>
+          <p:cNvSpPr>
+            <a:spLocks noGrp="1"/>
+          </p:cNvSpPr>
+          <p:nvPr>
+            <p:ph type="sldNum" sz="quarter" idx="12"/>
+          </p:nvPr>
+        </p:nvSpPr>
+        <p:spPr/>
+        <p:txBody>
+          <a:bodyPr/>
+          <a:lstStyle/>
+          <a:p>
+            <a:fld id="{6C43980B-2C02-594B-9C73-A951FE425682}" type="slidenum">
+              <a:rPr lang="de-DE" smtClean="0"/>
+              <a:t>7</a:t>
+            </a:fld>
+            <a:endParaRPr lang="de-DE" dirty="0"/>
+          </a:p>
+        </p:txBody>
+      </p:sp>
     </p:spTree>
     <p:extLst>
       <p:ext uri="{BB962C8B-B14F-4D97-AF65-F5344CB8AC3E}">
@@ -22963,6 +24191,68 @@
           </a:p>
         </p:txBody>
       </p:sp>
+      <p:sp>
+        <p:nvSpPr>
+          <p:cNvPr id="4" name="Foliennummernplatzhalter 3">
+            <a:extLst>
+              <a:ext uri="{FF2B5EF4-FFF2-40B4-BE49-F238E27FC236}">
+                <a16:creationId xmlns:a16="http://schemas.microsoft.com/office/drawing/2014/main" id="{8710381E-4804-9267-DF98-63C737484387}"/>
+              </a:ext>
+            </a:extLst>
+          </p:cNvPr>
+          <p:cNvSpPr>
+            <a:spLocks noGrp="1"/>
+          </p:cNvSpPr>
+          <p:nvPr>
+            <p:ph type="sldNum" sz="quarter" idx="12"/>
+          </p:nvPr>
+        </p:nvSpPr>
+        <p:spPr/>
+        <p:txBody>
+          <a:bodyPr/>
+          <a:lstStyle/>
+          <a:p>
+            <a:fld id="{6C43980B-2C02-594B-9C73-A951FE425682}" type="slidenum">
+              <a:rPr lang="de-DE" smtClean="0"/>
+              <a:t>8</a:t>
+            </a:fld>
+            <a:endParaRPr lang="de-DE" dirty="0"/>
+          </a:p>
+        </p:txBody>
+      </p:sp>
+      <p:sp>
+        <p:nvSpPr>
+          <p:cNvPr id="7" name="Fußzeilenplatzhalter 6">
+            <a:extLst>
+              <a:ext uri="{FF2B5EF4-FFF2-40B4-BE49-F238E27FC236}">
+                <a16:creationId xmlns:a16="http://schemas.microsoft.com/office/drawing/2014/main" id="{E07B1DAA-10B2-561E-81AB-D770E31D8A41}"/>
+              </a:ext>
+            </a:extLst>
+          </p:cNvPr>
+          <p:cNvSpPr>
+            <a:spLocks noGrp="1"/>
+          </p:cNvSpPr>
+          <p:nvPr>
+            <p:ph type="ftr" sz="quarter" idx="11"/>
+          </p:nvPr>
+        </p:nvSpPr>
+        <p:spPr>
+          <a:xfrm>
+            <a:off x="0" y="6481039"/>
+            <a:ext cx="11099800" cy="365125"/>
+          </a:xfrm>
+        </p:spPr>
+        <p:txBody>
+          <a:bodyPr/>
+          <a:lstStyle/>
+          <a:p>
+            <a:r>
+              <a:rPr lang="de-DE" i="1" dirty="0"/>
+              <a:t>[2], [3]</a:t>
+            </a:r>
+          </a:p>
+        </p:txBody>
+      </p:sp>
     </p:spTree>
     <p:extLst>
       <p:ext uri="{BB962C8B-B14F-4D97-AF65-F5344CB8AC3E}">
@@ -23056,6 +24346,35 @@
           </a:prstGeom>
         </p:spPr>
       </p:pic>
+      <p:sp>
+        <p:nvSpPr>
+          <p:cNvPr id="4" name="Foliennummernplatzhalter 3">
+            <a:extLst>
+              <a:ext uri="{FF2B5EF4-FFF2-40B4-BE49-F238E27FC236}">
+                <a16:creationId xmlns:a16="http://schemas.microsoft.com/office/drawing/2014/main" id="{496E271D-3E3B-339F-A697-A8CE1316ADC8}"/>
+              </a:ext>
+            </a:extLst>
+          </p:cNvPr>
+          <p:cNvSpPr>
+            <a:spLocks noGrp="1"/>
+          </p:cNvSpPr>
+          <p:nvPr>
+            <p:ph type="sldNum" sz="quarter" idx="12"/>
+          </p:nvPr>
+        </p:nvSpPr>
+        <p:spPr/>
+        <p:txBody>
+          <a:bodyPr/>
+          <a:lstStyle/>
+          <a:p>
+            <a:fld id="{6C43980B-2C02-594B-9C73-A951FE425682}" type="slidenum">
+              <a:rPr lang="de-DE" smtClean="0"/>
+              <a:t>9</a:t>
+            </a:fld>
+            <a:endParaRPr lang="de-DE" dirty="0"/>
+          </a:p>
+        </p:txBody>
+      </p:sp>
     </p:spTree>
     <p:extLst>
       <p:ext uri="{BB962C8B-B14F-4D97-AF65-F5344CB8AC3E}">

</xml_diff>

<commit_message>
added thomas part on presentation
</commit_message>
<xml_diff>
--- a/docs/Endpraesentation/DAPI_FractalCore_Endpraesentation.pptx
+++ b/docs/Endpraesentation/DAPI_FractalCore_Endpraesentation.pptx
@@ -5,7 +5,7 @@
     <p:sldMasterId id="2147483648" r:id="rId1"/>
   </p:sldMasterIdLst>
   <p:notesMasterIdLst>
-    <p:notesMasterId r:id="rId29"/>
+    <p:notesMasterId r:id="rId30"/>
   </p:notesMasterIdLst>
   <p:sldIdLst>
     <p:sldId id="256" r:id="rId2"/>
@@ -19,22 +19,23 @@
     <p:sldId id="266" r:id="rId10"/>
     <p:sldId id="277" r:id="rId11"/>
     <p:sldId id="274" r:id="rId12"/>
-    <p:sldId id="278" r:id="rId13"/>
-    <p:sldId id="279" r:id="rId14"/>
-    <p:sldId id="281" r:id="rId15"/>
-    <p:sldId id="286" r:id="rId16"/>
-    <p:sldId id="285" r:id="rId17"/>
-    <p:sldId id="280" r:id="rId18"/>
-    <p:sldId id="282" r:id="rId19"/>
-    <p:sldId id="270" r:id="rId20"/>
-    <p:sldId id="268" r:id="rId21"/>
-    <p:sldId id="283" r:id="rId22"/>
-    <p:sldId id="257" r:id="rId23"/>
-    <p:sldId id="271" r:id="rId24"/>
-    <p:sldId id="265" r:id="rId25"/>
-    <p:sldId id="258" r:id="rId26"/>
-    <p:sldId id="284" r:id="rId27"/>
-    <p:sldId id="273" r:id="rId28"/>
+    <p:sldId id="287" r:id="rId13"/>
+    <p:sldId id="278" r:id="rId14"/>
+    <p:sldId id="279" r:id="rId15"/>
+    <p:sldId id="281" r:id="rId16"/>
+    <p:sldId id="286" r:id="rId17"/>
+    <p:sldId id="285" r:id="rId18"/>
+    <p:sldId id="280" r:id="rId19"/>
+    <p:sldId id="282" r:id="rId20"/>
+    <p:sldId id="270" r:id="rId21"/>
+    <p:sldId id="268" r:id="rId22"/>
+    <p:sldId id="283" r:id="rId23"/>
+    <p:sldId id="257" r:id="rId24"/>
+    <p:sldId id="271" r:id="rId25"/>
+    <p:sldId id="265" r:id="rId26"/>
+    <p:sldId id="258" r:id="rId27"/>
+    <p:sldId id="284" r:id="rId28"/>
+    <p:sldId id="273" r:id="rId29"/>
   </p:sldIdLst>
   <p:sldSz cx="12192000" cy="6858000"/>
   <p:notesSz cx="6858000" cy="9144000"/>
@@ -141,6 +142,16 @@
 </p:presentation>
 </file>
 
+<file path=ppt/revisionInfo.xml><?xml version="1.0" encoding="utf-8"?>
+<p1510:revInfo xmlns:a="http://schemas.openxmlformats.org/drawingml/2006/main" xmlns:r="http://schemas.openxmlformats.org/officeDocument/2006/relationships" xmlns:p1510="http://schemas.microsoft.com/office/powerpoint/2015/10/main">
+  <p1510:revLst>
+    <p1510:client id="{87E8D9EF-151D-C0AF-FD62-01ED04B54185}" v="290" dt="2026-06-23T16:04:39.193"/>
+    <p1510:client id="{AD8E74BE-A737-2340-F74B-D225C784332A}" v="239" dt="2026-06-22T18:50:55.720"/>
+    <p1510:client id="{DD2898B8-EB7D-7DD6-7886-E401E840CD2F}" v="39" dt="2026-06-22T18:21:20.701"/>
+  </p1510:revLst>
+</p1510:revInfo>
+</file>
+
 <file path=ppt/notesMasters/notesMaster1.xml><?xml version="1.0" encoding="utf-8"?>
 <p:notesMaster xmlns:a="http://schemas.openxmlformats.org/drawingml/2006/main" xmlns:r="http://schemas.openxmlformats.org/officeDocument/2006/relationships" xmlns:p="http://schemas.openxmlformats.org/presentationml/2006/main">
   <p:cSld>
@@ -223,7 +234,7 @@
           <a:p>
             <a:fld id="{25690DA4-8E7E-0941-AA18-ABC55D37EF0E}" type="datetimeFigureOut">
               <a:rPr lang="de-DE" smtClean="0"/>
-              <a:t>19.06.26</a:t>
+              <a:t>23.06.2026</a:t>
             </a:fld>
             <a:endParaRPr lang="de-DE"/>
           </a:p>
@@ -381,7 +392,7 @@
           <a:p>
             <a:fld id="{BA036D80-E674-C74A-9C41-C7D9BE4A5ABE}" type="slidenum">
               <a:rPr lang="de-DE" smtClean="0"/>
-              <a:t>‹Nr.›</a:t>
+              <a:t>‹#›</a:t>
             </a:fld>
             <a:endParaRPr lang="de-DE"/>
           </a:p>
@@ -777,7 +788,7 @@
           <a:p>
             <a:fld id="{BA036D80-E674-C74A-9C41-C7D9BE4A5ABE}" type="slidenum">
               <a:rPr lang="de-DE" smtClean="0"/>
-              <a:t>12</a:t>
+              <a:t>13</a:t>
             </a:fld>
             <a:endParaRPr lang="de-DE"/>
           </a:p>
@@ -888,7 +899,7 @@
           <a:p>
             <a:fld id="{BA036D80-E674-C74A-9C41-C7D9BE4A5ABE}" type="slidenum">
               <a:rPr lang="de-DE" smtClean="0"/>
-              <a:t>15</a:t>
+              <a:t>16</a:t>
             </a:fld>
             <a:endParaRPr lang="de-DE"/>
           </a:p>
@@ -999,7 +1010,7 @@
           <a:p>
             <a:fld id="{BA036D80-E674-C74A-9C41-C7D9BE4A5ABE}" type="slidenum">
               <a:rPr lang="de-DE" smtClean="0"/>
-              <a:t>17</a:t>
+              <a:t>18</a:t>
             </a:fld>
             <a:endParaRPr lang="de-DE"/>
           </a:p>
@@ -1110,7 +1121,7 @@
           <a:p>
             <a:fld id="{BA036D80-E674-C74A-9C41-C7D9BE4A5ABE}" type="slidenum">
               <a:rPr lang="de-DE" smtClean="0"/>
-              <a:t>18</a:t>
+              <a:t>19</a:t>
             </a:fld>
             <a:endParaRPr lang="de-DE"/>
           </a:p>
@@ -1204,7 +1215,7 @@
           <a:p>
             <a:fld id="{BA036D80-E674-C74A-9C41-C7D9BE4A5ABE}" type="slidenum">
               <a:rPr lang="de-DE" smtClean="0"/>
-              <a:t>20</a:t>
+              <a:t>21</a:t>
             </a:fld>
             <a:endParaRPr lang="de-DE"/>
           </a:p>
@@ -1315,7 +1326,7 @@
           <a:p>
             <a:fld id="{BA036D80-E674-C74A-9C41-C7D9BE4A5ABE}" type="slidenum">
               <a:rPr lang="de-DE" smtClean="0"/>
-              <a:t>21</a:t>
+              <a:t>22</a:t>
             </a:fld>
             <a:endParaRPr lang="de-DE"/>
           </a:p>
@@ -1399,7 +1410,7 @@
           <a:p>
             <a:fld id="{BA036D80-E674-C74A-9C41-C7D9BE4A5ABE}" type="slidenum">
               <a:rPr lang="de-DE" smtClean="0"/>
-              <a:t>24</a:t>
+              <a:t>25</a:t>
             </a:fld>
             <a:endParaRPr lang="de-DE"/>
           </a:p>
@@ -1510,7 +1521,7 @@
           <a:p>
             <a:fld id="{BA036D80-E674-C74A-9C41-C7D9BE4A5ABE}" type="slidenum">
               <a:rPr lang="de-DE" smtClean="0"/>
-              <a:t>26</a:t>
+              <a:t>27</a:t>
             </a:fld>
             <a:endParaRPr lang="de-DE"/>
           </a:p>
@@ -2435,7 +2446,7 @@
           <a:p>
             <a:fld id="{E6DFA5A1-A813-7B43-85D4-C153DE6EEC5D}" type="datetime1">
               <a:rPr lang="de-DE" smtClean="0"/>
-              <a:t>19.06.26</a:t>
+              <a:t>23.06.2026</a:t>
             </a:fld>
             <a:endParaRPr lang="de-DE"/>
           </a:p>
@@ -2489,7 +2500,7 @@
           <a:p>
             <a:fld id="{6C43980B-2C02-594B-9C73-A951FE425682}" type="slidenum">
               <a:rPr lang="de-DE" smtClean="0"/>
-              <a:t>‹Nr.›</a:t>
+              <a:t>‹#›</a:t>
             </a:fld>
             <a:endParaRPr lang="de-DE"/>
           </a:p>
@@ -2633,7 +2644,7 @@
           <a:p>
             <a:fld id="{85A7F633-92B1-A640-B682-55DDF7097609}" type="datetime1">
               <a:rPr lang="de-DE" smtClean="0"/>
-              <a:t>19.06.26</a:t>
+              <a:t>23.06.2026</a:t>
             </a:fld>
             <a:endParaRPr lang="de-DE"/>
           </a:p>
@@ -2687,7 +2698,7 @@
           <a:p>
             <a:fld id="{6C43980B-2C02-594B-9C73-A951FE425682}" type="slidenum">
               <a:rPr lang="de-DE" smtClean="0"/>
-              <a:t>‹Nr.›</a:t>
+              <a:t>‹#›</a:t>
             </a:fld>
             <a:endParaRPr lang="de-DE"/>
           </a:p>
@@ -2841,7 +2852,7 @@
           <a:p>
             <a:fld id="{6B0DB9B7-7C2A-CA43-A176-0C82CB77F997}" type="datetime1">
               <a:rPr lang="de-DE" smtClean="0"/>
-              <a:t>19.06.26</a:t>
+              <a:t>23.06.2026</a:t>
             </a:fld>
             <a:endParaRPr lang="de-DE"/>
           </a:p>
@@ -2895,7 +2906,7 @@
           <a:p>
             <a:fld id="{6C43980B-2C02-594B-9C73-A951FE425682}" type="slidenum">
               <a:rPr lang="de-DE" smtClean="0"/>
-              <a:t>‹Nr.›</a:t>
+              <a:t>‹#›</a:t>
             </a:fld>
             <a:endParaRPr lang="de-DE"/>
           </a:p>
@@ -3044,7 +3055,7 @@
           <a:p>
             <a:fld id="{04634442-C186-E94E-B304-D4E0857BF857}" type="datetime1">
               <a:rPr lang="de-DE" smtClean="0"/>
-              <a:t>19.06.26</a:t>
+              <a:t>23.06.2026</a:t>
             </a:fld>
             <a:endParaRPr lang="de-DE"/>
           </a:p>
@@ -3108,7 +3119,7 @@
           <a:p>
             <a:fld id="{6C43980B-2C02-594B-9C73-A951FE425682}" type="slidenum">
               <a:rPr lang="de-DE" smtClean="0"/>
-              <a:t>‹Nr.›</a:t>
+              <a:t>‹#›</a:t>
             </a:fld>
             <a:endParaRPr lang="de-DE" dirty="0"/>
           </a:p>
@@ -3329,7 +3340,7 @@
           <a:p>
             <a:fld id="{3ACE65F1-39AD-D942-81CC-A8B185C49E41}" type="datetime1">
               <a:rPr lang="de-DE" smtClean="0"/>
-              <a:t>19.06.26</a:t>
+              <a:t>23.06.2026</a:t>
             </a:fld>
             <a:endParaRPr lang="de-DE"/>
           </a:p>
@@ -3383,7 +3394,7 @@
           <a:p>
             <a:fld id="{6C43980B-2C02-594B-9C73-A951FE425682}" type="slidenum">
               <a:rPr lang="de-DE" smtClean="0"/>
-              <a:t>‹Nr.›</a:t>
+              <a:t>‹#›</a:t>
             </a:fld>
             <a:endParaRPr lang="de-DE"/>
           </a:p>
@@ -3594,7 +3605,7 @@
           <a:p>
             <a:fld id="{15B311CB-D684-6D4F-A48A-21B70AE7BE5E}" type="datetime1">
               <a:rPr lang="de-DE" smtClean="0"/>
-              <a:t>19.06.26</a:t>
+              <a:t>23.06.2026</a:t>
             </a:fld>
             <a:endParaRPr lang="de-DE"/>
           </a:p>
@@ -3648,7 +3659,7 @@
           <a:p>
             <a:fld id="{6C43980B-2C02-594B-9C73-A951FE425682}" type="slidenum">
               <a:rPr lang="de-DE" smtClean="0"/>
-              <a:t>‹Nr.›</a:t>
+              <a:t>‹#›</a:t>
             </a:fld>
             <a:endParaRPr lang="de-DE"/>
           </a:p>
@@ -4006,7 +4017,7 @@
           <a:p>
             <a:fld id="{1F54E48E-21DA-704B-B06E-619E9794DDDC}" type="datetime1">
               <a:rPr lang="de-DE" smtClean="0"/>
-              <a:t>19.06.26</a:t>
+              <a:t>23.06.2026</a:t>
             </a:fld>
             <a:endParaRPr lang="de-DE"/>
           </a:p>
@@ -4060,7 +4071,7 @@
           <a:p>
             <a:fld id="{6C43980B-2C02-594B-9C73-A951FE425682}" type="slidenum">
               <a:rPr lang="de-DE" smtClean="0"/>
-              <a:t>‹Nr.›</a:t>
+              <a:t>‹#›</a:t>
             </a:fld>
             <a:endParaRPr lang="de-DE"/>
           </a:p>
@@ -4147,7 +4158,7 @@
           <a:p>
             <a:fld id="{4DB5E8C2-ED39-FA4A-892C-5D69F297ACBF}" type="datetime1">
               <a:rPr lang="de-DE" smtClean="0"/>
-              <a:t>19.06.26</a:t>
+              <a:t>23.06.2026</a:t>
             </a:fld>
             <a:endParaRPr lang="de-DE"/>
           </a:p>
@@ -4201,7 +4212,7 @@
           <a:p>
             <a:fld id="{6C43980B-2C02-594B-9C73-A951FE425682}" type="slidenum">
               <a:rPr lang="de-DE" smtClean="0"/>
-              <a:t>‹Nr.›</a:t>
+              <a:t>‹#›</a:t>
             </a:fld>
             <a:endParaRPr lang="de-DE"/>
           </a:p>
@@ -4260,7 +4271,7 @@
           <a:p>
             <a:fld id="{ECC4A7F1-D4D8-1545-AA93-BB835A9F7A8B}" type="datetime1">
               <a:rPr lang="de-DE" smtClean="0"/>
-              <a:t>19.06.26</a:t>
+              <a:t>23.06.2026</a:t>
             </a:fld>
             <a:endParaRPr lang="de-DE"/>
           </a:p>
@@ -4314,7 +4325,7 @@
           <a:p>
             <a:fld id="{6C43980B-2C02-594B-9C73-A951FE425682}" type="slidenum">
               <a:rPr lang="de-DE" smtClean="0"/>
-              <a:t>‹Nr.›</a:t>
+              <a:t>‹#›</a:t>
             </a:fld>
             <a:endParaRPr lang="de-DE"/>
           </a:p>
@@ -4571,7 +4582,7 @@
           <a:p>
             <a:fld id="{A04B4EF1-1BB5-A140-8507-2D8B6A510087}" type="datetime1">
               <a:rPr lang="de-DE" smtClean="0"/>
-              <a:t>19.06.26</a:t>
+              <a:t>23.06.2026</a:t>
             </a:fld>
             <a:endParaRPr lang="de-DE"/>
           </a:p>
@@ -4625,7 +4636,7 @@
           <a:p>
             <a:fld id="{6C43980B-2C02-594B-9C73-A951FE425682}" type="slidenum">
               <a:rPr lang="de-DE" smtClean="0"/>
-              <a:t>‹Nr.›</a:t>
+              <a:t>‹#›</a:t>
             </a:fld>
             <a:endParaRPr lang="de-DE"/>
           </a:p>
@@ -4859,7 +4870,7 @@
           <a:p>
             <a:fld id="{C33BA3A3-CA4A-E644-9084-D797594CB804}" type="datetime1">
               <a:rPr lang="de-DE" smtClean="0"/>
-              <a:t>19.06.26</a:t>
+              <a:t>23.06.2026</a:t>
             </a:fld>
             <a:endParaRPr lang="de-DE"/>
           </a:p>
@@ -4913,7 +4924,7 @@
           <a:p>
             <a:fld id="{6C43980B-2C02-594B-9C73-A951FE425682}" type="slidenum">
               <a:rPr lang="de-DE" smtClean="0"/>
-              <a:t>‹Nr.›</a:t>
+              <a:t>‹#›</a:t>
             </a:fld>
             <a:endParaRPr lang="de-DE"/>
           </a:p>
@@ -5100,7 +5111,7 @@
           <a:p>
             <a:fld id="{A7D163E4-7209-8D4B-B12D-5159794EF612}" type="datetime1">
               <a:rPr lang="de-DE" smtClean="0"/>
-              <a:t>19.06.26</a:t>
+              <a:t>23.06.2026</a:t>
             </a:fld>
             <a:endParaRPr lang="de-DE"/>
           </a:p>
@@ -5190,7 +5201,7 @@
           <a:p>
             <a:fld id="{6C43980B-2C02-594B-9C73-A951FE425682}" type="slidenum">
               <a:rPr lang="de-DE" smtClean="0"/>
-              <a:t>‹Nr.›</a:t>
+              <a:t>‹#›</a:t>
             </a:fld>
             <a:endParaRPr lang="de-DE"/>
           </a:p>
@@ -5981,7 +5992,7 @@
           <a:p>
             <a:r>
               <a:rPr lang="de-DE"/>
-              <a:t>PLATZHALTER FOLIEN THOMAS</a:t>
+              <a:t>Farbcodierung</a:t>
             </a:r>
           </a:p>
         </p:txBody>
@@ -6002,14 +6013,90 @@
             <p:ph idx="1"/>
           </p:nvPr>
         </p:nvSpPr>
-        <p:spPr/>
+        <p:spPr>
+          <a:xfrm>
+            <a:off x="968829" y="1985282"/>
+            <a:ext cx="5283201" cy="3524024"/>
+          </a:xfrm>
+        </p:spPr>
         <p:txBody>
-          <a:bodyPr/>
+          <a:bodyPr vert="horz" lIns="91440" tIns="45720" rIns="91440" bIns="45720" rtlCol="0" anchor="t">
+            <a:normAutofit/>
+          </a:bodyPr>
           <a:lstStyle/>
           <a:p>
             <a:r>
-              <a:rPr lang="de-DE"/>
-              <a:t>PLATZHALTER FOLIEN THOMAS</a:t>
+              <a:rPr lang="de-DE" sz="2100"/>
+              <a:t>Cores berechnen nur die Iterationsanzahl </a:t>
+            </a:r>
+            <a:endParaRPr lang="de-DE" sz="2100" dirty="0"/>
+          </a:p>
+          <a:p>
+            <a:r>
+              <a:rPr lang="de-DE" sz="2100"/>
+              <a:t>Farbcodierung erfolgt erst bei der Ausgabe</a:t>
+            </a:r>
+          </a:p>
+          <a:p>
+            <a:r>
+              <a:rPr lang="de-DE" sz="2100"/>
+              <a:t>Farbschema zur Laufzeit wechselbar</a:t>
+            </a:r>
+            <a:endParaRPr lang="de-DE"/>
+          </a:p>
+          <a:p>
+            <a:pPr marL="0" indent="0">
+              <a:buNone/>
+            </a:pPr>
+            <a:endParaRPr lang="de-DE" sz="2100" dirty="0"/>
+          </a:p>
+          <a:p>
+            <a:pPr marL="0" indent="0">
+              <a:buNone/>
+            </a:pPr>
+            <a:r>
+              <a:rPr lang="de-DE" sz="2100"/>
+              <a:t>Farbschemata: </a:t>
+            </a:r>
+          </a:p>
+          <a:p>
+            <a:pPr lvl="1">
+              <a:buFont typeface="Courier New" panose="020B0604020202020204" pitchFamily="34" charset="0"/>
+              <a:buChar char="o"/>
+            </a:pPr>
+            <a:r>
+              <a:rPr lang="de-DE" sz="2100"/>
+              <a:t>Graustufen </a:t>
+            </a:r>
+          </a:p>
+          <a:p>
+            <a:pPr lvl="1">
+              <a:buFont typeface="Courier New" panose="020B0604020202020204" pitchFamily="34" charset="0"/>
+              <a:buChar char="o"/>
+            </a:pPr>
+            <a:r>
+              <a:rPr lang="de-DE" sz="2100"/>
+              <a:t>Schwarz-Weiß </a:t>
+            </a:r>
+          </a:p>
+          <a:p>
+            <a:pPr lvl="1">
+              <a:buFont typeface="Courier New" panose="020B0604020202020204" pitchFamily="34" charset="0"/>
+              <a:buChar char="o"/>
+            </a:pPr>
+            <a:r>
+              <a:rPr lang="de-DE" sz="2100"/>
+              <a:t>Blau → Grün → Gelb → Rot </a:t>
+            </a:r>
+          </a:p>
+          <a:p>
+            <a:pPr lvl="1">
+              <a:buFont typeface="Courier New" panose="020B0604020202020204" pitchFamily="34" charset="0"/>
+              <a:buChar char="o"/>
+            </a:pPr>
+            <a:r>
+              <a:rPr lang="de-DE" sz="2100"/>
+              <a:t>Feuer </a:t>
             </a:r>
           </a:p>
         </p:txBody>
@@ -6043,6 +6130,226 @@
           </a:p>
         </p:txBody>
       </p:sp>
+      <p:sp>
+        <p:nvSpPr>
+          <p:cNvPr id="6" name="Rechteck 5">
+            <a:extLst>
+              <a:ext uri="{FF2B5EF4-FFF2-40B4-BE49-F238E27FC236}">
+                <a16:creationId xmlns:a16="http://schemas.microsoft.com/office/drawing/2014/main" id="{AF244251-AF87-C7E8-0D42-FBE2E569C8F7}"/>
+              </a:ext>
+            </a:extLst>
+          </p:cNvPr>
+          <p:cNvSpPr/>
+          <p:nvPr/>
+        </p:nvSpPr>
+        <p:spPr>
+          <a:xfrm>
+            <a:off x="838200" y="1833655"/>
+            <a:ext cx="5664200" cy="3800325"/>
+          </a:xfrm>
+          <a:prstGeom prst="rect">
+            <a:avLst/>
+          </a:prstGeom>
+          <a:noFill/>
+          <a:ln w="38100">
+            <a:solidFill>
+              <a:schemeClr val="accent1"/>
+            </a:solidFill>
+          </a:ln>
+        </p:spPr>
+        <p:style>
+          <a:lnRef idx="2">
+            <a:schemeClr val="accent1">
+              <a:shade val="15000"/>
+            </a:schemeClr>
+          </a:lnRef>
+          <a:fillRef idx="1">
+            <a:schemeClr val="accent1"/>
+          </a:fillRef>
+          <a:effectRef idx="0">
+            <a:schemeClr val="accent1"/>
+          </a:effectRef>
+          <a:fontRef idx="minor">
+            <a:schemeClr val="lt1"/>
+          </a:fontRef>
+        </p:style>
+        <p:txBody>
+          <a:bodyPr rtlCol="0" anchor="ctr"/>
+          <a:lstStyle/>
+          <a:p>
+            <a:pPr algn="ctr"/>
+            <a:endParaRPr lang="de-DE"/>
+          </a:p>
+        </p:txBody>
+      </p:sp>
+      <p:pic>
+        <p:nvPicPr>
+          <p:cNvPr id="4" name="Picture 3" descr="A yellow fractal on a white wall&#10;&#10;AI-generated content may be incorrect.">
+            <a:extLst>
+              <a:ext uri="{FF2B5EF4-FFF2-40B4-BE49-F238E27FC236}">
+                <a16:creationId xmlns:a16="http://schemas.microsoft.com/office/drawing/2014/main" id="{948290E0-8DAF-5876-411A-9435CB7CAEF4}"/>
+              </a:ext>
+            </a:extLst>
+          </p:cNvPr>
+          <p:cNvPicPr>
+            <a:picLocks noChangeAspect="1"/>
+          </p:cNvPicPr>
+          <p:nvPr/>
+        </p:nvPicPr>
+        <p:blipFill>
+          <a:blip r:embed="rId2"/>
+          <a:srcRect l="8765" t="14767" r="17849" b="25770"/>
+          <a:stretch>
+            <a:fillRect/>
+          </a:stretch>
+        </p:blipFill>
+        <p:spPr>
+          <a:xfrm>
+            <a:off x="7499413" y="692315"/>
+            <a:ext cx="3738674" cy="2273888"/>
+          </a:xfrm>
+          <a:prstGeom prst="rect">
+            <a:avLst/>
+          </a:prstGeom>
+        </p:spPr>
+      </p:pic>
+      <p:pic>
+        <p:nvPicPr>
+          <p:cNvPr id="7" name="Picture 6">
+            <a:extLst>
+              <a:ext uri="{FF2B5EF4-FFF2-40B4-BE49-F238E27FC236}">
+                <a16:creationId xmlns:a16="http://schemas.microsoft.com/office/drawing/2014/main" id="{32CC3D92-7CA7-8830-D9D4-E9B66893DC95}"/>
+              </a:ext>
+            </a:extLst>
+          </p:cNvPr>
+          <p:cNvPicPr>
+            <a:picLocks noChangeAspect="1"/>
+          </p:cNvPicPr>
+          <p:nvPr/>
+        </p:nvPicPr>
+        <p:blipFill>
+          <a:blip r:embed="rId3"/>
+          <a:srcRect l="18884" t="19048" r="12032" b="21998"/>
+          <a:stretch>
+            <a:fillRect/>
+          </a:stretch>
+        </p:blipFill>
+        <p:spPr>
+          <a:xfrm>
+            <a:off x="7500149" y="3519715"/>
+            <a:ext cx="3723077" cy="2388445"/>
+          </a:xfrm>
+          <a:prstGeom prst="rect">
+            <a:avLst/>
+          </a:prstGeom>
+        </p:spPr>
+      </p:pic>
+      <p:sp>
+        <p:nvSpPr>
+          <p:cNvPr id="9" name="Rechteck 7">
+            <a:extLst>
+              <a:ext uri="{FF2B5EF4-FFF2-40B4-BE49-F238E27FC236}">
+                <a16:creationId xmlns:a16="http://schemas.microsoft.com/office/drawing/2014/main" id="{78AD52B8-C231-6058-F3B7-05333290DE7A}"/>
+              </a:ext>
+            </a:extLst>
+          </p:cNvPr>
+          <p:cNvSpPr/>
+          <p:nvPr/>
+        </p:nvSpPr>
+        <p:spPr>
+          <a:xfrm>
+            <a:off x="7286824" y="2608779"/>
+            <a:ext cx="4167200" cy="524038"/>
+          </a:xfrm>
+          <a:prstGeom prst="rect">
+            <a:avLst/>
+          </a:prstGeom>
+          <a:ln>
+            <a:noFill/>
+          </a:ln>
+        </p:spPr>
+        <p:style>
+          <a:lnRef idx="2">
+            <a:schemeClr val="accent1">
+              <a:shade val="15000"/>
+            </a:schemeClr>
+          </a:lnRef>
+          <a:fillRef idx="1">
+            <a:schemeClr val="accent1"/>
+          </a:fillRef>
+          <a:effectRef idx="0">
+            <a:schemeClr val="accent1"/>
+          </a:effectRef>
+          <a:fontRef idx="minor">
+            <a:schemeClr val="lt1"/>
+          </a:fontRef>
+        </p:style>
+        <p:txBody>
+          <a:bodyPr lIns="91440" tIns="45720" rIns="91440" bIns="45720" rtlCol="0" anchor="ctr"/>
+          <a:lstStyle/>
+          <a:p>
+            <a:pPr algn="ctr"/>
+            <a:r>
+              <a:rPr lang="de-DE" sz="2100"/>
+              <a:t>Farbschema: Feuer</a:t>
+            </a:r>
+            <a:endParaRPr lang="de-DE" sz="2100" dirty="0"/>
+          </a:p>
+        </p:txBody>
+      </p:sp>
+      <p:sp>
+        <p:nvSpPr>
+          <p:cNvPr id="10" name="Rechteck 7">
+            <a:extLst>
+              <a:ext uri="{FF2B5EF4-FFF2-40B4-BE49-F238E27FC236}">
+                <a16:creationId xmlns:a16="http://schemas.microsoft.com/office/drawing/2014/main" id="{94772185-235B-C03A-824F-A449A186BE3C}"/>
+              </a:ext>
+            </a:extLst>
+          </p:cNvPr>
+          <p:cNvSpPr/>
+          <p:nvPr/>
+        </p:nvSpPr>
+        <p:spPr>
+          <a:xfrm>
+            <a:off x="7286823" y="5381007"/>
+            <a:ext cx="4167200" cy="524038"/>
+          </a:xfrm>
+          <a:prstGeom prst="rect">
+            <a:avLst/>
+          </a:prstGeom>
+          <a:ln>
+            <a:noFill/>
+          </a:ln>
+        </p:spPr>
+        <p:style>
+          <a:lnRef idx="2">
+            <a:schemeClr val="accent1">
+              <a:shade val="15000"/>
+            </a:schemeClr>
+          </a:lnRef>
+          <a:fillRef idx="1">
+            <a:schemeClr val="accent1"/>
+          </a:fillRef>
+          <a:effectRef idx="0">
+            <a:schemeClr val="accent1"/>
+          </a:effectRef>
+          <a:fontRef idx="minor">
+            <a:schemeClr val="lt1"/>
+          </a:fontRef>
+        </p:style>
+        <p:txBody>
+          <a:bodyPr lIns="91440" tIns="45720" rIns="91440" bIns="45720" rtlCol="0" anchor="ctr"/>
+          <a:lstStyle/>
+          <a:p>
+            <a:pPr algn="ctr"/>
+            <a:r>
+              <a:rPr lang="de-DE" sz="2100"/>
+              <a:t>Farbschema: Graustufen</a:t>
+            </a:r>
+            <a:endParaRPr lang="de-DE" sz="2100" dirty="0"/>
+          </a:p>
+        </p:txBody>
+      </p:sp>
     </p:spTree>
     <p:extLst>
       <p:ext uri="{BB962C8B-B14F-4D97-AF65-F5344CB8AC3E}">
@@ -6057,6 +6364,545 @@
 </file>
 
 <file path=ppt/slides/slide12.xml><?xml version="1.0" encoding="utf-8"?>
+<p:sld xmlns:a="http://schemas.openxmlformats.org/drawingml/2006/main" xmlns:r="http://schemas.openxmlformats.org/officeDocument/2006/relationships" xmlns:p="http://schemas.openxmlformats.org/presentationml/2006/main">
+  <p:cSld>
+    <p:spTree>
+      <p:nvGrpSpPr>
+        <p:cNvPr id="1" name=""/>
+        <p:cNvGrpSpPr/>
+        <p:nvPr/>
+      </p:nvGrpSpPr>
+      <p:grpSpPr>
+        <a:xfrm>
+          <a:off x="0" y="0"/>
+          <a:ext cx="0" cy="0"/>
+          <a:chOff x="0" y="0"/>
+          <a:chExt cx="0" cy="0"/>
+        </a:xfrm>
+      </p:grpSpPr>
+      <p:sp>
+        <p:nvSpPr>
+          <p:cNvPr id="2" name="Titel 1">
+            <a:extLst>
+              <a:ext uri="{FF2B5EF4-FFF2-40B4-BE49-F238E27FC236}">
+                <a16:creationId xmlns:a16="http://schemas.microsoft.com/office/drawing/2014/main" id="{AC483806-A22C-85D9-5174-72B7867699BD}"/>
+              </a:ext>
+            </a:extLst>
+          </p:cNvPr>
+          <p:cNvSpPr>
+            <a:spLocks noGrp="1"/>
+          </p:cNvSpPr>
+          <p:nvPr>
+            <p:ph type="title"/>
+          </p:nvPr>
+        </p:nvSpPr>
+        <p:spPr/>
+        <p:txBody>
+          <a:bodyPr/>
+          <a:lstStyle/>
+          <a:p>
+            <a:r>
+              <a:rPr lang="de-DE">
+                <a:ea typeface="+mj-lt"/>
+                <a:cs typeface="+mj-lt"/>
+              </a:rPr>
+              <a:t>Speicheroptimierung und Bildausgabe</a:t>
+            </a:r>
+            <a:endParaRPr lang="de-DE"/>
+          </a:p>
+        </p:txBody>
+      </p:sp>
+      <p:sp>
+        <p:nvSpPr>
+          <p:cNvPr id="4" name="Foliennummernplatzhalter 3">
+            <a:extLst>
+              <a:ext uri="{FF2B5EF4-FFF2-40B4-BE49-F238E27FC236}">
+                <a16:creationId xmlns:a16="http://schemas.microsoft.com/office/drawing/2014/main" id="{AA9CB8E1-C601-4295-2AA1-6F2F1788F9BC}"/>
+              </a:ext>
+            </a:extLst>
+          </p:cNvPr>
+          <p:cNvSpPr>
+            <a:spLocks noGrp="1"/>
+          </p:cNvSpPr>
+          <p:nvPr>
+            <p:ph type="sldNum" sz="quarter" idx="12"/>
+          </p:nvPr>
+        </p:nvSpPr>
+        <p:spPr/>
+        <p:txBody>
+          <a:bodyPr/>
+          <a:lstStyle/>
+          <a:p>
+            <a:fld id="{6C43980B-2C02-594B-9C73-A951FE425682}" type="slidenum">
+              <a:rPr lang="de-DE" smtClean="0"/>
+              <a:t>12</a:t>
+            </a:fld>
+            <a:endParaRPr lang="de-DE" dirty="0"/>
+          </a:p>
+        </p:txBody>
+      </p:sp>
+      <p:sp>
+        <p:nvSpPr>
+          <p:cNvPr id="6" name="Textfeld 5">
+            <a:extLst>
+              <a:ext uri="{FF2B5EF4-FFF2-40B4-BE49-F238E27FC236}">
+                <a16:creationId xmlns:a16="http://schemas.microsoft.com/office/drawing/2014/main" id="{A73AB165-E14E-B53F-C964-6095C65C6108}"/>
+              </a:ext>
+            </a:extLst>
+          </p:cNvPr>
+          <p:cNvSpPr txBox="1"/>
+          <p:nvPr/>
+        </p:nvSpPr>
+        <p:spPr>
+          <a:xfrm>
+            <a:off x="1042388" y="2331522"/>
+            <a:ext cx="3596574" cy="945101"/>
+          </a:xfrm>
+          <a:prstGeom prst="rect">
+            <a:avLst/>
+          </a:prstGeom>
+          <a:noFill/>
+        </p:spPr>
+        <p:txBody>
+          <a:bodyPr rot="0" spcFirstLastPara="0" vertOverflow="overflow" horzOverflow="overflow" vert="horz" wrap="square" lIns="91440" tIns="45720" rIns="91440" bIns="45720" numCol="1" spcCol="0" rtlCol="0" fromWordArt="0" anchor="t" anchorCtr="0" forceAA="0" compatLnSpc="1">
+            <a:prstTxWarp prst="textNoShape">
+              <a:avLst/>
+            </a:prstTxWarp>
+            <a:spAutoFit/>
+          </a:bodyPr>
+          <a:lstStyle/>
+          <a:p>
+            <a:r>
+              <a:rPr lang="de-DE" dirty="0" err="1">
+                <a:ea typeface="+mn-lt"/>
+                <a:cs typeface="+mn-lt"/>
+              </a:rPr>
+              <a:t>Framebuffer</a:t>
+            </a:r>
+            <a:r>
+              <a:rPr lang="de-DE" dirty="0">
+                <a:ea typeface="+mn-lt"/>
+                <a:cs typeface="+mn-lt"/>
+              </a:rPr>
+              <a:t> speichert RGB-Werte</a:t>
+            </a:r>
+            <a:endParaRPr lang="de-DE" dirty="0"/>
+          </a:p>
+          <a:p>
+            <a:r>
+              <a:rPr lang="de-DE">
+                <a:ea typeface="+mn-lt"/>
+                <a:cs typeface="+mn-lt"/>
+              </a:rPr>
+              <a:t>640 × 480 × 12 Bit</a:t>
+            </a:r>
+            <a:endParaRPr lang="de-DE"/>
+          </a:p>
+          <a:p>
+            <a:r>
+              <a:rPr lang="de-DE">
+                <a:ea typeface="+mn-lt"/>
+                <a:cs typeface="+mn-lt"/>
+              </a:rPr>
+              <a:t>= 3.686.400 Bit</a:t>
+            </a:r>
+            <a:endParaRPr lang="de-DE"/>
+          </a:p>
+        </p:txBody>
+      </p:sp>
+      <p:sp>
+        <p:nvSpPr>
+          <p:cNvPr id="9" name="Textfeld 8">
+            <a:extLst>
+              <a:ext uri="{FF2B5EF4-FFF2-40B4-BE49-F238E27FC236}">
+                <a16:creationId xmlns:a16="http://schemas.microsoft.com/office/drawing/2014/main" id="{C0041C89-578B-64BF-DA30-93E186870194}"/>
+              </a:ext>
+            </a:extLst>
+          </p:cNvPr>
+          <p:cNvSpPr txBox="1"/>
+          <p:nvPr/>
+        </p:nvSpPr>
+        <p:spPr>
+          <a:xfrm>
+            <a:off x="1044038" y="4655127"/>
+            <a:ext cx="3912589" cy="923330"/>
+          </a:xfrm>
+          <a:prstGeom prst="rect">
+            <a:avLst/>
+          </a:prstGeom>
+          <a:noFill/>
+        </p:spPr>
+        <p:txBody>
+          <a:bodyPr rot="0" spcFirstLastPara="0" vertOverflow="overflow" horzOverflow="overflow" vert="horz" wrap="square" lIns="91440" tIns="45720" rIns="91440" bIns="45720" numCol="1" spcCol="0" rtlCol="0" fromWordArt="0" anchor="t" anchorCtr="0" forceAA="0" compatLnSpc="1">
+            <a:prstTxWarp prst="textNoShape">
+              <a:avLst/>
+            </a:prstTxWarp>
+            <a:spAutoFit/>
+          </a:bodyPr>
+          <a:lstStyle/>
+          <a:p>
+            <a:r>
+              <a:rPr lang="de-DE" dirty="0" err="1">
+                <a:ea typeface="+mn-lt"/>
+                <a:cs typeface="+mn-lt"/>
+              </a:rPr>
+              <a:t>Framebuffer</a:t>
+            </a:r>
+            <a:r>
+              <a:rPr lang="de-DE" dirty="0">
+                <a:ea typeface="+mn-lt"/>
+                <a:cs typeface="+mn-lt"/>
+              </a:rPr>
+              <a:t> speichert Iterationen</a:t>
+            </a:r>
+            <a:endParaRPr lang="de-DE" dirty="0"/>
+          </a:p>
+          <a:p>
+            <a:r>
+              <a:rPr lang="de-DE">
+                <a:ea typeface="+mn-lt"/>
+                <a:cs typeface="+mn-lt"/>
+              </a:rPr>
+              <a:t>640 × 480 × 9 Bit</a:t>
+            </a:r>
+            <a:endParaRPr lang="de-DE"/>
+          </a:p>
+          <a:p>
+            <a:r>
+              <a:rPr lang="de-DE">
+                <a:ea typeface="+mn-lt"/>
+                <a:cs typeface="+mn-lt"/>
+              </a:rPr>
+              <a:t>= 2.764.800 Bit</a:t>
+            </a:r>
+            <a:endParaRPr lang="de-DE"/>
+          </a:p>
+        </p:txBody>
+      </p:sp>
+      <p:sp>
+        <p:nvSpPr>
+          <p:cNvPr id="10" name="Textfeld 9">
+            <a:extLst>
+              <a:ext uri="{FF2B5EF4-FFF2-40B4-BE49-F238E27FC236}">
+                <a16:creationId xmlns:a16="http://schemas.microsoft.com/office/drawing/2014/main" id="{121F7F0C-91FB-6E2C-3856-908B6E411239}"/>
+              </a:ext>
+            </a:extLst>
+          </p:cNvPr>
+          <p:cNvSpPr txBox="1"/>
+          <p:nvPr/>
+        </p:nvSpPr>
+        <p:spPr>
+          <a:xfrm>
+            <a:off x="6167912" y="3546434"/>
+            <a:ext cx="4057732" cy="923330"/>
+          </a:xfrm>
+          <a:prstGeom prst="rect">
+            <a:avLst/>
+          </a:prstGeom>
+          <a:noFill/>
+        </p:spPr>
+        <p:txBody>
+          <a:bodyPr rot="0" spcFirstLastPara="0" vertOverflow="overflow" horzOverflow="overflow" vert="horz" wrap="square" lIns="91440" tIns="45720" rIns="91440" bIns="45720" numCol="1" spcCol="0" rtlCol="0" fromWordArt="0" anchor="t" anchorCtr="0" forceAA="0" compatLnSpc="1">
+            <a:prstTxWarp prst="textNoShape">
+              <a:avLst/>
+            </a:prstTxWarp>
+            <a:spAutoFit/>
+          </a:bodyPr>
+          <a:lstStyle/>
+          <a:p>
+            <a:pPr marL="285750" indent="-285750">
+              <a:buFont typeface="Arial"/>
+              <a:buChar char="•"/>
+            </a:pPr>
+            <a:r>
+              <a:rPr lang="de-DE">
+                <a:ea typeface="+mn-lt"/>
+                <a:cs typeface="+mn-lt"/>
+              </a:rPr>
+              <a:t>~25 % weniger Speicherbedarf </a:t>
+            </a:r>
+            <a:endParaRPr lang="de-DE"/>
+          </a:p>
+          <a:p>
+            <a:pPr marL="285750" indent="-285750">
+              <a:buFont typeface="Arial"/>
+              <a:buChar char="•"/>
+            </a:pPr>
+            <a:r>
+              <a:rPr lang="de-DE">
+                <a:ea typeface="+mn-lt"/>
+                <a:cs typeface="+mn-lt"/>
+              </a:rPr>
+              <a:t>VGA-Ausgabe mit 640×480 @ 60 Hz </a:t>
+            </a:r>
+            <a:endParaRPr lang="de-DE"/>
+          </a:p>
+          <a:p>
+            <a:pPr marL="285750" indent="-285750">
+              <a:buFont typeface="Arial"/>
+              <a:buChar char="•"/>
+            </a:pPr>
+            <a:r>
+              <a:rPr lang="de-DE">
+                <a:ea typeface="+mn-lt"/>
+                <a:cs typeface="+mn-lt"/>
+              </a:rPr>
+              <a:t>Pixeltakt ca. 25 MHz</a:t>
+            </a:r>
+            <a:endParaRPr lang="de-DE"/>
+          </a:p>
+        </p:txBody>
+      </p:sp>
+      <p:sp>
+        <p:nvSpPr>
+          <p:cNvPr id="12" name="Rechteck 11">
+            <a:extLst>
+              <a:ext uri="{FF2B5EF4-FFF2-40B4-BE49-F238E27FC236}">
+                <a16:creationId xmlns:a16="http://schemas.microsoft.com/office/drawing/2014/main" id="{CF7C5772-FFAB-9045-9EAC-9D83431A99B2}"/>
+              </a:ext>
+            </a:extLst>
+          </p:cNvPr>
+          <p:cNvSpPr/>
+          <p:nvPr/>
+        </p:nvSpPr>
+        <p:spPr>
+          <a:xfrm>
+            <a:off x="6048829" y="3372169"/>
+            <a:ext cx="4220029" cy="1282097"/>
+          </a:xfrm>
+          <a:prstGeom prst="rect">
+            <a:avLst/>
+          </a:prstGeom>
+          <a:noFill/>
+          <a:ln w="38100">
+            <a:solidFill>
+              <a:schemeClr val="accent1"/>
+            </a:solidFill>
+          </a:ln>
+        </p:spPr>
+        <p:style>
+          <a:lnRef idx="2">
+            <a:schemeClr val="accent1">
+              <a:shade val="15000"/>
+            </a:schemeClr>
+          </a:lnRef>
+          <a:fillRef idx="1">
+            <a:schemeClr val="accent1"/>
+          </a:fillRef>
+          <a:effectRef idx="0">
+            <a:schemeClr val="accent1"/>
+          </a:effectRef>
+          <a:fontRef idx="minor">
+            <a:schemeClr val="lt1"/>
+          </a:fontRef>
+        </p:style>
+        <p:txBody>
+          <a:bodyPr rtlCol="0" anchor="ctr"/>
+          <a:lstStyle/>
+          <a:p>
+            <a:pPr algn="ctr"/>
+            <a:endParaRPr lang="de-DE"/>
+          </a:p>
+        </p:txBody>
+      </p:sp>
+      <p:sp>
+        <p:nvSpPr>
+          <p:cNvPr id="14" name="Rechteck 13">
+            <a:extLst>
+              <a:ext uri="{FF2B5EF4-FFF2-40B4-BE49-F238E27FC236}">
+                <a16:creationId xmlns:a16="http://schemas.microsoft.com/office/drawing/2014/main" id="{FAF53C63-EA9C-9251-1BA2-AD50EAF31496}"/>
+              </a:ext>
+            </a:extLst>
+          </p:cNvPr>
+          <p:cNvSpPr/>
+          <p:nvPr/>
+        </p:nvSpPr>
+        <p:spPr>
+          <a:xfrm>
+            <a:off x="925286" y="2116684"/>
+            <a:ext cx="4053114" cy="1601410"/>
+          </a:xfrm>
+          <a:prstGeom prst="rect">
+            <a:avLst/>
+          </a:prstGeom>
+          <a:noFill/>
+          <a:ln w="38100">
+            <a:solidFill>
+              <a:schemeClr val="accent1"/>
+            </a:solidFill>
+          </a:ln>
+        </p:spPr>
+        <p:style>
+          <a:lnRef idx="2">
+            <a:schemeClr val="accent1">
+              <a:shade val="15000"/>
+            </a:schemeClr>
+          </a:lnRef>
+          <a:fillRef idx="1">
+            <a:schemeClr val="accent1"/>
+          </a:fillRef>
+          <a:effectRef idx="0">
+            <a:schemeClr val="accent1"/>
+          </a:effectRef>
+          <a:fontRef idx="minor">
+            <a:schemeClr val="lt1"/>
+          </a:fontRef>
+        </p:style>
+        <p:txBody>
+          <a:bodyPr rtlCol="0" anchor="ctr"/>
+          <a:lstStyle/>
+          <a:p>
+            <a:pPr algn="ctr"/>
+            <a:endParaRPr lang="de-DE"/>
+          </a:p>
+        </p:txBody>
+      </p:sp>
+      <p:sp>
+        <p:nvSpPr>
+          <p:cNvPr id="7" name="Textfeld 6">
+            <a:extLst>
+              <a:ext uri="{FF2B5EF4-FFF2-40B4-BE49-F238E27FC236}">
+                <a16:creationId xmlns:a16="http://schemas.microsoft.com/office/drawing/2014/main" id="{340FB149-009D-C044-D194-94C0430590E1}"/>
+              </a:ext>
+            </a:extLst>
+          </p:cNvPr>
+          <p:cNvSpPr txBox="1"/>
+          <p:nvPr/>
+        </p:nvSpPr>
+        <p:spPr>
+          <a:xfrm>
+            <a:off x="1039748" y="1877291"/>
+            <a:ext cx="2821710" cy="461665"/>
+          </a:xfrm>
+          <a:prstGeom prst="rect">
+            <a:avLst/>
+          </a:prstGeom>
+          <a:solidFill>
+            <a:schemeClr val="bg1"/>
+          </a:solidFill>
+        </p:spPr>
+        <p:txBody>
+          <a:bodyPr rot="0" spcFirstLastPara="0" vertOverflow="overflow" horzOverflow="overflow" vert="horz" wrap="square" lIns="91440" tIns="45720" rIns="91440" bIns="45720" numCol="1" spcCol="0" rtlCol="0" fromWordArt="0" anchor="t" anchorCtr="0" forceAA="0" compatLnSpc="1">
+            <a:prstTxWarp prst="textNoShape">
+              <a:avLst/>
+            </a:prstTxWarp>
+            <a:spAutoFit/>
+          </a:bodyPr>
+          <a:lstStyle/>
+          <a:p>
+            <a:r>
+              <a:rPr lang="de-DE" sz="2400" b="1"/>
+              <a:t>Ursprüngliche Idee</a:t>
+            </a:r>
+          </a:p>
+        </p:txBody>
+      </p:sp>
+      <p:sp>
+        <p:nvSpPr>
+          <p:cNvPr id="16" name="Rechteck 15">
+            <a:extLst>
+              <a:ext uri="{FF2B5EF4-FFF2-40B4-BE49-F238E27FC236}">
+                <a16:creationId xmlns:a16="http://schemas.microsoft.com/office/drawing/2014/main" id="{4AA8CB4E-3139-D985-7A4A-FF4AFEB7FAD2}"/>
+              </a:ext>
+            </a:extLst>
+          </p:cNvPr>
+          <p:cNvSpPr/>
+          <p:nvPr/>
+        </p:nvSpPr>
+        <p:spPr>
+          <a:xfrm>
+            <a:off x="925285" y="4380912"/>
+            <a:ext cx="4045858" cy="1601411"/>
+          </a:xfrm>
+          <a:prstGeom prst="rect">
+            <a:avLst/>
+          </a:prstGeom>
+          <a:noFill/>
+          <a:ln w="38100">
+            <a:solidFill>
+              <a:schemeClr val="accent1"/>
+            </a:solidFill>
+          </a:ln>
+        </p:spPr>
+        <p:style>
+          <a:lnRef idx="2">
+            <a:schemeClr val="accent1">
+              <a:shade val="15000"/>
+            </a:schemeClr>
+          </a:lnRef>
+          <a:fillRef idx="1">
+            <a:schemeClr val="accent1"/>
+          </a:fillRef>
+          <a:effectRef idx="0">
+            <a:schemeClr val="accent1"/>
+          </a:effectRef>
+          <a:fontRef idx="minor">
+            <a:schemeClr val="lt1"/>
+          </a:fontRef>
+        </p:style>
+        <p:txBody>
+          <a:bodyPr rtlCol="0" anchor="ctr"/>
+          <a:lstStyle/>
+          <a:p>
+            <a:pPr algn="ctr"/>
+            <a:endParaRPr lang="de-DE"/>
+          </a:p>
+        </p:txBody>
+      </p:sp>
+      <p:sp>
+        <p:nvSpPr>
+          <p:cNvPr id="8" name="Textfeld 7">
+            <a:extLst>
+              <a:ext uri="{FF2B5EF4-FFF2-40B4-BE49-F238E27FC236}">
+                <a16:creationId xmlns:a16="http://schemas.microsoft.com/office/drawing/2014/main" id="{A9FDF06F-5F41-909A-19C0-502FA12CC67E}"/>
+              </a:ext>
+            </a:extLst>
+          </p:cNvPr>
+          <p:cNvSpPr txBox="1"/>
+          <p:nvPr/>
+        </p:nvSpPr>
+        <p:spPr>
+          <a:xfrm>
+            <a:off x="1040740" y="4146797"/>
+            <a:ext cx="2921660" cy="461665"/>
+          </a:xfrm>
+          <a:prstGeom prst="rect">
+            <a:avLst/>
+          </a:prstGeom>
+          <a:solidFill>
+            <a:schemeClr val="bg1"/>
+          </a:solidFill>
+        </p:spPr>
+        <p:txBody>
+          <a:bodyPr rot="0" spcFirstLastPara="0" vertOverflow="overflow" horzOverflow="overflow" vert="horz" wrap="square" lIns="91440" tIns="45720" rIns="91440" bIns="45720" numCol="1" spcCol="0" rtlCol="0" fromWordArt="0" anchor="t" anchorCtr="0" forceAA="0" compatLnSpc="1">
+            <a:prstTxWarp prst="textNoShape">
+              <a:avLst/>
+            </a:prstTxWarp>
+            <a:spAutoFit/>
+          </a:bodyPr>
+          <a:lstStyle/>
+          <a:p>
+            <a:r>
+              <a:rPr lang="de-DE" sz="2400" b="1"/>
+              <a:t>Umgesetzte Lösung</a:t>
+            </a:r>
+          </a:p>
+        </p:txBody>
+      </p:sp>
+    </p:spTree>
+    <p:extLst>
+      <p:ext uri="{BB962C8B-B14F-4D97-AF65-F5344CB8AC3E}">
+        <p14:creationId xmlns:p14="http://schemas.microsoft.com/office/powerpoint/2010/main" val="1977590359"/>
+      </p:ext>
+    </p:extLst>
+  </p:cSld>
+  <p:clrMapOvr>
+    <a:masterClrMapping/>
+  </p:clrMapOvr>
+</p:sld>
+</file>
+
+<file path=ppt/slides/slide13.xml><?xml version="1.0" encoding="utf-8"?>
 <p:sld xmlns:a="http://schemas.openxmlformats.org/drawingml/2006/main" xmlns:r="http://schemas.openxmlformats.org/officeDocument/2006/relationships" xmlns:p="http://schemas.openxmlformats.org/presentationml/2006/main">
   <p:cSld>
     <p:spTree>
@@ -6159,7 +7005,7 @@
           <a:p>
             <a:fld id="{6C43980B-2C02-594B-9C73-A951FE425682}" type="slidenum">
               <a:rPr lang="de-DE" smtClean="0"/>
-              <a:t>12</a:t>
+              <a:t>13</a:t>
             </a:fld>
             <a:endParaRPr lang="de-DE" dirty="0"/>
           </a:p>
@@ -6178,7 +7024,7 @@
 </p:sld>
 </file>
 
-<file path=ppt/slides/slide13.xml><?xml version="1.0" encoding="utf-8"?>
+<file path=ppt/slides/slide14.xml><?xml version="1.0" encoding="utf-8"?>
 <p:sld xmlns:a="http://schemas.openxmlformats.org/drawingml/2006/main" xmlns:r="http://schemas.openxmlformats.org/officeDocument/2006/relationships" xmlns:p="http://schemas.openxmlformats.org/presentationml/2006/main">
   <p:cSld>
     <p:spTree>
@@ -6223,36 +7069,25 @@
           <a:lstStyle/>
           <a:p>
             <a:r>
-              <a:rPr lang="de-DE"/>
-              <a:t>PLATZHALTER FOLIEN THOMAS</a:t>
+              <a:rPr lang="de-DE" dirty="0">
+                <a:ea typeface="+mj-lt"/>
+                <a:cs typeface="+mj-lt"/>
+              </a:rPr>
+              <a:t>Steuerung über </a:t>
             </a:r>
-          </a:p>
-        </p:txBody>
-      </p:sp>
-      <p:sp>
-        <p:nvSpPr>
-          <p:cNvPr id="3" name="Inhaltsplatzhalter 2">
-            <a:extLst>
-              <a:ext uri="{FF2B5EF4-FFF2-40B4-BE49-F238E27FC236}">
-                <a16:creationId xmlns:a16="http://schemas.microsoft.com/office/drawing/2014/main" id="{B2943D88-2FB6-CF78-A587-C0A5A330EEA0}"/>
-              </a:ext>
-            </a:extLst>
-          </p:cNvPr>
-          <p:cNvSpPr>
-            <a:spLocks noGrp="1"/>
-          </p:cNvSpPr>
-          <p:nvPr>
-            <p:ph idx="1"/>
-          </p:nvPr>
-        </p:nvSpPr>
-        <p:spPr/>
-        <p:txBody>
-          <a:bodyPr/>
-          <a:lstStyle/>
-          <a:p>
             <a:r>
-              <a:rPr lang="de-DE"/>
-              <a:t>PLATZHALTER FOLIEN THOMAS</a:t>
+              <a:rPr lang="de-DE" dirty="0" err="1">
+                <a:ea typeface="+mj-lt"/>
+                <a:cs typeface="+mj-lt"/>
+              </a:rPr>
+              <a:t>MicroBlaze</a:t>
+            </a:r>
+            <a:r>
+              <a:rPr lang="de-DE" dirty="0">
+                <a:ea typeface="+mj-lt"/>
+                <a:cs typeface="+mj-lt"/>
+              </a:rPr>
+              <a:t> und UART</a:t>
             </a:r>
           </a:p>
         </p:txBody>
@@ -6280,9 +7115,1046 @@
           <a:p>
             <a:fld id="{6C43980B-2C02-594B-9C73-A951FE425682}" type="slidenum">
               <a:rPr lang="de-DE" smtClean="0"/>
-              <a:t>13</a:t>
+              <a:t>14</a:t>
             </a:fld>
             <a:endParaRPr lang="de-DE" dirty="0"/>
+          </a:p>
+        </p:txBody>
+      </p:sp>
+      <p:sp>
+        <p:nvSpPr>
+          <p:cNvPr id="7" name="Textfeld 6">
+            <a:extLst>
+              <a:ext uri="{FF2B5EF4-FFF2-40B4-BE49-F238E27FC236}">
+                <a16:creationId xmlns:a16="http://schemas.microsoft.com/office/drawing/2014/main" id="{49D0F191-4538-4A13-DB2D-864D7511E53C}"/>
+              </a:ext>
+            </a:extLst>
+          </p:cNvPr>
+          <p:cNvSpPr txBox="1"/>
+          <p:nvPr/>
+        </p:nvSpPr>
+        <p:spPr>
+          <a:xfrm>
+            <a:off x="1128486" y="1604818"/>
+            <a:ext cx="1524000" cy="369332"/>
+          </a:xfrm>
+          <a:prstGeom prst="rect">
+            <a:avLst/>
+          </a:prstGeom>
+          <a:noFill/>
+        </p:spPr>
+        <p:txBody>
+          <a:bodyPr rot="0" spcFirstLastPara="0" vertOverflow="overflow" horzOverflow="overflow" vert="horz" wrap="square" lIns="91440" tIns="45720" rIns="91440" bIns="45720" numCol="1" spcCol="0" rtlCol="0" fromWordArt="0" anchor="t" anchorCtr="0" forceAA="0" compatLnSpc="1">
+            <a:prstTxWarp prst="textNoShape">
+              <a:avLst/>
+            </a:prstTxWarp>
+            <a:spAutoFit/>
+          </a:bodyPr>
+          <a:lstStyle/>
+          <a:p>
+            <a:pPr algn="ctr"/>
+            <a:r>
+              <a:rPr lang="de-DE"/>
+              <a:t>Benutzer</a:t>
+            </a:r>
+            <a:endParaRPr lang="en-US"/>
+          </a:p>
+        </p:txBody>
+      </p:sp>
+      <p:sp>
+        <p:nvSpPr>
+          <p:cNvPr id="8" name="Textfeld 7">
+            <a:extLst>
+              <a:ext uri="{FF2B5EF4-FFF2-40B4-BE49-F238E27FC236}">
+                <a16:creationId xmlns:a16="http://schemas.microsoft.com/office/drawing/2014/main" id="{13CB833B-F55D-D02B-2E1E-BC75CF3AD960}"/>
+              </a:ext>
+            </a:extLst>
+          </p:cNvPr>
+          <p:cNvSpPr txBox="1"/>
+          <p:nvPr/>
+        </p:nvSpPr>
+        <p:spPr>
+          <a:xfrm>
+            <a:off x="1033813" y="2645558"/>
+            <a:ext cx="1743363" cy="369332"/>
+          </a:xfrm>
+          <a:prstGeom prst="rect">
+            <a:avLst/>
+          </a:prstGeom>
+          <a:noFill/>
+        </p:spPr>
+        <p:txBody>
+          <a:bodyPr rot="0" spcFirstLastPara="0" vertOverflow="overflow" horzOverflow="overflow" vert="horz" wrap="square" lIns="91440" tIns="45720" rIns="91440" bIns="45720" numCol="1" spcCol="0" rtlCol="0" fromWordArt="0" anchor="t" anchorCtr="0" forceAA="0" compatLnSpc="1">
+            <a:prstTxWarp prst="textNoShape">
+              <a:avLst/>
+            </a:prstTxWarp>
+            <a:spAutoFit/>
+          </a:bodyPr>
+          <a:lstStyle/>
+          <a:p>
+            <a:pPr algn="ctr"/>
+            <a:r>
+              <a:rPr lang="de-DE"/>
+              <a:t>UART-Konsole</a:t>
+            </a:r>
+            <a:endParaRPr lang="en-US"/>
+          </a:p>
+        </p:txBody>
+      </p:sp>
+      <p:sp>
+        <p:nvSpPr>
+          <p:cNvPr id="9" name="Textfeld 8">
+            <a:extLst>
+              <a:ext uri="{FF2B5EF4-FFF2-40B4-BE49-F238E27FC236}">
+                <a16:creationId xmlns:a16="http://schemas.microsoft.com/office/drawing/2014/main" id="{FA67A4BF-8D46-EC08-9548-7A6DD24EA469}"/>
+              </a:ext>
+            </a:extLst>
+          </p:cNvPr>
+          <p:cNvSpPr txBox="1"/>
+          <p:nvPr/>
+        </p:nvSpPr>
+        <p:spPr>
+          <a:xfrm>
+            <a:off x="1117600" y="3705430"/>
+            <a:ext cx="1537524" cy="369332"/>
+          </a:xfrm>
+          <a:prstGeom prst="rect">
+            <a:avLst/>
+          </a:prstGeom>
+          <a:noFill/>
+        </p:spPr>
+        <p:txBody>
+          <a:bodyPr rot="0" spcFirstLastPara="0" vertOverflow="overflow" horzOverflow="overflow" vert="horz" wrap="square" lIns="91440" tIns="45720" rIns="91440" bIns="45720" numCol="1" spcCol="0" rtlCol="0" fromWordArt="0" anchor="t" anchorCtr="0" forceAA="0" compatLnSpc="1">
+            <a:prstTxWarp prst="textNoShape">
+              <a:avLst/>
+            </a:prstTxWarp>
+            <a:spAutoFit/>
+          </a:bodyPr>
+          <a:lstStyle/>
+          <a:p>
+            <a:pPr algn="ctr"/>
+            <a:r>
+              <a:rPr lang="de-DE" dirty="0" err="1"/>
+              <a:t>MicroBla</a:t>
+            </a:r>
+            <a:r>
+              <a:rPr lang="de-DE" dirty="0" err="1">
+                <a:solidFill>
+                  <a:srgbClr val="000000"/>
+                </a:solidFill>
+                <a:latin typeface="Aptos"/>
+              </a:rPr>
+              <a:t>ze</a:t>
+            </a:r>
+            <a:endParaRPr lang="de-DE" dirty="0" err="1"/>
+          </a:p>
+        </p:txBody>
+      </p:sp>
+      <p:sp>
+        <p:nvSpPr>
+          <p:cNvPr id="10" name="Textfeld 9">
+            <a:extLst>
+              <a:ext uri="{FF2B5EF4-FFF2-40B4-BE49-F238E27FC236}">
+                <a16:creationId xmlns:a16="http://schemas.microsoft.com/office/drawing/2014/main" id="{D5FCAC23-7F6D-C180-317C-BC578C9974A2}"/>
+              </a:ext>
+            </a:extLst>
+          </p:cNvPr>
+          <p:cNvSpPr txBox="1"/>
+          <p:nvPr/>
+        </p:nvSpPr>
+        <p:spPr>
+          <a:xfrm>
+            <a:off x="734621" y="4755078"/>
+            <a:ext cx="2309090" cy="369332"/>
+          </a:xfrm>
+          <a:prstGeom prst="rect">
+            <a:avLst/>
+          </a:prstGeom>
+          <a:noFill/>
+        </p:spPr>
+        <p:txBody>
+          <a:bodyPr rot="0" spcFirstLastPara="0" vertOverflow="overflow" horzOverflow="overflow" vert="horz" wrap="square" lIns="91440" tIns="45720" rIns="91440" bIns="45720" numCol="1" spcCol="0" rtlCol="0" fromWordArt="0" anchor="t" anchorCtr="0" forceAA="0" compatLnSpc="1">
+            <a:prstTxWarp prst="textNoShape">
+              <a:avLst/>
+            </a:prstTxWarp>
+            <a:spAutoFit/>
+          </a:bodyPr>
+          <a:lstStyle/>
+          <a:p>
+            <a:pPr algn="ctr"/>
+            <a:r>
+              <a:rPr lang="de-DE"/>
+              <a:t>AXI-Lite Register</a:t>
+            </a:r>
+            <a:endParaRPr lang="en-US"/>
+          </a:p>
+        </p:txBody>
+      </p:sp>
+      <p:sp>
+        <p:nvSpPr>
+          <p:cNvPr id="11" name="Textfeld 10">
+            <a:extLst>
+              <a:ext uri="{FF2B5EF4-FFF2-40B4-BE49-F238E27FC236}">
+                <a16:creationId xmlns:a16="http://schemas.microsoft.com/office/drawing/2014/main" id="{758792F2-3ACB-C6DA-A7F2-0C36E07EA4D9}"/>
+              </a:ext>
+            </a:extLst>
+          </p:cNvPr>
+          <p:cNvSpPr txBox="1"/>
+          <p:nvPr/>
+        </p:nvSpPr>
+        <p:spPr>
+          <a:xfrm>
+            <a:off x="300511" y="5725886"/>
+            <a:ext cx="1905000" cy="369332"/>
+          </a:xfrm>
+          <a:prstGeom prst="rect">
+            <a:avLst/>
+          </a:prstGeom>
+          <a:noFill/>
+        </p:spPr>
+        <p:txBody>
+          <a:bodyPr rot="0" spcFirstLastPara="0" vertOverflow="overflow" horzOverflow="overflow" vert="horz" wrap="square" lIns="91440" tIns="45720" rIns="91440" bIns="45720" numCol="1" spcCol="0" rtlCol="0" fromWordArt="0" anchor="t" anchorCtr="0" forceAA="0" compatLnSpc="1">
+            <a:prstTxWarp prst="textNoShape">
+              <a:avLst/>
+            </a:prstTxWarp>
+            <a:spAutoFit/>
+          </a:bodyPr>
+          <a:lstStyle/>
+          <a:p>
+            <a:pPr algn="ctr"/>
+            <a:r>
+              <a:rPr lang="de-DE" dirty="0"/>
+              <a:t>Init</a:t>
+            </a:r>
+            <a:r>
+              <a:rPr lang="de-DE"/>
+              <a:t>ialwerte</a:t>
+            </a:r>
+            <a:endParaRPr lang="en-US"/>
+          </a:p>
+        </p:txBody>
+      </p:sp>
+      <p:sp>
+        <p:nvSpPr>
+          <p:cNvPr id="12" name="Textfeld 11">
+            <a:extLst>
+              <a:ext uri="{FF2B5EF4-FFF2-40B4-BE49-F238E27FC236}">
+                <a16:creationId xmlns:a16="http://schemas.microsoft.com/office/drawing/2014/main" id="{5F31B198-17AF-4490-699A-5D8661C92EE0}"/>
+              </a:ext>
+            </a:extLst>
+          </p:cNvPr>
+          <p:cNvSpPr txBox="1"/>
+          <p:nvPr/>
+        </p:nvSpPr>
+        <p:spPr>
+          <a:xfrm>
+            <a:off x="2903186" y="5724566"/>
+            <a:ext cx="1685306" cy="369332"/>
+          </a:xfrm>
+          <a:prstGeom prst="rect">
+            <a:avLst/>
+          </a:prstGeom>
+          <a:noFill/>
+        </p:spPr>
+        <p:txBody>
+          <a:bodyPr rot="0" spcFirstLastPara="0" vertOverflow="overflow" horzOverflow="overflow" vert="horz" wrap="square" lIns="91440" tIns="45720" rIns="91440" bIns="45720" numCol="1" spcCol="0" rtlCol="0" fromWordArt="0" anchor="t" anchorCtr="0" forceAA="0" compatLnSpc="1">
+            <a:prstTxWarp prst="textNoShape">
+              <a:avLst/>
+            </a:prstTxWarp>
+            <a:spAutoFit/>
+          </a:bodyPr>
+          <a:lstStyle/>
+          <a:p>
+            <a:pPr algn="ctr"/>
+            <a:r>
+              <a:rPr lang="de-DE" dirty="0"/>
+              <a:t>Farb</a:t>
+            </a:r>
+            <a:r>
+              <a:rPr lang="de-DE"/>
+              <a:t>schema</a:t>
+            </a:r>
+            <a:endParaRPr lang="en-US"/>
+          </a:p>
+        </p:txBody>
+      </p:sp>
+      <p:sp>
+        <p:nvSpPr>
+          <p:cNvPr id="13" name="Textfeld 12">
+            <a:extLst>
+              <a:ext uri="{FF2B5EF4-FFF2-40B4-BE49-F238E27FC236}">
+                <a16:creationId xmlns:a16="http://schemas.microsoft.com/office/drawing/2014/main" id="{B176685B-4E8A-FD7E-41CD-66F0D9BF111C}"/>
+              </a:ext>
+            </a:extLst>
+          </p:cNvPr>
+          <p:cNvSpPr txBox="1"/>
+          <p:nvPr/>
+        </p:nvSpPr>
+        <p:spPr>
+          <a:xfrm>
+            <a:off x="5579754" y="2373744"/>
+            <a:ext cx="4820061" cy="1477328"/>
+          </a:xfrm>
+          <a:prstGeom prst="rect">
+            <a:avLst/>
+          </a:prstGeom>
+          <a:noFill/>
+        </p:spPr>
+        <p:txBody>
+          <a:bodyPr rot="0" spcFirstLastPara="0" vertOverflow="overflow" horzOverflow="overflow" vert="horz" wrap="square" lIns="91440" tIns="45720" rIns="91440" bIns="45720" numCol="1" spcCol="0" rtlCol="0" fromWordArt="0" anchor="t" anchorCtr="0" forceAA="0" compatLnSpc="1">
+            <a:prstTxWarp prst="textNoShape">
+              <a:avLst/>
+            </a:prstTxWarp>
+            <a:spAutoFit/>
+          </a:bodyPr>
+          <a:lstStyle/>
+          <a:p>
+            <a:pPr marL="285750" indent="-285750">
+              <a:buFont typeface="Arial"/>
+              <a:buChar char="•"/>
+            </a:pPr>
+            <a:r>
+              <a:rPr lang="de-DE">
+                <a:ea typeface="+mn-lt"/>
+                <a:cs typeface="+mn-lt"/>
+              </a:rPr>
+              <a:t>Laufzeitkonfiguration ohne neue Synthese </a:t>
+            </a:r>
+            <a:endParaRPr lang="de-DE"/>
+          </a:p>
+          <a:p>
+            <a:pPr marL="285750" indent="-285750">
+              <a:buFont typeface="Arial"/>
+              <a:buChar char="•"/>
+            </a:pPr>
+            <a:r>
+              <a:rPr lang="de-DE">
+                <a:ea typeface="+mn-lt"/>
+                <a:cs typeface="+mn-lt"/>
+              </a:rPr>
+              <a:t>Auswahl von Mandelbrot- und Julia-Modi </a:t>
+            </a:r>
+            <a:endParaRPr lang="de-DE"/>
+          </a:p>
+          <a:p>
+            <a:pPr marL="285750" indent="-285750">
+              <a:buFont typeface="Arial"/>
+              <a:buChar char="•"/>
+            </a:pPr>
+            <a:r>
+              <a:rPr lang="de-DE">
+                <a:ea typeface="+mn-lt"/>
+                <a:cs typeface="+mn-lt"/>
+              </a:rPr>
+              <a:t>Zoom und Animationsgeschwindigkeit </a:t>
+            </a:r>
+            <a:endParaRPr lang="de-DE"/>
+          </a:p>
+          <a:p>
+            <a:pPr marL="285750" indent="-285750">
+              <a:buFont typeface="Arial"/>
+              <a:buChar char="•"/>
+            </a:pPr>
+            <a:r>
+              <a:rPr lang="de-DE">
+                <a:ea typeface="+mn-lt"/>
+                <a:cs typeface="+mn-lt"/>
+              </a:rPr>
+              <a:t>LFSR- und Diamond-Parameter </a:t>
+            </a:r>
+            <a:endParaRPr lang="de-DE"/>
+          </a:p>
+          <a:p>
+            <a:pPr marL="285750" indent="-285750">
+              <a:buFont typeface="Arial"/>
+              <a:buChar char="•"/>
+            </a:pPr>
+            <a:r>
+              <a:rPr lang="de-DE">
+                <a:ea typeface="+mn-lt"/>
+                <a:cs typeface="+mn-lt"/>
+              </a:rPr>
+              <a:t>Farbschema konfigurierbar</a:t>
+            </a:r>
+            <a:endParaRPr lang="de-DE"/>
+          </a:p>
+        </p:txBody>
+      </p:sp>
+      <p:cxnSp>
+        <p:nvCxnSpPr>
+          <p:cNvPr id="15" name="Verbinder: gewinkelt 14">
+            <a:extLst>
+              <a:ext uri="{FF2B5EF4-FFF2-40B4-BE49-F238E27FC236}">
+                <a16:creationId xmlns:a16="http://schemas.microsoft.com/office/drawing/2014/main" id="{576E06BB-FFC1-F4B9-D321-913A938C9B47}"/>
+              </a:ext>
+            </a:extLst>
+          </p:cNvPr>
+          <p:cNvCxnSpPr/>
+          <p:nvPr/>
+        </p:nvCxnSpPr>
+        <p:spPr>
+          <a:xfrm>
+            <a:off x="1895763" y="2011549"/>
+            <a:ext cx="2968" cy="548904"/>
+          </a:xfrm>
+          <a:prstGeom prst="bentConnector3">
+            <a:avLst/>
+          </a:prstGeom>
+          <a:ln>
+            <a:tailEnd type="triangle"/>
+          </a:ln>
+        </p:spPr>
+        <p:style>
+          <a:lnRef idx="1">
+            <a:schemeClr val="dk1"/>
+          </a:lnRef>
+          <a:fillRef idx="0">
+            <a:schemeClr val="dk1"/>
+          </a:fillRef>
+          <a:effectRef idx="0">
+            <a:schemeClr val="dk1"/>
+          </a:effectRef>
+          <a:fontRef idx="minor">
+            <a:schemeClr val="tx1"/>
+          </a:fontRef>
+        </p:style>
+      </p:cxnSp>
+      <p:sp>
+        <p:nvSpPr>
+          <p:cNvPr id="4" name="Rechteck 13">
+            <a:extLst>
+              <a:ext uri="{FF2B5EF4-FFF2-40B4-BE49-F238E27FC236}">
+                <a16:creationId xmlns:a16="http://schemas.microsoft.com/office/drawing/2014/main" id="{FD42E074-B764-F01B-15CF-D78A9396F2F5}"/>
+              </a:ext>
+            </a:extLst>
+          </p:cNvPr>
+          <p:cNvSpPr/>
+          <p:nvPr/>
+        </p:nvSpPr>
+        <p:spPr>
+          <a:xfrm>
+            <a:off x="1026886" y="1557884"/>
+            <a:ext cx="1752600" cy="462039"/>
+          </a:xfrm>
+          <a:prstGeom prst="rect">
+            <a:avLst/>
+          </a:prstGeom>
+          <a:noFill/>
+          <a:ln w="38100">
+            <a:solidFill>
+              <a:schemeClr val="accent1"/>
+            </a:solidFill>
+          </a:ln>
+        </p:spPr>
+        <p:style>
+          <a:lnRef idx="2">
+            <a:schemeClr val="accent1">
+              <a:shade val="15000"/>
+            </a:schemeClr>
+          </a:lnRef>
+          <a:fillRef idx="1">
+            <a:schemeClr val="accent1"/>
+          </a:fillRef>
+          <a:effectRef idx="0">
+            <a:schemeClr val="accent1"/>
+          </a:effectRef>
+          <a:fontRef idx="minor">
+            <a:schemeClr val="lt1"/>
+          </a:fontRef>
+        </p:style>
+        <p:txBody>
+          <a:bodyPr rtlCol="0" anchor="ctr"/>
+          <a:lstStyle/>
+          <a:p>
+            <a:pPr algn="ctr"/>
+            <a:endParaRPr lang="de-DE"/>
+          </a:p>
+        </p:txBody>
+      </p:sp>
+      <p:sp>
+        <p:nvSpPr>
+          <p:cNvPr id="6" name="Rechteck 13">
+            <a:extLst>
+              <a:ext uri="{FF2B5EF4-FFF2-40B4-BE49-F238E27FC236}">
+                <a16:creationId xmlns:a16="http://schemas.microsoft.com/office/drawing/2014/main" id="{ED73F2AA-F415-EE8C-CE19-A6C73D61A472}"/>
+              </a:ext>
+            </a:extLst>
+          </p:cNvPr>
+          <p:cNvSpPr/>
+          <p:nvPr/>
+        </p:nvSpPr>
+        <p:spPr>
+          <a:xfrm>
+            <a:off x="1026885" y="2595655"/>
+            <a:ext cx="1752600" cy="462039"/>
+          </a:xfrm>
+          <a:prstGeom prst="rect">
+            <a:avLst/>
+          </a:prstGeom>
+          <a:noFill/>
+          <a:ln w="38100">
+            <a:solidFill>
+              <a:schemeClr val="accent1"/>
+            </a:solidFill>
+          </a:ln>
+        </p:spPr>
+        <p:style>
+          <a:lnRef idx="2">
+            <a:schemeClr val="accent1">
+              <a:shade val="15000"/>
+            </a:schemeClr>
+          </a:lnRef>
+          <a:fillRef idx="1">
+            <a:schemeClr val="accent1"/>
+          </a:fillRef>
+          <a:effectRef idx="0">
+            <a:schemeClr val="accent1"/>
+          </a:effectRef>
+          <a:fontRef idx="minor">
+            <a:schemeClr val="lt1"/>
+          </a:fontRef>
+        </p:style>
+        <p:txBody>
+          <a:bodyPr rtlCol="0" anchor="ctr"/>
+          <a:lstStyle/>
+          <a:p>
+            <a:pPr algn="ctr"/>
+            <a:endParaRPr lang="de-DE"/>
+          </a:p>
+        </p:txBody>
+      </p:sp>
+      <p:sp>
+        <p:nvSpPr>
+          <p:cNvPr id="16" name="Rechteck 13">
+            <a:extLst>
+              <a:ext uri="{FF2B5EF4-FFF2-40B4-BE49-F238E27FC236}">
+                <a16:creationId xmlns:a16="http://schemas.microsoft.com/office/drawing/2014/main" id="{0861E76F-2588-E727-D744-50A190E44B14}"/>
+              </a:ext>
+            </a:extLst>
+          </p:cNvPr>
+          <p:cNvSpPr/>
+          <p:nvPr/>
+        </p:nvSpPr>
+        <p:spPr>
+          <a:xfrm>
+            <a:off x="1005113" y="3655196"/>
+            <a:ext cx="1752600" cy="462039"/>
+          </a:xfrm>
+          <a:prstGeom prst="rect">
+            <a:avLst/>
+          </a:prstGeom>
+          <a:noFill/>
+          <a:ln w="38100">
+            <a:solidFill>
+              <a:schemeClr val="accent1"/>
+            </a:solidFill>
+          </a:ln>
+        </p:spPr>
+        <p:style>
+          <a:lnRef idx="2">
+            <a:schemeClr val="accent1">
+              <a:shade val="15000"/>
+            </a:schemeClr>
+          </a:lnRef>
+          <a:fillRef idx="1">
+            <a:schemeClr val="accent1"/>
+          </a:fillRef>
+          <a:effectRef idx="0">
+            <a:schemeClr val="accent1"/>
+          </a:effectRef>
+          <a:fontRef idx="minor">
+            <a:schemeClr val="lt1"/>
+          </a:fontRef>
+        </p:style>
+        <p:txBody>
+          <a:bodyPr rtlCol="0" anchor="ctr"/>
+          <a:lstStyle/>
+          <a:p>
+            <a:pPr algn="ctr"/>
+            <a:endParaRPr lang="de-DE"/>
+          </a:p>
+        </p:txBody>
+      </p:sp>
+      <p:sp>
+        <p:nvSpPr>
+          <p:cNvPr id="18" name="Rechteck 13">
+            <a:extLst>
+              <a:ext uri="{FF2B5EF4-FFF2-40B4-BE49-F238E27FC236}">
+                <a16:creationId xmlns:a16="http://schemas.microsoft.com/office/drawing/2014/main" id="{9C15B6C7-0EC5-58BA-7129-9ED3B013C193}"/>
+              </a:ext>
+            </a:extLst>
+          </p:cNvPr>
+          <p:cNvSpPr/>
+          <p:nvPr/>
+        </p:nvSpPr>
+        <p:spPr>
+          <a:xfrm>
+            <a:off x="939797" y="4707481"/>
+            <a:ext cx="1883228" cy="440268"/>
+          </a:xfrm>
+          <a:prstGeom prst="rect">
+            <a:avLst/>
+          </a:prstGeom>
+          <a:noFill/>
+          <a:ln w="38100">
+            <a:solidFill>
+              <a:schemeClr val="accent1"/>
+            </a:solidFill>
+          </a:ln>
+        </p:spPr>
+        <p:style>
+          <a:lnRef idx="2">
+            <a:schemeClr val="accent1">
+              <a:shade val="15000"/>
+            </a:schemeClr>
+          </a:lnRef>
+          <a:fillRef idx="1">
+            <a:schemeClr val="accent1"/>
+          </a:fillRef>
+          <a:effectRef idx="0">
+            <a:schemeClr val="accent1"/>
+          </a:effectRef>
+          <a:fontRef idx="minor">
+            <a:schemeClr val="lt1"/>
+          </a:fontRef>
+        </p:style>
+        <p:txBody>
+          <a:bodyPr rtlCol="0" anchor="ctr"/>
+          <a:lstStyle/>
+          <a:p>
+            <a:pPr algn="ctr"/>
+            <a:endParaRPr lang="de-DE"/>
+          </a:p>
+        </p:txBody>
+      </p:sp>
+      <p:cxnSp>
+        <p:nvCxnSpPr>
+          <p:cNvPr id="21" name="Verbinder: gewinkelt 14">
+            <a:extLst>
+              <a:ext uri="{FF2B5EF4-FFF2-40B4-BE49-F238E27FC236}">
+                <a16:creationId xmlns:a16="http://schemas.microsoft.com/office/drawing/2014/main" id="{B822ECD4-D887-FD4E-78F7-80ECE03535E2}"/>
+              </a:ext>
+            </a:extLst>
+          </p:cNvPr>
+          <p:cNvCxnSpPr>
+            <a:cxnSpLocks/>
+          </p:cNvCxnSpPr>
+          <p:nvPr/>
+        </p:nvCxnSpPr>
+        <p:spPr>
+          <a:xfrm>
+            <a:off x="1881248" y="3063834"/>
+            <a:ext cx="2968" cy="548904"/>
+          </a:xfrm>
+          <a:prstGeom prst="bentConnector3">
+            <a:avLst/>
+          </a:prstGeom>
+          <a:ln>
+            <a:tailEnd type="triangle"/>
+          </a:ln>
+        </p:spPr>
+        <p:style>
+          <a:lnRef idx="1">
+            <a:schemeClr val="dk1"/>
+          </a:lnRef>
+          <a:fillRef idx="0">
+            <a:schemeClr val="dk1"/>
+          </a:fillRef>
+          <a:effectRef idx="0">
+            <a:schemeClr val="dk1"/>
+          </a:effectRef>
+          <a:fontRef idx="minor">
+            <a:schemeClr val="tx1"/>
+          </a:fontRef>
+        </p:style>
+      </p:cxnSp>
+      <p:cxnSp>
+        <p:nvCxnSpPr>
+          <p:cNvPr id="22" name="Verbinder: gewinkelt 14">
+            <a:extLst>
+              <a:ext uri="{FF2B5EF4-FFF2-40B4-BE49-F238E27FC236}">
+                <a16:creationId xmlns:a16="http://schemas.microsoft.com/office/drawing/2014/main" id="{A49E6884-DA81-E522-5838-8FDD36325344}"/>
+              </a:ext>
+            </a:extLst>
+          </p:cNvPr>
+          <p:cNvCxnSpPr>
+            <a:cxnSpLocks/>
+          </p:cNvCxnSpPr>
+          <p:nvPr/>
+        </p:nvCxnSpPr>
+        <p:spPr>
+          <a:xfrm>
+            <a:off x="1873990" y="4123376"/>
+            <a:ext cx="2968" cy="548904"/>
+          </a:xfrm>
+          <a:prstGeom prst="bentConnector3">
+            <a:avLst/>
+          </a:prstGeom>
+          <a:ln>
+            <a:tailEnd type="triangle"/>
+          </a:ln>
+        </p:spPr>
+        <p:style>
+          <a:lnRef idx="1">
+            <a:schemeClr val="dk1"/>
+          </a:lnRef>
+          <a:fillRef idx="0">
+            <a:schemeClr val="dk1"/>
+          </a:fillRef>
+          <a:effectRef idx="0">
+            <a:schemeClr val="dk1"/>
+          </a:effectRef>
+          <a:fontRef idx="minor">
+            <a:schemeClr val="tx1"/>
+          </a:fontRef>
+        </p:style>
+      </p:cxnSp>
+      <p:sp>
+        <p:nvSpPr>
+          <p:cNvPr id="24" name="Rechteck 13">
+            <a:extLst>
+              <a:ext uri="{FF2B5EF4-FFF2-40B4-BE49-F238E27FC236}">
+                <a16:creationId xmlns:a16="http://schemas.microsoft.com/office/drawing/2014/main" id="{6B4C3D0B-8671-9870-0155-BCB4F2E4C955}"/>
+              </a:ext>
+            </a:extLst>
+          </p:cNvPr>
+          <p:cNvSpPr/>
+          <p:nvPr/>
+        </p:nvSpPr>
+        <p:spPr>
+          <a:xfrm>
+            <a:off x="373741" y="5679938"/>
+            <a:ext cx="1752600" cy="462039"/>
+          </a:xfrm>
+          <a:prstGeom prst="rect">
+            <a:avLst/>
+          </a:prstGeom>
+          <a:noFill/>
+          <a:ln w="38100">
+            <a:solidFill>
+              <a:schemeClr val="accent1"/>
+            </a:solidFill>
+          </a:ln>
+        </p:spPr>
+        <p:style>
+          <a:lnRef idx="2">
+            <a:schemeClr val="accent1">
+              <a:shade val="15000"/>
+            </a:schemeClr>
+          </a:lnRef>
+          <a:fillRef idx="1">
+            <a:schemeClr val="accent1"/>
+          </a:fillRef>
+          <a:effectRef idx="0">
+            <a:schemeClr val="accent1"/>
+          </a:effectRef>
+          <a:fontRef idx="minor">
+            <a:schemeClr val="lt1"/>
+          </a:fontRef>
+        </p:style>
+        <p:txBody>
+          <a:bodyPr rtlCol="0" anchor="ctr"/>
+          <a:lstStyle/>
+          <a:p>
+            <a:pPr algn="ctr"/>
+            <a:endParaRPr lang="de-DE"/>
+          </a:p>
+        </p:txBody>
+      </p:sp>
+      <p:sp>
+        <p:nvSpPr>
+          <p:cNvPr id="25" name="Rechteck 13">
+            <a:extLst>
+              <a:ext uri="{FF2B5EF4-FFF2-40B4-BE49-F238E27FC236}">
+                <a16:creationId xmlns:a16="http://schemas.microsoft.com/office/drawing/2014/main" id="{92BF46CA-F953-A77B-F497-5C179B5BEB25}"/>
+              </a:ext>
+            </a:extLst>
+          </p:cNvPr>
+          <p:cNvSpPr/>
+          <p:nvPr/>
+        </p:nvSpPr>
+        <p:spPr>
+          <a:xfrm>
+            <a:off x="2870198" y="5679938"/>
+            <a:ext cx="1752600" cy="462039"/>
+          </a:xfrm>
+          <a:prstGeom prst="rect">
+            <a:avLst/>
+          </a:prstGeom>
+          <a:noFill/>
+          <a:ln w="38100">
+            <a:solidFill>
+              <a:schemeClr val="accent1"/>
+            </a:solidFill>
+          </a:ln>
+        </p:spPr>
+        <p:style>
+          <a:lnRef idx="2">
+            <a:schemeClr val="accent1">
+              <a:shade val="15000"/>
+            </a:schemeClr>
+          </a:lnRef>
+          <a:fillRef idx="1">
+            <a:schemeClr val="accent1"/>
+          </a:fillRef>
+          <a:effectRef idx="0">
+            <a:schemeClr val="accent1"/>
+          </a:effectRef>
+          <a:fontRef idx="minor">
+            <a:schemeClr val="lt1"/>
+          </a:fontRef>
+        </p:style>
+        <p:txBody>
+          <a:bodyPr rtlCol="0" anchor="ctr"/>
+          <a:lstStyle/>
+          <a:p>
+            <a:pPr algn="ctr"/>
+            <a:endParaRPr lang="de-DE"/>
+          </a:p>
+        </p:txBody>
+      </p:sp>
+      <p:cxnSp>
+        <p:nvCxnSpPr>
+          <p:cNvPr id="29" name="Straight Arrow Connector 28">
+            <a:extLst>
+              <a:ext uri="{FF2B5EF4-FFF2-40B4-BE49-F238E27FC236}">
+                <a16:creationId xmlns:a16="http://schemas.microsoft.com/office/drawing/2014/main" id="{485C3814-DB70-C604-B766-ED15D50DF305}"/>
+              </a:ext>
+            </a:extLst>
+          </p:cNvPr>
+          <p:cNvCxnSpPr/>
+          <p:nvPr/>
+        </p:nvCxnSpPr>
+        <p:spPr>
+          <a:xfrm>
+            <a:off x="1886197" y="5168075"/>
+            <a:ext cx="1384" cy="270823"/>
+          </a:xfrm>
+          <a:prstGeom prst="straightConnector1">
+            <a:avLst/>
+          </a:prstGeom>
+        </p:spPr>
+        <p:style>
+          <a:lnRef idx="1">
+            <a:schemeClr val="dk1"/>
+          </a:lnRef>
+          <a:fillRef idx="0">
+            <a:schemeClr val="dk1"/>
+          </a:fillRef>
+          <a:effectRef idx="0">
+            <a:schemeClr val="dk1"/>
+          </a:effectRef>
+          <a:fontRef idx="minor">
+            <a:schemeClr val="tx1"/>
+          </a:fontRef>
+        </p:style>
+      </p:cxnSp>
+      <p:cxnSp>
+        <p:nvCxnSpPr>
+          <p:cNvPr id="30" name="Straight Arrow Connector 29">
+            <a:extLst>
+              <a:ext uri="{FF2B5EF4-FFF2-40B4-BE49-F238E27FC236}">
+                <a16:creationId xmlns:a16="http://schemas.microsoft.com/office/drawing/2014/main" id="{80C42D7A-0C16-33E7-AF2A-6CE5BFEC53C0}"/>
+              </a:ext>
+            </a:extLst>
+          </p:cNvPr>
+          <p:cNvCxnSpPr/>
+          <p:nvPr/>
+        </p:nvCxnSpPr>
+        <p:spPr>
+          <a:xfrm>
+            <a:off x="1217221" y="5446815"/>
+            <a:ext cx="2562821" cy="11545"/>
+          </a:xfrm>
+          <a:prstGeom prst="straightConnector1">
+            <a:avLst/>
+          </a:prstGeom>
+        </p:spPr>
+        <p:style>
+          <a:lnRef idx="1">
+            <a:schemeClr val="dk1"/>
+          </a:lnRef>
+          <a:fillRef idx="0">
+            <a:schemeClr val="dk1"/>
+          </a:fillRef>
+          <a:effectRef idx="0">
+            <a:schemeClr val="dk1"/>
+          </a:effectRef>
+          <a:fontRef idx="minor">
+            <a:schemeClr val="tx1"/>
+          </a:fontRef>
+        </p:style>
+      </p:cxnSp>
+      <p:cxnSp>
+        <p:nvCxnSpPr>
+          <p:cNvPr id="31" name="Straight Arrow Connector 30">
+            <a:extLst>
+              <a:ext uri="{FF2B5EF4-FFF2-40B4-BE49-F238E27FC236}">
+                <a16:creationId xmlns:a16="http://schemas.microsoft.com/office/drawing/2014/main" id="{645A3372-D29F-C2AE-2492-6EBE021A50B6}"/>
+              </a:ext>
+            </a:extLst>
+          </p:cNvPr>
+          <p:cNvCxnSpPr/>
+          <p:nvPr/>
+        </p:nvCxnSpPr>
+        <p:spPr>
+          <a:xfrm flipH="1">
+            <a:off x="1218077" y="5449454"/>
+            <a:ext cx="5740" cy="219363"/>
+          </a:xfrm>
+          <a:prstGeom prst="straightConnector1">
+            <a:avLst/>
+          </a:prstGeom>
+          <a:ln>
+            <a:tailEnd type="triangle"/>
+          </a:ln>
+        </p:spPr>
+        <p:style>
+          <a:lnRef idx="1">
+            <a:schemeClr val="dk1"/>
+          </a:lnRef>
+          <a:fillRef idx="0">
+            <a:schemeClr val="dk1"/>
+          </a:fillRef>
+          <a:effectRef idx="0">
+            <a:schemeClr val="dk1"/>
+          </a:effectRef>
+          <a:fontRef idx="minor">
+            <a:schemeClr val="tx1"/>
+          </a:fontRef>
+        </p:style>
+      </p:cxnSp>
+      <p:cxnSp>
+        <p:nvCxnSpPr>
+          <p:cNvPr id="32" name="Straight Arrow Connector 31">
+            <a:extLst>
+              <a:ext uri="{FF2B5EF4-FFF2-40B4-BE49-F238E27FC236}">
+                <a16:creationId xmlns:a16="http://schemas.microsoft.com/office/drawing/2014/main" id="{D3766EFB-9D8C-90A0-32F8-BC082C6AECA2}"/>
+              </a:ext>
+            </a:extLst>
+          </p:cNvPr>
+          <p:cNvCxnSpPr>
+            <a:cxnSpLocks/>
+          </p:cNvCxnSpPr>
+          <p:nvPr/>
+        </p:nvCxnSpPr>
+        <p:spPr>
+          <a:xfrm flipH="1">
+            <a:off x="3772590" y="5449453"/>
+            <a:ext cx="5740" cy="219363"/>
+          </a:xfrm>
+          <a:prstGeom prst="straightConnector1">
+            <a:avLst/>
+          </a:prstGeom>
+          <a:ln>
+            <a:tailEnd type="triangle"/>
+          </a:ln>
+        </p:spPr>
+        <p:style>
+          <a:lnRef idx="1">
+            <a:schemeClr val="dk1"/>
+          </a:lnRef>
+          <a:fillRef idx="0">
+            <a:schemeClr val="dk1"/>
+          </a:fillRef>
+          <a:effectRef idx="0">
+            <a:schemeClr val="dk1"/>
+          </a:effectRef>
+          <a:fontRef idx="minor">
+            <a:schemeClr val="tx1"/>
+          </a:fontRef>
+        </p:style>
+      </p:cxnSp>
+      <p:sp>
+        <p:nvSpPr>
+          <p:cNvPr id="33" name="Rechteck 13">
+            <a:extLst>
+              <a:ext uri="{FF2B5EF4-FFF2-40B4-BE49-F238E27FC236}">
+                <a16:creationId xmlns:a16="http://schemas.microsoft.com/office/drawing/2014/main" id="{C9BA192F-3C47-31E0-2FD2-79EC6AB4DC6B}"/>
+              </a:ext>
+            </a:extLst>
+          </p:cNvPr>
+          <p:cNvSpPr/>
+          <p:nvPr/>
+        </p:nvSpPr>
+        <p:spPr>
+          <a:xfrm>
+            <a:off x="5301342" y="2145711"/>
+            <a:ext cx="5090885" cy="1913468"/>
+          </a:xfrm>
+          <a:prstGeom prst="rect">
+            <a:avLst/>
+          </a:prstGeom>
+          <a:noFill/>
+          <a:ln w="38100">
+            <a:solidFill>
+              <a:schemeClr val="accent1"/>
+            </a:solidFill>
+          </a:ln>
+        </p:spPr>
+        <p:style>
+          <a:lnRef idx="2">
+            <a:schemeClr val="accent1">
+              <a:shade val="15000"/>
+            </a:schemeClr>
+          </a:lnRef>
+          <a:fillRef idx="1">
+            <a:schemeClr val="accent1"/>
+          </a:fillRef>
+          <a:effectRef idx="0">
+            <a:schemeClr val="accent1"/>
+          </a:effectRef>
+          <a:fontRef idx="minor">
+            <a:schemeClr val="lt1"/>
+          </a:fontRef>
+        </p:style>
+        <p:txBody>
+          <a:bodyPr rtlCol="0" anchor="ctr"/>
+          <a:lstStyle/>
+          <a:p>
+            <a:pPr algn="ctr"/>
+            <a:endParaRPr lang="de-DE"/>
+          </a:p>
+        </p:txBody>
+      </p:sp>
+      <p:sp>
+        <p:nvSpPr>
+          <p:cNvPr id="35" name="Textfeld 6">
+            <a:extLst>
+              <a:ext uri="{FF2B5EF4-FFF2-40B4-BE49-F238E27FC236}">
+                <a16:creationId xmlns:a16="http://schemas.microsoft.com/office/drawing/2014/main" id="{B6EFF2CD-FC2E-D778-4611-90F6CF2BD840}"/>
+              </a:ext>
+            </a:extLst>
+          </p:cNvPr>
+          <p:cNvSpPr txBox="1"/>
+          <p:nvPr/>
+        </p:nvSpPr>
+        <p:spPr>
+          <a:xfrm>
+            <a:off x="5488377" y="1906319"/>
+            <a:ext cx="2074225" cy="461665"/>
+          </a:xfrm>
+          <a:prstGeom prst="rect">
+            <a:avLst/>
+          </a:prstGeom>
+          <a:solidFill>
+            <a:schemeClr val="bg1"/>
+          </a:solidFill>
+        </p:spPr>
+        <p:txBody>
+          <a:bodyPr rot="0" spcFirstLastPara="0" vertOverflow="overflow" horzOverflow="overflow" vert="horz" wrap="square" lIns="91440" tIns="45720" rIns="91440" bIns="45720" numCol="1" spcCol="0" rtlCol="0" fromWordArt="0" anchor="t" anchorCtr="0" forceAA="0" compatLnSpc="1">
+            <a:prstTxWarp prst="textNoShape">
+              <a:avLst/>
+            </a:prstTxWarp>
+            <a:spAutoFit/>
+          </a:bodyPr>
+          <a:lstStyle/>
+          <a:p>
+            <a:r>
+              <a:rPr lang="de-DE" sz="2400" b="1"/>
+              <a:t>Konfiguration</a:t>
+            </a:r>
+            <a:endParaRPr lang="en-US"/>
           </a:p>
         </p:txBody>
       </p:sp>
@@ -6299,7 +8171,7 @@
 </p:sld>
 </file>
 
-<file path=ppt/slides/slide14.xml><?xml version="1.0" encoding="utf-8"?>
+<file path=ppt/slides/slide15.xml><?xml version="1.0" encoding="utf-8"?>
 <p:sld xmlns:a="http://schemas.openxmlformats.org/drawingml/2006/main" xmlns:r="http://schemas.openxmlformats.org/officeDocument/2006/relationships" xmlns:p="http://schemas.openxmlformats.org/presentationml/2006/main">
   <p:cSld>
     <p:spTree>
@@ -6569,7 +8441,7 @@
           <a:p>
             <a:fld id="{6C43980B-2C02-594B-9C73-A951FE425682}" type="slidenum">
               <a:rPr lang="de-DE" smtClean="0"/>
-              <a:t>14</a:t>
+              <a:t>15</a:t>
             </a:fld>
             <a:endParaRPr lang="de-DE" dirty="0"/>
           </a:p>
@@ -6588,7 +8460,7 @@
 </p:sld>
 </file>
 
-<file path=ppt/slides/slide15.xml><?xml version="1.0" encoding="utf-8"?>
+<file path=ppt/slides/slide16.xml><?xml version="1.0" encoding="utf-8"?>
 <p:sld xmlns:a="http://schemas.openxmlformats.org/drawingml/2006/main" xmlns:r="http://schemas.openxmlformats.org/officeDocument/2006/relationships" xmlns:p="http://schemas.openxmlformats.org/presentationml/2006/main">
   <p:cSld>
     <p:spTree>
@@ -6747,7 +8619,7 @@
 </p:sld>
 </file>
 
-<file path=ppt/slides/slide16.xml><?xml version="1.0" encoding="utf-8"?>
+<file path=ppt/slides/slide17.xml><?xml version="1.0" encoding="utf-8"?>
 <p:sld xmlns:a="http://schemas.openxmlformats.org/drawingml/2006/main" xmlns:r="http://schemas.openxmlformats.org/officeDocument/2006/relationships" xmlns:p="http://schemas.openxmlformats.org/presentationml/2006/main">
   <p:cSld>
     <p:spTree>
@@ -6840,7 +8712,7 @@
           <a:p>
             <a:fld id="{6C43980B-2C02-594B-9C73-A951FE425682}" type="slidenum">
               <a:rPr lang="de-DE" smtClean="0"/>
-              <a:t>16</a:t>
+              <a:t>17</a:t>
             </a:fld>
             <a:endParaRPr lang="de-DE" dirty="0"/>
           </a:p>
@@ -6859,7 +8731,7 @@
 </p:sld>
 </file>
 
-<file path=ppt/slides/slide17.xml><?xml version="1.0" encoding="utf-8"?>
+<file path=ppt/slides/slide18.xml><?xml version="1.0" encoding="utf-8"?>
 <p:sld xmlns:a="http://schemas.openxmlformats.org/drawingml/2006/main" xmlns:r="http://schemas.openxmlformats.org/officeDocument/2006/relationships" xmlns:p="http://schemas.openxmlformats.org/presentationml/2006/main">
   <p:cSld>
     <p:spTree>
@@ -6962,7 +8834,7 @@
           <a:p>
             <a:fld id="{6C43980B-2C02-594B-9C73-A951FE425682}" type="slidenum">
               <a:rPr lang="de-DE" smtClean="0"/>
-              <a:t>17</a:t>
+              <a:t>18</a:t>
             </a:fld>
             <a:endParaRPr lang="de-DE" dirty="0"/>
           </a:p>
@@ -6981,7 +8853,7 @@
 </p:sld>
 </file>
 
-<file path=ppt/slides/slide18.xml><?xml version="1.0" encoding="utf-8"?>
+<file path=ppt/slides/slide19.xml><?xml version="1.0" encoding="utf-8"?>
 <p:sld xmlns:a="http://schemas.openxmlformats.org/drawingml/2006/main" xmlns:r="http://schemas.openxmlformats.org/officeDocument/2006/relationships" xmlns:p="http://schemas.openxmlformats.org/presentationml/2006/main">
   <p:cSld>
     <p:spTree>
@@ -7084,7 +8956,7 @@
           <a:p>
             <a:fld id="{6C43980B-2C02-594B-9C73-A951FE425682}" type="slidenum">
               <a:rPr lang="de-DE" smtClean="0"/>
-              <a:t>18</a:t>
+              <a:t>19</a:t>
             </a:fld>
             <a:endParaRPr lang="de-DE" dirty="0"/>
           </a:p>
@@ -7103,7 +8975,123 @@
 </p:sld>
 </file>
 
-<file path=ppt/slides/slide19.xml><?xml version="1.0" encoding="utf-8"?>
+<file path=ppt/slides/slide2.xml><?xml version="1.0" encoding="utf-8"?>
+<p:sld xmlns:a="http://schemas.openxmlformats.org/drawingml/2006/main" xmlns:r="http://schemas.openxmlformats.org/officeDocument/2006/relationships" xmlns:p="http://schemas.openxmlformats.org/presentationml/2006/main">
+  <p:cSld>
+    <p:spTree>
+      <p:nvGrpSpPr>
+        <p:cNvPr id="1" name=""/>
+        <p:cNvGrpSpPr/>
+        <p:nvPr/>
+      </p:nvGrpSpPr>
+      <p:grpSpPr>
+        <a:xfrm>
+          <a:off x="0" y="0"/>
+          <a:ext cx="0" cy="0"/>
+          <a:chOff x="0" y="0"/>
+          <a:chExt cx="0" cy="0"/>
+        </a:xfrm>
+      </p:grpSpPr>
+      <p:sp>
+        <p:nvSpPr>
+          <p:cNvPr id="2" name="Titel 1">
+            <a:extLst>
+              <a:ext uri="{FF2B5EF4-FFF2-40B4-BE49-F238E27FC236}">
+                <a16:creationId xmlns:a16="http://schemas.microsoft.com/office/drawing/2014/main" id="{72DF80EC-CD95-0B1A-565E-9E71C35046D6}"/>
+              </a:ext>
+            </a:extLst>
+          </p:cNvPr>
+          <p:cNvSpPr>
+            <a:spLocks noGrp="1"/>
+          </p:cNvSpPr>
+          <p:nvPr>
+            <p:ph type="title"/>
+          </p:nvPr>
+        </p:nvSpPr>
+        <p:spPr/>
+        <p:txBody>
+          <a:bodyPr/>
+          <a:lstStyle/>
+          <a:p>
+            <a:r>
+              <a:rPr lang="de-DE"/>
+              <a:t>Systemüberblick</a:t>
+            </a:r>
+          </a:p>
+        </p:txBody>
+      </p:sp>
+      <p:pic>
+        <p:nvPicPr>
+          <p:cNvPr id="5" name="Grafik 4">
+            <a:extLst>
+              <a:ext uri="{FF2B5EF4-FFF2-40B4-BE49-F238E27FC236}">
+                <a16:creationId xmlns:a16="http://schemas.microsoft.com/office/drawing/2014/main" id="{033EC115-1820-E513-0021-FAF480BA97C9}"/>
+              </a:ext>
+            </a:extLst>
+          </p:cNvPr>
+          <p:cNvPicPr>
+            <a:picLocks noChangeAspect="1"/>
+          </p:cNvPicPr>
+          <p:nvPr/>
+        </p:nvPicPr>
+        <p:blipFill>
+          <a:blip r:embed="rId3"/>
+          <a:srcRect/>
+          <a:stretch/>
+        </p:blipFill>
+        <p:spPr>
+          <a:xfrm>
+            <a:off x="1747533" y="1485074"/>
+            <a:ext cx="8696933" cy="5007801"/>
+          </a:xfrm>
+          <a:prstGeom prst="rect">
+            <a:avLst/>
+          </a:prstGeom>
+        </p:spPr>
+      </p:pic>
+      <p:sp>
+        <p:nvSpPr>
+          <p:cNvPr id="4" name="Foliennummernplatzhalter 3">
+            <a:extLst>
+              <a:ext uri="{FF2B5EF4-FFF2-40B4-BE49-F238E27FC236}">
+                <a16:creationId xmlns:a16="http://schemas.microsoft.com/office/drawing/2014/main" id="{53405529-831B-213E-5F34-8F66C31A035B}"/>
+              </a:ext>
+            </a:extLst>
+          </p:cNvPr>
+          <p:cNvSpPr>
+            <a:spLocks noGrp="1"/>
+          </p:cNvSpPr>
+          <p:nvPr>
+            <p:ph type="sldNum" sz="quarter" idx="12"/>
+          </p:nvPr>
+        </p:nvSpPr>
+        <p:spPr/>
+        <p:txBody>
+          <a:bodyPr/>
+          <a:lstStyle/>
+          <a:p>
+            <a:fld id="{6C43980B-2C02-594B-9C73-A951FE425682}" type="slidenum">
+              <a:rPr lang="de-DE" smtClean="0"/>
+              <a:t>2</a:t>
+            </a:fld>
+            <a:endParaRPr lang="de-DE" dirty="0"/>
+          </a:p>
+        </p:txBody>
+      </p:sp>
+    </p:spTree>
+    <p:extLst>
+      <p:ext uri="{BB962C8B-B14F-4D97-AF65-F5344CB8AC3E}">
+        <p14:creationId xmlns:p14="http://schemas.microsoft.com/office/powerpoint/2010/main" val="3010708104"/>
+      </p:ext>
+    </p:extLst>
+  </p:cSld>
+  <p:clrMapOvr>
+    <a:masterClrMapping/>
+  </p:clrMapOvr>
+</p:sld>
+</file>
+
+<file path=ppt/slides/slide20.xml><?xml version="1.0" encoding="utf-8"?>
 <p:sld xmlns:a="http://schemas.openxmlformats.org/drawingml/2006/main" xmlns:r="http://schemas.openxmlformats.org/officeDocument/2006/relationships" xmlns:p="http://schemas.openxmlformats.org/presentationml/2006/main">
   <p:cSld>
     <p:spTree>
@@ -7764,7 +9752,7 @@
           <a:p>
             <a:fld id="{6C43980B-2C02-594B-9C73-A951FE425682}" type="slidenum">
               <a:rPr lang="de-DE" smtClean="0"/>
-              <a:t>19</a:t>
+              <a:t>20</a:t>
             </a:fld>
             <a:endParaRPr lang="de-DE" dirty="0"/>
           </a:p>
@@ -7783,123 +9771,7 @@
 </p:sld>
 </file>
 
-<file path=ppt/slides/slide2.xml><?xml version="1.0" encoding="utf-8"?>
-<p:sld xmlns:a="http://schemas.openxmlformats.org/drawingml/2006/main" xmlns:r="http://schemas.openxmlformats.org/officeDocument/2006/relationships" xmlns:p="http://schemas.openxmlformats.org/presentationml/2006/main">
-  <p:cSld>
-    <p:spTree>
-      <p:nvGrpSpPr>
-        <p:cNvPr id="1" name=""/>
-        <p:cNvGrpSpPr/>
-        <p:nvPr/>
-      </p:nvGrpSpPr>
-      <p:grpSpPr>
-        <a:xfrm>
-          <a:off x="0" y="0"/>
-          <a:ext cx="0" cy="0"/>
-          <a:chOff x="0" y="0"/>
-          <a:chExt cx="0" cy="0"/>
-        </a:xfrm>
-      </p:grpSpPr>
-      <p:sp>
-        <p:nvSpPr>
-          <p:cNvPr id="2" name="Titel 1">
-            <a:extLst>
-              <a:ext uri="{FF2B5EF4-FFF2-40B4-BE49-F238E27FC236}">
-                <a16:creationId xmlns:a16="http://schemas.microsoft.com/office/drawing/2014/main" id="{72DF80EC-CD95-0B1A-565E-9E71C35046D6}"/>
-              </a:ext>
-            </a:extLst>
-          </p:cNvPr>
-          <p:cNvSpPr>
-            <a:spLocks noGrp="1"/>
-          </p:cNvSpPr>
-          <p:nvPr>
-            <p:ph type="title"/>
-          </p:nvPr>
-        </p:nvSpPr>
-        <p:spPr/>
-        <p:txBody>
-          <a:bodyPr/>
-          <a:lstStyle/>
-          <a:p>
-            <a:r>
-              <a:rPr lang="de-DE"/>
-              <a:t>Systemüberblick</a:t>
-            </a:r>
-          </a:p>
-        </p:txBody>
-      </p:sp>
-      <p:pic>
-        <p:nvPicPr>
-          <p:cNvPr id="5" name="Grafik 4">
-            <a:extLst>
-              <a:ext uri="{FF2B5EF4-FFF2-40B4-BE49-F238E27FC236}">
-                <a16:creationId xmlns:a16="http://schemas.microsoft.com/office/drawing/2014/main" id="{033EC115-1820-E513-0021-FAF480BA97C9}"/>
-              </a:ext>
-            </a:extLst>
-          </p:cNvPr>
-          <p:cNvPicPr>
-            <a:picLocks noChangeAspect="1"/>
-          </p:cNvPicPr>
-          <p:nvPr/>
-        </p:nvPicPr>
-        <p:blipFill>
-          <a:blip r:embed="rId3"/>
-          <a:srcRect/>
-          <a:stretch/>
-        </p:blipFill>
-        <p:spPr>
-          <a:xfrm>
-            <a:off x="1747533" y="1485074"/>
-            <a:ext cx="8696933" cy="5007801"/>
-          </a:xfrm>
-          <a:prstGeom prst="rect">
-            <a:avLst/>
-          </a:prstGeom>
-        </p:spPr>
-      </p:pic>
-      <p:sp>
-        <p:nvSpPr>
-          <p:cNvPr id="4" name="Foliennummernplatzhalter 3">
-            <a:extLst>
-              <a:ext uri="{FF2B5EF4-FFF2-40B4-BE49-F238E27FC236}">
-                <a16:creationId xmlns:a16="http://schemas.microsoft.com/office/drawing/2014/main" id="{53405529-831B-213E-5F34-8F66C31A035B}"/>
-              </a:ext>
-            </a:extLst>
-          </p:cNvPr>
-          <p:cNvSpPr>
-            <a:spLocks noGrp="1"/>
-          </p:cNvSpPr>
-          <p:nvPr>
-            <p:ph type="sldNum" sz="quarter" idx="12"/>
-          </p:nvPr>
-        </p:nvSpPr>
-        <p:spPr/>
-        <p:txBody>
-          <a:bodyPr/>
-          <a:lstStyle/>
-          <a:p>
-            <a:fld id="{6C43980B-2C02-594B-9C73-A951FE425682}" type="slidenum">
-              <a:rPr lang="de-DE" smtClean="0"/>
-              <a:t>2</a:t>
-            </a:fld>
-            <a:endParaRPr lang="de-DE" dirty="0"/>
-          </a:p>
-        </p:txBody>
-      </p:sp>
-    </p:spTree>
-    <p:extLst>
-      <p:ext uri="{BB962C8B-B14F-4D97-AF65-F5344CB8AC3E}">
-        <p14:creationId xmlns:p14="http://schemas.microsoft.com/office/powerpoint/2010/main" val="3010708104"/>
-      </p:ext>
-    </p:extLst>
-  </p:cSld>
-  <p:clrMapOvr>
-    <a:masterClrMapping/>
-  </p:clrMapOvr>
-</p:sld>
-</file>
-
-<file path=ppt/slides/slide20.xml><?xml version="1.0" encoding="utf-8"?>
+<file path=ppt/slides/slide21.xml><?xml version="1.0" encoding="utf-8"?>
 <p:sld xmlns:a="http://schemas.openxmlformats.org/drawingml/2006/main" xmlns:r="http://schemas.openxmlformats.org/officeDocument/2006/relationships" xmlns:p="http://schemas.openxmlformats.org/presentationml/2006/main">
   <p:cSld>
     <p:spTree>
@@ -8049,7 +9921,7 @@
           <a:p>
             <a:fld id="{6C43980B-2C02-594B-9C73-A951FE425682}" type="slidenum">
               <a:rPr lang="de-DE" smtClean="0"/>
-              <a:t>20</a:t>
+              <a:t>21</a:t>
             </a:fld>
             <a:endParaRPr lang="de-DE" dirty="0"/>
           </a:p>
@@ -8101,7 +9973,7 @@
 </p:sld>
 </file>
 
-<file path=ppt/slides/slide21.xml><?xml version="1.0" encoding="utf-8"?>
+<file path=ppt/slides/slide22.xml><?xml version="1.0" encoding="utf-8"?>
 <p:sld xmlns:a="http://schemas.openxmlformats.org/drawingml/2006/main" xmlns:r="http://schemas.openxmlformats.org/officeDocument/2006/relationships" xmlns:p="http://schemas.openxmlformats.org/presentationml/2006/main">
   <p:cSld>
     <p:spTree>
@@ -8204,7 +10076,7 @@
           <a:p>
             <a:fld id="{6C43980B-2C02-594B-9C73-A951FE425682}" type="slidenum">
               <a:rPr lang="de-DE" smtClean="0"/>
-              <a:t>21</a:t>
+              <a:t>22</a:t>
             </a:fld>
             <a:endParaRPr lang="de-DE" dirty="0"/>
           </a:p>
@@ -8223,7 +10095,7 @@
 </p:sld>
 </file>
 
-<file path=ppt/slides/slide22.xml><?xml version="1.0" encoding="utf-8"?>
+<file path=ppt/slides/slide23.xml><?xml version="1.0" encoding="utf-8"?>
 <p:sld xmlns:a="http://schemas.openxmlformats.org/drawingml/2006/main" xmlns:r="http://schemas.openxmlformats.org/officeDocument/2006/relationships" xmlns:p="http://schemas.openxmlformats.org/presentationml/2006/main">
   <p:cSld>
     <p:spTree>
@@ -10388,7 +12260,7 @@
           <a:p>
             <a:fld id="{6C43980B-2C02-594B-9C73-A951FE425682}" type="slidenum">
               <a:rPr lang="de-DE" smtClean="0"/>
-              <a:t>22</a:t>
+              <a:t>23</a:t>
             </a:fld>
             <a:endParaRPr lang="de-DE" dirty="0"/>
           </a:p>
@@ -10407,7 +12279,7 @@
 </p:sld>
 </file>
 
-<file path=ppt/slides/slide23.xml><?xml version="1.0" encoding="utf-8"?>
+<file path=ppt/slides/slide24.xml><?xml version="1.0" encoding="utf-8"?>
 <p:sld xmlns:a="http://schemas.openxmlformats.org/drawingml/2006/main" xmlns:r="http://schemas.openxmlformats.org/officeDocument/2006/relationships" xmlns:p="http://schemas.openxmlformats.org/presentationml/2006/main">
   <p:cSld>
     <p:spTree>
@@ -12996,7 +14868,7 @@
           <a:p>
             <a:fld id="{6C43980B-2C02-594B-9C73-A951FE425682}" type="slidenum">
               <a:rPr lang="de-DE" smtClean="0"/>
-              <a:t>23</a:t>
+              <a:t>24</a:t>
             </a:fld>
             <a:endParaRPr lang="de-DE" dirty="0"/>
           </a:p>
@@ -13015,7 +14887,7 @@
 </p:sld>
 </file>
 
-<file path=ppt/slides/slide24.xml><?xml version="1.0" encoding="utf-8"?>
+<file path=ppt/slides/slide25.xml><?xml version="1.0" encoding="utf-8"?>
 <p:sld xmlns:a="http://schemas.openxmlformats.org/drawingml/2006/main" xmlns:r="http://schemas.openxmlformats.org/officeDocument/2006/relationships" xmlns:p="http://schemas.openxmlformats.org/presentationml/2006/main">
   <p:cSld>
     <p:spTree>
@@ -16289,7 +18161,7 @@
           <a:p>
             <a:fld id="{6C43980B-2C02-594B-9C73-A951FE425682}" type="slidenum">
               <a:rPr lang="de-DE" smtClean="0"/>
-              <a:t>24</a:t>
+              <a:t>25</a:t>
             </a:fld>
             <a:endParaRPr lang="de-DE" dirty="0"/>
           </a:p>
@@ -16341,7 +18213,7 @@
 </p:sld>
 </file>
 
-<file path=ppt/slides/slide25.xml><?xml version="1.0" encoding="utf-8"?>
+<file path=ppt/slides/slide26.xml><?xml version="1.0" encoding="utf-8"?>
 <p:sld xmlns:a="http://schemas.openxmlformats.org/drawingml/2006/main" xmlns:r="http://schemas.openxmlformats.org/officeDocument/2006/relationships" xmlns:p="http://schemas.openxmlformats.org/presentationml/2006/main">
   <p:cSld>
     <p:spTree>
@@ -20491,7 +22363,7 @@
           <a:p>
             <a:fld id="{6C43980B-2C02-594B-9C73-A951FE425682}" type="slidenum">
               <a:rPr lang="de-DE" smtClean="0"/>
-              <a:t>25</a:t>
+              <a:t>26</a:t>
             </a:fld>
             <a:endParaRPr lang="de-DE" dirty="0"/>
           </a:p>
@@ -20510,7 +22382,7 @@
 </p:sld>
 </file>
 
-<file path=ppt/slides/slide26.xml><?xml version="1.0" encoding="utf-8"?>
+<file path=ppt/slides/slide27.xml><?xml version="1.0" encoding="utf-8"?>
 <p:sld xmlns:a="http://schemas.openxmlformats.org/drawingml/2006/main" xmlns:r="http://schemas.openxmlformats.org/officeDocument/2006/relationships" xmlns:p="http://schemas.openxmlformats.org/presentationml/2006/main">
   <p:cSld>
     <p:spTree>
@@ -20613,7 +22485,7 @@
           <a:p>
             <a:fld id="{6C43980B-2C02-594B-9C73-A951FE425682}" type="slidenum">
               <a:rPr lang="de-DE" smtClean="0"/>
-              <a:t>26</a:t>
+              <a:t>27</a:t>
             </a:fld>
             <a:endParaRPr lang="de-DE" dirty="0"/>
           </a:p>
@@ -20632,7 +22504,7 @@
 </p:sld>
 </file>
 
-<file path=ppt/slides/slide27.xml><?xml version="1.0" encoding="utf-8"?>
+<file path=ppt/slides/slide28.xml><?xml version="1.0" encoding="utf-8"?>
 <p:sld xmlns:a="http://schemas.openxmlformats.org/drawingml/2006/main" xmlns:r="http://schemas.openxmlformats.org/officeDocument/2006/relationships" xmlns:p="http://schemas.openxmlformats.org/presentationml/2006/main">
   <p:cSld>
     <p:spTree>
@@ -22016,7 +23888,7 @@
           <a:p>
             <a:fld id="{6C43980B-2C02-594B-9C73-A951FE425682}" type="slidenum">
               <a:rPr lang="de-DE" smtClean="0"/>
-              <a:t>27</a:t>
+              <a:t>28</a:t>
             </a:fld>
             <a:endParaRPr lang="de-DE" dirty="0"/>
           </a:p>
@@ -22208,8 +24080,8 @@
           </a:p>
         </p:txBody>
       </p:sp>
-      <mc:AlternateContent xmlns:mc="http://schemas.openxmlformats.org/markup-compatibility/2006">
-        <mc:Choice xmlns:a14="http://schemas.microsoft.com/office/drawing/2010/main" Requires="a14">
+      <mc:AlternateContent xmlns:mc="http://schemas.openxmlformats.org/markup-compatibility/2006" xmlns:a14="http://schemas.microsoft.com/office/drawing/2010/main">
+        <mc:Choice Requires="a14">
           <p:sp>
             <p:nvSpPr>
               <p:cNvPr id="3" name="Inhaltsplatzhalter 2">
@@ -22516,7 +24388,7 @@
             </p:txBody>
           </p:sp>
         </mc:Choice>
-        <mc:Fallback>
+        <mc:Fallback xmlns="">
           <p:sp>
             <p:nvSpPr>
               <p:cNvPr id="3" name="Inhaltsplatzhalter 2">

</xml_diff>

<commit_message>
Removed duplicated backup slide
</commit_message>
<xml_diff>
--- a/docs/Endpraesentation/DAPI_FractalCore_Endpraesentation.pptx
+++ b/docs/Endpraesentation/DAPI_FractalCore_Endpraesentation.pptx
@@ -5,7 +5,7 @@
     <p:sldMasterId id="2147483648" r:id="rId1"/>
   </p:sldMasterIdLst>
   <p:notesMasterIdLst>
-    <p:notesMasterId r:id="rId30"/>
+    <p:notesMasterId r:id="rId29"/>
   </p:notesMasterIdLst>
   <p:sldIdLst>
     <p:sldId id="256" r:id="rId2"/>
@@ -25,17 +25,16 @@
     <p:sldId id="281" r:id="rId16"/>
     <p:sldId id="286" r:id="rId17"/>
     <p:sldId id="285" r:id="rId18"/>
-    <p:sldId id="280" r:id="rId19"/>
-    <p:sldId id="282" r:id="rId20"/>
-    <p:sldId id="270" r:id="rId21"/>
-    <p:sldId id="268" r:id="rId22"/>
-    <p:sldId id="283" r:id="rId23"/>
-    <p:sldId id="257" r:id="rId24"/>
-    <p:sldId id="271" r:id="rId25"/>
-    <p:sldId id="265" r:id="rId26"/>
-    <p:sldId id="258" r:id="rId27"/>
-    <p:sldId id="284" r:id="rId28"/>
-    <p:sldId id="273" r:id="rId29"/>
+    <p:sldId id="282" r:id="rId19"/>
+    <p:sldId id="270" r:id="rId20"/>
+    <p:sldId id="268" r:id="rId21"/>
+    <p:sldId id="283" r:id="rId22"/>
+    <p:sldId id="257" r:id="rId23"/>
+    <p:sldId id="271" r:id="rId24"/>
+    <p:sldId id="265" r:id="rId25"/>
+    <p:sldId id="258" r:id="rId26"/>
+    <p:sldId id="284" r:id="rId27"/>
+    <p:sldId id="273" r:id="rId28"/>
   </p:sldIdLst>
   <p:sldSz cx="12192000" cy="6858000"/>
   <p:notesSz cx="6858000" cy="9144000"/>
@@ -234,7 +233,7 @@
           <a:p>
             <a:fld id="{25690DA4-8E7E-0941-AA18-ABC55D37EF0E}" type="datetimeFigureOut">
               <a:rPr lang="de-DE" smtClean="0"/>
-              <a:t>23.06.2026</a:t>
+              <a:t>23.06.26</a:t>
             </a:fld>
             <a:endParaRPr lang="de-DE"/>
           </a:p>
@@ -392,7 +391,7 @@
           <a:p>
             <a:fld id="{BA036D80-E674-C74A-9C41-C7D9BE4A5ABE}" type="slidenum">
               <a:rPr lang="de-DE" smtClean="0"/>
-              <a:t>‹#›</a:t>
+              <a:t>‹Nr.›</a:t>
             </a:fld>
             <a:endParaRPr lang="de-DE"/>
           </a:p>
@@ -545,7 +544,10 @@
           <a:bodyPr/>
           <a:lstStyle/>
           <a:p>
-            <a:endParaRPr lang="de-DE" dirty="0"/>
+            <a:r>
+              <a:rPr lang="de-DE" dirty="0"/>
+              <a:t>Vielleicht kennen Sie dieses Bild….</a:t>
+            </a:r>
           </a:p>
         </p:txBody>
       </p:sp>
@@ -926,117 +928,6 @@
         <p:cNvPr id="1" name="">
           <a:extLst>
             <a:ext uri="{FF2B5EF4-FFF2-40B4-BE49-F238E27FC236}">
-              <a16:creationId xmlns:a16="http://schemas.microsoft.com/office/drawing/2014/main" id="{22BBB2B2-F221-7669-5B48-35869E18781E}"/>
-            </a:ext>
-          </a:extLst>
-        </p:cNvPr>
-        <p:cNvGrpSpPr/>
-        <p:nvPr/>
-      </p:nvGrpSpPr>
-      <p:grpSpPr>
-        <a:xfrm>
-          <a:off x="0" y="0"/>
-          <a:ext cx="0" cy="0"/>
-          <a:chOff x="0" y="0"/>
-          <a:chExt cx="0" cy="0"/>
-        </a:xfrm>
-      </p:grpSpPr>
-      <p:sp>
-        <p:nvSpPr>
-          <p:cNvPr id="2" name="Folienbildplatzhalter 1">
-            <a:extLst>
-              <a:ext uri="{FF2B5EF4-FFF2-40B4-BE49-F238E27FC236}">
-                <a16:creationId xmlns:a16="http://schemas.microsoft.com/office/drawing/2014/main" id="{A3EEB85D-612D-D8B7-C592-08FA2D629950}"/>
-              </a:ext>
-            </a:extLst>
-          </p:cNvPr>
-          <p:cNvSpPr>
-            <a:spLocks noGrp="1" noRot="1" noChangeAspect="1"/>
-          </p:cNvSpPr>
-          <p:nvPr>
-            <p:ph type="sldImg"/>
-          </p:nvPr>
-        </p:nvSpPr>
-        <p:spPr/>
-      </p:sp>
-      <p:sp>
-        <p:nvSpPr>
-          <p:cNvPr id="3" name="Notizenplatzhalter 2">
-            <a:extLst>
-              <a:ext uri="{FF2B5EF4-FFF2-40B4-BE49-F238E27FC236}">
-                <a16:creationId xmlns:a16="http://schemas.microsoft.com/office/drawing/2014/main" id="{4AECDE8D-4B4D-79EF-119E-31138BE1705C}"/>
-              </a:ext>
-            </a:extLst>
-          </p:cNvPr>
-          <p:cNvSpPr>
-            <a:spLocks noGrp="1"/>
-          </p:cNvSpPr>
-          <p:nvPr>
-            <p:ph type="body" idx="1"/>
-          </p:nvPr>
-        </p:nvSpPr>
-        <p:spPr/>
-        <p:txBody>
-          <a:bodyPr/>
-          <a:lstStyle/>
-          <a:p>
-            <a:r>
-              <a:rPr lang="de-DE" dirty="0"/>
-              <a:t>Entspricht der Gliederung</a:t>
-            </a:r>
-          </a:p>
-        </p:txBody>
-      </p:sp>
-      <p:sp>
-        <p:nvSpPr>
-          <p:cNvPr id="4" name="Foliennummernplatzhalter 3">
-            <a:extLst>
-              <a:ext uri="{FF2B5EF4-FFF2-40B4-BE49-F238E27FC236}">
-                <a16:creationId xmlns:a16="http://schemas.microsoft.com/office/drawing/2014/main" id="{7B424F95-8B32-A310-36E3-6E9690EC49FC}"/>
-              </a:ext>
-            </a:extLst>
-          </p:cNvPr>
-          <p:cNvSpPr>
-            <a:spLocks noGrp="1"/>
-          </p:cNvSpPr>
-          <p:nvPr>
-            <p:ph type="sldNum" sz="quarter" idx="5"/>
-          </p:nvPr>
-        </p:nvSpPr>
-        <p:spPr/>
-        <p:txBody>
-          <a:bodyPr/>
-          <a:lstStyle/>
-          <a:p>
-            <a:fld id="{BA036D80-E674-C74A-9C41-C7D9BE4A5ABE}" type="slidenum">
-              <a:rPr lang="de-DE" smtClean="0"/>
-              <a:t>18</a:t>
-            </a:fld>
-            <a:endParaRPr lang="de-DE"/>
-          </a:p>
-        </p:txBody>
-      </p:sp>
-    </p:spTree>
-    <p:extLst>
-      <p:ext uri="{BB962C8B-B14F-4D97-AF65-F5344CB8AC3E}">
-        <p14:creationId xmlns:p14="http://schemas.microsoft.com/office/powerpoint/2010/main" val="768810871"/>
-      </p:ext>
-    </p:extLst>
-  </p:cSld>
-  <p:clrMapOvr>
-    <a:masterClrMapping/>
-  </p:clrMapOvr>
-</p:notes>
-</file>
-
-<file path=ppt/notesSlides/notesSlide14.xml><?xml version="1.0" encoding="utf-8"?>
-<p:notes xmlns:a="http://schemas.openxmlformats.org/drawingml/2006/main" xmlns:r="http://schemas.openxmlformats.org/officeDocument/2006/relationships" xmlns:p="http://schemas.openxmlformats.org/presentationml/2006/main">
-  <p:cSld>
-    <p:spTree>
-      <p:nvGrpSpPr>
-        <p:cNvPr id="1" name="">
-          <a:extLst>
-            <a:ext uri="{FF2B5EF4-FFF2-40B4-BE49-F238E27FC236}">
               <a16:creationId xmlns:a16="http://schemas.microsoft.com/office/drawing/2014/main" id="{9D9D0C18-34E2-87F7-089F-5DDCED3EE0F9}"/>
             </a:ext>
           </a:extLst>
@@ -1121,7 +1012,7 @@
           <a:p>
             <a:fld id="{BA036D80-E674-C74A-9C41-C7D9BE4A5ABE}" type="slidenum">
               <a:rPr lang="de-DE" smtClean="0"/>
-              <a:t>19</a:t>
+              <a:t>18</a:t>
             </a:fld>
             <a:endParaRPr lang="de-DE"/>
           </a:p>
@@ -1140,7 +1031,7 @@
 </p:notes>
 </file>
 
-<file path=ppt/notesSlides/notesSlide15.xml><?xml version="1.0" encoding="utf-8"?>
+<file path=ppt/notesSlides/notesSlide14.xml><?xml version="1.0" encoding="utf-8"?>
 <p:notes xmlns:a="http://schemas.openxmlformats.org/drawingml/2006/main" xmlns:r="http://schemas.openxmlformats.org/officeDocument/2006/relationships" xmlns:p="http://schemas.openxmlformats.org/presentationml/2006/main">
   <p:cSld>
     <p:spTree>
@@ -1215,7 +1106,7 @@
           <a:p>
             <a:fld id="{BA036D80-E674-C74A-9C41-C7D9BE4A5ABE}" type="slidenum">
               <a:rPr lang="de-DE" smtClean="0"/>
-              <a:t>21</a:t>
+              <a:t>20</a:t>
             </a:fld>
             <a:endParaRPr lang="de-DE"/>
           </a:p>
@@ -1234,7 +1125,7 @@
 </p:notes>
 </file>
 
-<file path=ppt/notesSlides/notesSlide16.xml><?xml version="1.0" encoding="utf-8"?>
+<file path=ppt/notesSlides/notesSlide15.xml><?xml version="1.0" encoding="utf-8"?>
 <p:notes xmlns:a="http://schemas.openxmlformats.org/drawingml/2006/main" xmlns:r="http://schemas.openxmlformats.org/officeDocument/2006/relationships" xmlns:p="http://schemas.openxmlformats.org/presentationml/2006/main">
   <p:cSld>
     <p:spTree>
@@ -1326,7 +1217,7 @@
           <a:p>
             <a:fld id="{BA036D80-E674-C74A-9C41-C7D9BE4A5ABE}" type="slidenum">
               <a:rPr lang="de-DE" smtClean="0"/>
-              <a:t>22</a:t>
+              <a:t>21</a:t>
             </a:fld>
             <a:endParaRPr lang="de-DE"/>
           </a:p>
@@ -1345,7 +1236,7 @@
 </p:notes>
 </file>
 
-<file path=ppt/notesSlides/notesSlide17.xml><?xml version="1.0" encoding="utf-8"?>
+<file path=ppt/notesSlides/notesSlide16.xml><?xml version="1.0" encoding="utf-8"?>
 <p:notes xmlns:a="http://schemas.openxmlformats.org/drawingml/2006/main" xmlns:r="http://schemas.openxmlformats.org/officeDocument/2006/relationships" xmlns:p="http://schemas.openxmlformats.org/presentationml/2006/main">
   <p:cSld>
     <p:spTree>
@@ -1410,7 +1301,7 @@
           <a:p>
             <a:fld id="{BA036D80-E674-C74A-9C41-C7D9BE4A5ABE}" type="slidenum">
               <a:rPr lang="de-DE" smtClean="0"/>
-              <a:t>25</a:t>
+              <a:t>24</a:t>
             </a:fld>
             <a:endParaRPr lang="de-DE"/>
           </a:p>
@@ -1429,7 +1320,7 @@
 </p:notes>
 </file>
 
-<file path=ppt/notesSlides/notesSlide18.xml><?xml version="1.0" encoding="utf-8"?>
+<file path=ppt/notesSlides/notesSlide17.xml><?xml version="1.0" encoding="utf-8"?>
 <p:notes xmlns:a="http://schemas.openxmlformats.org/drawingml/2006/main" xmlns:r="http://schemas.openxmlformats.org/officeDocument/2006/relationships" xmlns:p="http://schemas.openxmlformats.org/presentationml/2006/main">
   <p:cSld>
     <p:spTree>
@@ -1521,7 +1412,7 @@
           <a:p>
             <a:fld id="{BA036D80-E674-C74A-9C41-C7D9BE4A5ABE}" type="slidenum">
               <a:rPr lang="de-DE" smtClean="0"/>
-              <a:t>27</a:t>
+              <a:t>26</a:t>
             </a:fld>
             <a:endParaRPr lang="de-DE"/>
           </a:p>
@@ -2446,7 +2337,7 @@
           <a:p>
             <a:fld id="{E6DFA5A1-A813-7B43-85D4-C153DE6EEC5D}" type="datetime1">
               <a:rPr lang="de-DE" smtClean="0"/>
-              <a:t>23.06.2026</a:t>
+              <a:t>23.06.26</a:t>
             </a:fld>
             <a:endParaRPr lang="de-DE"/>
           </a:p>
@@ -2500,7 +2391,7 @@
           <a:p>
             <a:fld id="{6C43980B-2C02-594B-9C73-A951FE425682}" type="slidenum">
               <a:rPr lang="de-DE" smtClean="0"/>
-              <a:t>‹#›</a:t>
+              <a:t>‹Nr.›</a:t>
             </a:fld>
             <a:endParaRPr lang="de-DE"/>
           </a:p>
@@ -2644,7 +2535,7 @@
           <a:p>
             <a:fld id="{85A7F633-92B1-A640-B682-55DDF7097609}" type="datetime1">
               <a:rPr lang="de-DE" smtClean="0"/>
-              <a:t>23.06.2026</a:t>
+              <a:t>23.06.26</a:t>
             </a:fld>
             <a:endParaRPr lang="de-DE"/>
           </a:p>
@@ -2698,7 +2589,7 @@
           <a:p>
             <a:fld id="{6C43980B-2C02-594B-9C73-A951FE425682}" type="slidenum">
               <a:rPr lang="de-DE" smtClean="0"/>
-              <a:t>‹#›</a:t>
+              <a:t>‹Nr.›</a:t>
             </a:fld>
             <a:endParaRPr lang="de-DE"/>
           </a:p>
@@ -2852,7 +2743,7 @@
           <a:p>
             <a:fld id="{6B0DB9B7-7C2A-CA43-A176-0C82CB77F997}" type="datetime1">
               <a:rPr lang="de-DE" smtClean="0"/>
-              <a:t>23.06.2026</a:t>
+              <a:t>23.06.26</a:t>
             </a:fld>
             <a:endParaRPr lang="de-DE"/>
           </a:p>
@@ -2906,7 +2797,7 @@
           <a:p>
             <a:fld id="{6C43980B-2C02-594B-9C73-A951FE425682}" type="slidenum">
               <a:rPr lang="de-DE" smtClean="0"/>
-              <a:t>‹#›</a:t>
+              <a:t>‹Nr.›</a:t>
             </a:fld>
             <a:endParaRPr lang="de-DE"/>
           </a:p>
@@ -3055,7 +2946,7 @@
           <a:p>
             <a:fld id="{04634442-C186-E94E-B304-D4E0857BF857}" type="datetime1">
               <a:rPr lang="de-DE" smtClean="0"/>
-              <a:t>23.06.2026</a:t>
+              <a:t>23.06.26</a:t>
             </a:fld>
             <a:endParaRPr lang="de-DE"/>
           </a:p>
@@ -3119,7 +3010,7 @@
           <a:p>
             <a:fld id="{6C43980B-2C02-594B-9C73-A951FE425682}" type="slidenum">
               <a:rPr lang="de-DE" smtClean="0"/>
-              <a:t>‹#›</a:t>
+              <a:t>‹Nr.›</a:t>
             </a:fld>
             <a:endParaRPr lang="de-DE" dirty="0"/>
           </a:p>
@@ -3340,7 +3231,7 @@
           <a:p>
             <a:fld id="{3ACE65F1-39AD-D942-81CC-A8B185C49E41}" type="datetime1">
               <a:rPr lang="de-DE" smtClean="0"/>
-              <a:t>23.06.2026</a:t>
+              <a:t>23.06.26</a:t>
             </a:fld>
             <a:endParaRPr lang="de-DE"/>
           </a:p>
@@ -3394,7 +3285,7 @@
           <a:p>
             <a:fld id="{6C43980B-2C02-594B-9C73-A951FE425682}" type="slidenum">
               <a:rPr lang="de-DE" smtClean="0"/>
-              <a:t>‹#›</a:t>
+              <a:t>‹Nr.›</a:t>
             </a:fld>
             <a:endParaRPr lang="de-DE"/>
           </a:p>
@@ -3605,7 +3496,7 @@
           <a:p>
             <a:fld id="{15B311CB-D684-6D4F-A48A-21B70AE7BE5E}" type="datetime1">
               <a:rPr lang="de-DE" smtClean="0"/>
-              <a:t>23.06.2026</a:t>
+              <a:t>23.06.26</a:t>
             </a:fld>
             <a:endParaRPr lang="de-DE"/>
           </a:p>
@@ -3659,7 +3550,7 @@
           <a:p>
             <a:fld id="{6C43980B-2C02-594B-9C73-A951FE425682}" type="slidenum">
               <a:rPr lang="de-DE" smtClean="0"/>
-              <a:t>‹#›</a:t>
+              <a:t>‹Nr.›</a:t>
             </a:fld>
             <a:endParaRPr lang="de-DE"/>
           </a:p>
@@ -4017,7 +3908,7 @@
           <a:p>
             <a:fld id="{1F54E48E-21DA-704B-B06E-619E9794DDDC}" type="datetime1">
               <a:rPr lang="de-DE" smtClean="0"/>
-              <a:t>23.06.2026</a:t>
+              <a:t>23.06.26</a:t>
             </a:fld>
             <a:endParaRPr lang="de-DE"/>
           </a:p>
@@ -4071,7 +3962,7 @@
           <a:p>
             <a:fld id="{6C43980B-2C02-594B-9C73-A951FE425682}" type="slidenum">
               <a:rPr lang="de-DE" smtClean="0"/>
-              <a:t>‹#›</a:t>
+              <a:t>‹Nr.›</a:t>
             </a:fld>
             <a:endParaRPr lang="de-DE"/>
           </a:p>
@@ -4158,7 +4049,7 @@
           <a:p>
             <a:fld id="{4DB5E8C2-ED39-FA4A-892C-5D69F297ACBF}" type="datetime1">
               <a:rPr lang="de-DE" smtClean="0"/>
-              <a:t>23.06.2026</a:t>
+              <a:t>23.06.26</a:t>
             </a:fld>
             <a:endParaRPr lang="de-DE"/>
           </a:p>
@@ -4212,7 +4103,7 @@
           <a:p>
             <a:fld id="{6C43980B-2C02-594B-9C73-A951FE425682}" type="slidenum">
               <a:rPr lang="de-DE" smtClean="0"/>
-              <a:t>‹#›</a:t>
+              <a:t>‹Nr.›</a:t>
             </a:fld>
             <a:endParaRPr lang="de-DE"/>
           </a:p>
@@ -4271,7 +4162,7 @@
           <a:p>
             <a:fld id="{ECC4A7F1-D4D8-1545-AA93-BB835A9F7A8B}" type="datetime1">
               <a:rPr lang="de-DE" smtClean="0"/>
-              <a:t>23.06.2026</a:t>
+              <a:t>23.06.26</a:t>
             </a:fld>
             <a:endParaRPr lang="de-DE"/>
           </a:p>
@@ -4325,7 +4216,7 @@
           <a:p>
             <a:fld id="{6C43980B-2C02-594B-9C73-A951FE425682}" type="slidenum">
               <a:rPr lang="de-DE" smtClean="0"/>
-              <a:t>‹#›</a:t>
+              <a:t>‹Nr.›</a:t>
             </a:fld>
             <a:endParaRPr lang="de-DE"/>
           </a:p>
@@ -4582,7 +4473,7 @@
           <a:p>
             <a:fld id="{A04B4EF1-1BB5-A140-8507-2D8B6A510087}" type="datetime1">
               <a:rPr lang="de-DE" smtClean="0"/>
-              <a:t>23.06.2026</a:t>
+              <a:t>23.06.26</a:t>
             </a:fld>
             <a:endParaRPr lang="de-DE"/>
           </a:p>
@@ -4636,7 +4527,7 @@
           <a:p>
             <a:fld id="{6C43980B-2C02-594B-9C73-A951FE425682}" type="slidenum">
               <a:rPr lang="de-DE" smtClean="0"/>
-              <a:t>‹#›</a:t>
+              <a:t>‹Nr.›</a:t>
             </a:fld>
             <a:endParaRPr lang="de-DE"/>
           </a:p>
@@ -4870,7 +4761,7 @@
           <a:p>
             <a:fld id="{C33BA3A3-CA4A-E644-9084-D797594CB804}" type="datetime1">
               <a:rPr lang="de-DE" smtClean="0"/>
-              <a:t>23.06.2026</a:t>
+              <a:t>23.06.26</a:t>
             </a:fld>
             <a:endParaRPr lang="de-DE"/>
           </a:p>
@@ -4924,7 +4815,7 @@
           <a:p>
             <a:fld id="{6C43980B-2C02-594B-9C73-A951FE425682}" type="slidenum">
               <a:rPr lang="de-DE" smtClean="0"/>
-              <a:t>‹#›</a:t>
+              <a:t>‹Nr.›</a:t>
             </a:fld>
             <a:endParaRPr lang="de-DE"/>
           </a:p>
@@ -5111,7 +5002,7 @@
           <a:p>
             <a:fld id="{A7D163E4-7209-8D4B-B12D-5159794EF612}" type="datetime1">
               <a:rPr lang="de-DE" smtClean="0"/>
-              <a:t>23.06.2026</a:t>
+              <a:t>23.06.26</a:t>
             </a:fld>
             <a:endParaRPr lang="de-DE"/>
           </a:p>
@@ -5201,7 +5092,7 @@
           <a:p>
             <a:fld id="{6C43980B-2C02-594B-9C73-A951FE425682}" type="slidenum">
               <a:rPr lang="de-DE" smtClean="0"/>
-              <a:t>‹#›</a:t>
+              <a:t>‹Nr.›</a:t>
             </a:fld>
             <a:endParaRPr lang="de-DE"/>
           </a:p>
@@ -8739,128 +8630,6 @@
         <p:cNvPr id="1" name="">
           <a:extLst>
             <a:ext uri="{FF2B5EF4-FFF2-40B4-BE49-F238E27FC236}">
-              <a16:creationId xmlns:a16="http://schemas.microsoft.com/office/drawing/2014/main" id="{26499C9D-4180-7793-68ED-0A35743B1BED}"/>
-            </a:ext>
-          </a:extLst>
-        </p:cNvPr>
-        <p:cNvGrpSpPr/>
-        <p:nvPr/>
-      </p:nvGrpSpPr>
-      <p:grpSpPr>
-        <a:xfrm>
-          <a:off x="0" y="0"/>
-          <a:ext cx="0" cy="0"/>
-          <a:chOff x="0" y="0"/>
-          <a:chExt cx="0" cy="0"/>
-        </a:xfrm>
-      </p:grpSpPr>
-      <p:sp>
-        <p:nvSpPr>
-          <p:cNvPr id="2" name="Titel 1">
-            <a:extLst>
-              <a:ext uri="{FF2B5EF4-FFF2-40B4-BE49-F238E27FC236}">
-                <a16:creationId xmlns:a16="http://schemas.microsoft.com/office/drawing/2014/main" id="{0454727B-560E-EEFD-64B8-6F3327E30EDB}"/>
-              </a:ext>
-            </a:extLst>
-          </p:cNvPr>
-          <p:cNvSpPr>
-            <a:spLocks noGrp="1"/>
-          </p:cNvSpPr>
-          <p:nvPr>
-            <p:ph type="title"/>
-          </p:nvPr>
-        </p:nvSpPr>
-        <p:spPr/>
-        <p:txBody>
-          <a:bodyPr/>
-          <a:lstStyle/>
-          <a:p>
-            <a:r>
-              <a:rPr lang="de-DE" dirty="0"/>
-              <a:t>Arty A7 vs. Arty Z7</a:t>
-            </a:r>
-          </a:p>
-        </p:txBody>
-      </p:sp>
-      <p:pic>
-        <p:nvPicPr>
-          <p:cNvPr id="5" name="Grafik 4">
-            <a:extLst>
-              <a:ext uri="{FF2B5EF4-FFF2-40B4-BE49-F238E27FC236}">
-                <a16:creationId xmlns:a16="http://schemas.microsoft.com/office/drawing/2014/main" id="{8CF37E60-1E0C-2D5E-A7B2-745001B55E1E}"/>
-              </a:ext>
-            </a:extLst>
-          </p:cNvPr>
-          <p:cNvPicPr>
-            <a:picLocks noChangeAspect="1"/>
-          </p:cNvPicPr>
-          <p:nvPr/>
-        </p:nvPicPr>
-        <p:blipFill>
-          <a:blip r:embed="rId3"/>
-          <a:srcRect/>
-          <a:stretch/>
-        </p:blipFill>
-        <p:spPr>
-          <a:xfrm>
-            <a:off x="1755370" y="1489586"/>
-            <a:ext cx="8681259" cy="4998775"/>
-          </a:xfrm>
-          <a:prstGeom prst="rect">
-            <a:avLst/>
-          </a:prstGeom>
-        </p:spPr>
-      </p:pic>
-      <p:sp>
-        <p:nvSpPr>
-          <p:cNvPr id="4" name="Foliennummernplatzhalter 3">
-            <a:extLst>
-              <a:ext uri="{FF2B5EF4-FFF2-40B4-BE49-F238E27FC236}">
-                <a16:creationId xmlns:a16="http://schemas.microsoft.com/office/drawing/2014/main" id="{AD0DF6EF-19CE-71AE-3430-75A215A3AC09}"/>
-              </a:ext>
-            </a:extLst>
-          </p:cNvPr>
-          <p:cNvSpPr>
-            <a:spLocks noGrp="1"/>
-          </p:cNvSpPr>
-          <p:nvPr>
-            <p:ph type="sldNum" sz="quarter" idx="12"/>
-          </p:nvPr>
-        </p:nvSpPr>
-        <p:spPr/>
-        <p:txBody>
-          <a:bodyPr/>
-          <a:lstStyle/>
-          <a:p>
-            <a:fld id="{6C43980B-2C02-594B-9C73-A951FE425682}" type="slidenum">
-              <a:rPr lang="de-DE" smtClean="0"/>
-              <a:t>18</a:t>
-            </a:fld>
-            <a:endParaRPr lang="de-DE" dirty="0"/>
-          </a:p>
-        </p:txBody>
-      </p:sp>
-    </p:spTree>
-    <p:extLst>
-      <p:ext uri="{BB962C8B-B14F-4D97-AF65-F5344CB8AC3E}">
-        <p14:creationId xmlns:p14="http://schemas.microsoft.com/office/powerpoint/2010/main" val="1160231224"/>
-      </p:ext>
-    </p:extLst>
-  </p:cSld>
-  <p:clrMapOvr>
-    <a:masterClrMapping/>
-  </p:clrMapOvr>
-</p:sld>
-</file>
-
-<file path=ppt/slides/slide19.xml><?xml version="1.0" encoding="utf-8"?>
-<p:sld xmlns:a="http://schemas.openxmlformats.org/drawingml/2006/main" xmlns:r="http://schemas.openxmlformats.org/officeDocument/2006/relationships" xmlns:p="http://schemas.openxmlformats.org/presentationml/2006/main">
-  <p:cSld>
-    <p:spTree>
-      <p:nvGrpSpPr>
-        <p:cNvPr id="1" name="">
-          <a:extLst>
-            <a:ext uri="{FF2B5EF4-FFF2-40B4-BE49-F238E27FC236}">
               <a16:creationId xmlns:a16="http://schemas.microsoft.com/office/drawing/2014/main" id="{87767810-F7BC-50DD-93F3-7CF89A9141E5}"/>
             </a:ext>
           </a:extLst>
@@ -8956,7 +8725,7 @@
           <a:p>
             <a:fld id="{6C43980B-2C02-594B-9C73-A951FE425682}" type="slidenum">
               <a:rPr lang="de-DE" smtClean="0"/>
-              <a:t>19</a:t>
+              <a:t>18</a:t>
             </a:fld>
             <a:endParaRPr lang="de-DE" dirty="0"/>
           </a:p>
@@ -8975,123 +8744,7 @@
 </p:sld>
 </file>
 
-<file path=ppt/slides/slide2.xml><?xml version="1.0" encoding="utf-8"?>
-<p:sld xmlns:a="http://schemas.openxmlformats.org/drawingml/2006/main" xmlns:r="http://schemas.openxmlformats.org/officeDocument/2006/relationships" xmlns:p="http://schemas.openxmlformats.org/presentationml/2006/main">
-  <p:cSld>
-    <p:spTree>
-      <p:nvGrpSpPr>
-        <p:cNvPr id="1" name=""/>
-        <p:cNvGrpSpPr/>
-        <p:nvPr/>
-      </p:nvGrpSpPr>
-      <p:grpSpPr>
-        <a:xfrm>
-          <a:off x="0" y="0"/>
-          <a:ext cx="0" cy="0"/>
-          <a:chOff x="0" y="0"/>
-          <a:chExt cx="0" cy="0"/>
-        </a:xfrm>
-      </p:grpSpPr>
-      <p:sp>
-        <p:nvSpPr>
-          <p:cNvPr id="2" name="Titel 1">
-            <a:extLst>
-              <a:ext uri="{FF2B5EF4-FFF2-40B4-BE49-F238E27FC236}">
-                <a16:creationId xmlns:a16="http://schemas.microsoft.com/office/drawing/2014/main" id="{72DF80EC-CD95-0B1A-565E-9E71C35046D6}"/>
-              </a:ext>
-            </a:extLst>
-          </p:cNvPr>
-          <p:cNvSpPr>
-            <a:spLocks noGrp="1"/>
-          </p:cNvSpPr>
-          <p:nvPr>
-            <p:ph type="title"/>
-          </p:nvPr>
-        </p:nvSpPr>
-        <p:spPr/>
-        <p:txBody>
-          <a:bodyPr/>
-          <a:lstStyle/>
-          <a:p>
-            <a:r>
-              <a:rPr lang="de-DE"/>
-              <a:t>Systemüberblick</a:t>
-            </a:r>
-          </a:p>
-        </p:txBody>
-      </p:sp>
-      <p:pic>
-        <p:nvPicPr>
-          <p:cNvPr id="5" name="Grafik 4">
-            <a:extLst>
-              <a:ext uri="{FF2B5EF4-FFF2-40B4-BE49-F238E27FC236}">
-                <a16:creationId xmlns:a16="http://schemas.microsoft.com/office/drawing/2014/main" id="{033EC115-1820-E513-0021-FAF480BA97C9}"/>
-              </a:ext>
-            </a:extLst>
-          </p:cNvPr>
-          <p:cNvPicPr>
-            <a:picLocks noChangeAspect="1"/>
-          </p:cNvPicPr>
-          <p:nvPr/>
-        </p:nvPicPr>
-        <p:blipFill>
-          <a:blip r:embed="rId3"/>
-          <a:srcRect/>
-          <a:stretch/>
-        </p:blipFill>
-        <p:spPr>
-          <a:xfrm>
-            <a:off x="1747533" y="1485074"/>
-            <a:ext cx="8696933" cy="5007801"/>
-          </a:xfrm>
-          <a:prstGeom prst="rect">
-            <a:avLst/>
-          </a:prstGeom>
-        </p:spPr>
-      </p:pic>
-      <p:sp>
-        <p:nvSpPr>
-          <p:cNvPr id="4" name="Foliennummernplatzhalter 3">
-            <a:extLst>
-              <a:ext uri="{FF2B5EF4-FFF2-40B4-BE49-F238E27FC236}">
-                <a16:creationId xmlns:a16="http://schemas.microsoft.com/office/drawing/2014/main" id="{53405529-831B-213E-5F34-8F66C31A035B}"/>
-              </a:ext>
-            </a:extLst>
-          </p:cNvPr>
-          <p:cNvSpPr>
-            <a:spLocks noGrp="1"/>
-          </p:cNvSpPr>
-          <p:nvPr>
-            <p:ph type="sldNum" sz="quarter" idx="12"/>
-          </p:nvPr>
-        </p:nvSpPr>
-        <p:spPr/>
-        <p:txBody>
-          <a:bodyPr/>
-          <a:lstStyle/>
-          <a:p>
-            <a:fld id="{6C43980B-2C02-594B-9C73-A951FE425682}" type="slidenum">
-              <a:rPr lang="de-DE" smtClean="0"/>
-              <a:t>2</a:t>
-            </a:fld>
-            <a:endParaRPr lang="de-DE" dirty="0"/>
-          </a:p>
-        </p:txBody>
-      </p:sp>
-    </p:spTree>
-    <p:extLst>
-      <p:ext uri="{BB962C8B-B14F-4D97-AF65-F5344CB8AC3E}">
-        <p14:creationId xmlns:p14="http://schemas.microsoft.com/office/powerpoint/2010/main" val="3010708104"/>
-      </p:ext>
-    </p:extLst>
-  </p:cSld>
-  <p:clrMapOvr>
-    <a:masterClrMapping/>
-  </p:clrMapOvr>
-</p:sld>
-</file>
-
-<file path=ppt/slides/slide20.xml><?xml version="1.0" encoding="utf-8"?>
+<file path=ppt/slides/slide19.xml><?xml version="1.0" encoding="utf-8"?>
 <p:sld xmlns:a="http://schemas.openxmlformats.org/drawingml/2006/main" xmlns:r="http://schemas.openxmlformats.org/officeDocument/2006/relationships" xmlns:p="http://schemas.openxmlformats.org/presentationml/2006/main">
   <p:cSld>
     <p:spTree>
@@ -9752,7 +9405,7 @@
           <a:p>
             <a:fld id="{6C43980B-2C02-594B-9C73-A951FE425682}" type="slidenum">
               <a:rPr lang="de-DE" smtClean="0"/>
-              <a:t>20</a:t>
+              <a:t>19</a:t>
             </a:fld>
             <a:endParaRPr lang="de-DE" dirty="0"/>
           </a:p>
@@ -9771,7 +9424,123 @@
 </p:sld>
 </file>
 
-<file path=ppt/slides/slide21.xml><?xml version="1.0" encoding="utf-8"?>
+<file path=ppt/slides/slide2.xml><?xml version="1.0" encoding="utf-8"?>
+<p:sld xmlns:a="http://schemas.openxmlformats.org/drawingml/2006/main" xmlns:r="http://schemas.openxmlformats.org/officeDocument/2006/relationships" xmlns:p="http://schemas.openxmlformats.org/presentationml/2006/main">
+  <p:cSld>
+    <p:spTree>
+      <p:nvGrpSpPr>
+        <p:cNvPr id="1" name=""/>
+        <p:cNvGrpSpPr/>
+        <p:nvPr/>
+      </p:nvGrpSpPr>
+      <p:grpSpPr>
+        <a:xfrm>
+          <a:off x="0" y="0"/>
+          <a:ext cx="0" cy="0"/>
+          <a:chOff x="0" y="0"/>
+          <a:chExt cx="0" cy="0"/>
+        </a:xfrm>
+      </p:grpSpPr>
+      <p:sp>
+        <p:nvSpPr>
+          <p:cNvPr id="2" name="Titel 1">
+            <a:extLst>
+              <a:ext uri="{FF2B5EF4-FFF2-40B4-BE49-F238E27FC236}">
+                <a16:creationId xmlns:a16="http://schemas.microsoft.com/office/drawing/2014/main" id="{72DF80EC-CD95-0B1A-565E-9E71C35046D6}"/>
+              </a:ext>
+            </a:extLst>
+          </p:cNvPr>
+          <p:cNvSpPr>
+            <a:spLocks noGrp="1"/>
+          </p:cNvSpPr>
+          <p:nvPr>
+            <p:ph type="title"/>
+          </p:nvPr>
+        </p:nvSpPr>
+        <p:spPr/>
+        <p:txBody>
+          <a:bodyPr/>
+          <a:lstStyle/>
+          <a:p>
+            <a:r>
+              <a:rPr lang="de-DE"/>
+              <a:t>Systemüberblick</a:t>
+            </a:r>
+          </a:p>
+        </p:txBody>
+      </p:sp>
+      <p:pic>
+        <p:nvPicPr>
+          <p:cNvPr id="5" name="Grafik 4">
+            <a:extLst>
+              <a:ext uri="{FF2B5EF4-FFF2-40B4-BE49-F238E27FC236}">
+                <a16:creationId xmlns:a16="http://schemas.microsoft.com/office/drawing/2014/main" id="{033EC115-1820-E513-0021-FAF480BA97C9}"/>
+              </a:ext>
+            </a:extLst>
+          </p:cNvPr>
+          <p:cNvPicPr>
+            <a:picLocks noChangeAspect="1"/>
+          </p:cNvPicPr>
+          <p:nvPr/>
+        </p:nvPicPr>
+        <p:blipFill>
+          <a:blip r:embed="rId3"/>
+          <a:srcRect/>
+          <a:stretch/>
+        </p:blipFill>
+        <p:spPr>
+          <a:xfrm>
+            <a:off x="1747533" y="1485074"/>
+            <a:ext cx="8696933" cy="5007801"/>
+          </a:xfrm>
+          <a:prstGeom prst="rect">
+            <a:avLst/>
+          </a:prstGeom>
+        </p:spPr>
+      </p:pic>
+      <p:sp>
+        <p:nvSpPr>
+          <p:cNvPr id="4" name="Foliennummernplatzhalter 3">
+            <a:extLst>
+              <a:ext uri="{FF2B5EF4-FFF2-40B4-BE49-F238E27FC236}">
+                <a16:creationId xmlns:a16="http://schemas.microsoft.com/office/drawing/2014/main" id="{53405529-831B-213E-5F34-8F66C31A035B}"/>
+              </a:ext>
+            </a:extLst>
+          </p:cNvPr>
+          <p:cNvSpPr>
+            <a:spLocks noGrp="1"/>
+          </p:cNvSpPr>
+          <p:nvPr>
+            <p:ph type="sldNum" sz="quarter" idx="12"/>
+          </p:nvPr>
+        </p:nvSpPr>
+        <p:spPr/>
+        <p:txBody>
+          <a:bodyPr/>
+          <a:lstStyle/>
+          <a:p>
+            <a:fld id="{6C43980B-2C02-594B-9C73-A951FE425682}" type="slidenum">
+              <a:rPr lang="de-DE" smtClean="0"/>
+              <a:t>2</a:t>
+            </a:fld>
+            <a:endParaRPr lang="de-DE" dirty="0"/>
+          </a:p>
+        </p:txBody>
+      </p:sp>
+    </p:spTree>
+    <p:extLst>
+      <p:ext uri="{BB962C8B-B14F-4D97-AF65-F5344CB8AC3E}">
+        <p14:creationId xmlns:p14="http://schemas.microsoft.com/office/powerpoint/2010/main" val="3010708104"/>
+      </p:ext>
+    </p:extLst>
+  </p:cSld>
+  <p:clrMapOvr>
+    <a:masterClrMapping/>
+  </p:clrMapOvr>
+</p:sld>
+</file>
+
+<file path=ppt/slides/slide20.xml><?xml version="1.0" encoding="utf-8"?>
 <p:sld xmlns:a="http://schemas.openxmlformats.org/drawingml/2006/main" xmlns:r="http://schemas.openxmlformats.org/officeDocument/2006/relationships" xmlns:p="http://schemas.openxmlformats.org/presentationml/2006/main">
   <p:cSld>
     <p:spTree>
@@ -9921,7 +9690,7 @@
           <a:p>
             <a:fld id="{6C43980B-2C02-594B-9C73-A951FE425682}" type="slidenum">
               <a:rPr lang="de-DE" smtClean="0"/>
-              <a:t>21</a:t>
+              <a:t>20</a:t>
             </a:fld>
             <a:endParaRPr lang="de-DE" dirty="0"/>
           </a:p>
@@ -9973,7 +9742,7 @@
 </p:sld>
 </file>
 
-<file path=ppt/slides/slide22.xml><?xml version="1.0" encoding="utf-8"?>
+<file path=ppt/slides/slide21.xml><?xml version="1.0" encoding="utf-8"?>
 <p:sld xmlns:a="http://schemas.openxmlformats.org/drawingml/2006/main" xmlns:r="http://schemas.openxmlformats.org/officeDocument/2006/relationships" xmlns:p="http://schemas.openxmlformats.org/presentationml/2006/main">
   <p:cSld>
     <p:spTree>
@@ -10076,7 +9845,7 @@
           <a:p>
             <a:fld id="{6C43980B-2C02-594B-9C73-A951FE425682}" type="slidenum">
               <a:rPr lang="de-DE" smtClean="0"/>
-              <a:t>22</a:t>
+              <a:t>21</a:t>
             </a:fld>
             <a:endParaRPr lang="de-DE" dirty="0"/>
           </a:p>
@@ -10095,7 +9864,7 @@
 </p:sld>
 </file>
 
-<file path=ppt/slides/slide23.xml><?xml version="1.0" encoding="utf-8"?>
+<file path=ppt/slides/slide22.xml><?xml version="1.0" encoding="utf-8"?>
 <p:sld xmlns:a="http://schemas.openxmlformats.org/drawingml/2006/main" xmlns:r="http://schemas.openxmlformats.org/officeDocument/2006/relationships" xmlns:p="http://schemas.openxmlformats.org/presentationml/2006/main">
   <p:cSld>
     <p:spTree>
@@ -12260,7 +12029,7 @@
           <a:p>
             <a:fld id="{6C43980B-2C02-594B-9C73-A951FE425682}" type="slidenum">
               <a:rPr lang="de-DE" smtClean="0"/>
-              <a:t>23</a:t>
+              <a:t>22</a:t>
             </a:fld>
             <a:endParaRPr lang="de-DE" dirty="0"/>
           </a:p>
@@ -12279,7 +12048,7 @@
 </p:sld>
 </file>
 
-<file path=ppt/slides/slide24.xml><?xml version="1.0" encoding="utf-8"?>
+<file path=ppt/slides/slide23.xml><?xml version="1.0" encoding="utf-8"?>
 <p:sld xmlns:a="http://schemas.openxmlformats.org/drawingml/2006/main" xmlns:r="http://schemas.openxmlformats.org/officeDocument/2006/relationships" xmlns:p="http://schemas.openxmlformats.org/presentationml/2006/main">
   <p:cSld>
     <p:spTree>
@@ -14868,7 +14637,7 @@
           <a:p>
             <a:fld id="{6C43980B-2C02-594B-9C73-A951FE425682}" type="slidenum">
               <a:rPr lang="de-DE" smtClean="0"/>
-              <a:t>24</a:t>
+              <a:t>23</a:t>
             </a:fld>
             <a:endParaRPr lang="de-DE" dirty="0"/>
           </a:p>
@@ -14887,7 +14656,7 @@
 </p:sld>
 </file>
 
-<file path=ppt/slides/slide25.xml><?xml version="1.0" encoding="utf-8"?>
+<file path=ppt/slides/slide24.xml><?xml version="1.0" encoding="utf-8"?>
 <p:sld xmlns:a="http://schemas.openxmlformats.org/drawingml/2006/main" xmlns:r="http://schemas.openxmlformats.org/officeDocument/2006/relationships" xmlns:p="http://schemas.openxmlformats.org/presentationml/2006/main">
   <p:cSld>
     <p:spTree>
@@ -18161,7 +17930,7 @@
           <a:p>
             <a:fld id="{6C43980B-2C02-594B-9C73-A951FE425682}" type="slidenum">
               <a:rPr lang="de-DE" smtClean="0"/>
-              <a:t>25</a:t>
+              <a:t>24</a:t>
             </a:fld>
             <a:endParaRPr lang="de-DE" dirty="0"/>
           </a:p>
@@ -18213,7 +17982,7 @@
 </p:sld>
 </file>
 
-<file path=ppt/slides/slide26.xml><?xml version="1.0" encoding="utf-8"?>
+<file path=ppt/slides/slide25.xml><?xml version="1.0" encoding="utf-8"?>
 <p:sld xmlns:a="http://schemas.openxmlformats.org/drawingml/2006/main" xmlns:r="http://schemas.openxmlformats.org/officeDocument/2006/relationships" xmlns:p="http://schemas.openxmlformats.org/presentationml/2006/main">
   <p:cSld>
     <p:spTree>
@@ -22363,7 +22132,7 @@
           <a:p>
             <a:fld id="{6C43980B-2C02-594B-9C73-A951FE425682}" type="slidenum">
               <a:rPr lang="de-DE" smtClean="0"/>
-              <a:t>26</a:t>
+              <a:t>25</a:t>
             </a:fld>
             <a:endParaRPr lang="de-DE" dirty="0"/>
           </a:p>
@@ -22382,7 +22151,7 @@
 </p:sld>
 </file>
 
-<file path=ppt/slides/slide27.xml><?xml version="1.0" encoding="utf-8"?>
+<file path=ppt/slides/slide26.xml><?xml version="1.0" encoding="utf-8"?>
 <p:sld xmlns:a="http://schemas.openxmlformats.org/drawingml/2006/main" xmlns:r="http://schemas.openxmlformats.org/officeDocument/2006/relationships" xmlns:p="http://schemas.openxmlformats.org/presentationml/2006/main">
   <p:cSld>
     <p:spTree>
@@ -22485,7 +22254,7 @@
           <a:p>
             <a:fld id="{6C43980B-2C02-594B-9C73-A951FE425682}" type="slidenum">
               <a:rPr lang="de-DE" smtClean="0"/>
-              <a:t>27</a:t>
+              <a:t>26</a:t>
             </a:fld>
             <a:endParaRPr lang="de-DE" dirty="0"/>
           </a:p>
@@ -22504,7 +22273,7 @@
 </p:sld>
 </file>
 
-<file path=ppt/slides/slide28.xml><?xml version="1.0" encoding="utf-8"?>
+<file path=ppt/slides/slide27.xml><?xml version="1.0" encoding="utf-8"?>
 <p:sld xmlns:a="http://schemas.openxmlformats.org/drawingml/2006/main" xmlns:r="http://schemas.openxmlformats.org/officeDocument/2006/relationships" xmlns:p="http://schemas.openxmlformats.org/presentationml/2006/main">
   <p:cSld>
     <p:spTree>
@@ -23888,7 +23657,7 @@
           <a:p>
             <a:fld id="{6C43980B-2C02-594B-9C73-A951FE425682}" type="slidenum">
               <a:rPr lang="de-DE" smtClean="0"/>
-              <a:t>28</a:t>
+              <a:t>27</a:t>
             </a:fld>
             <a:endParaRPr lang="de-DE" dirty="0"/>
           </a:p>

</xml_diff>

<commit_message>
Copied final presentation from A7 to Z7
</commit_message>
<xml_diff>
--- a/docs/Endpraesentation/DAPI_FractalCore_Endpraesentation.pptx
+++ b/docs/Endpraesentation/DAPI_FractalCore_Endpraesentation.pptx
@@ -19,12 +19,12 @@
     <p:sldId id="266" r:id="rId10"/>
     <p:sldId id="277" r:id="rId11"/>
     <p:sldId id="274" r:id="rId12"/>
-    <p:sldId id="278" r:id="rId13"/>
-    <p:sldId id="279" r:id="rId14"/>
-    <p:sldId id="281" r:id="rId15"/>
-    <p:sldId id="286" r:id="rId16"/>
-    <p:sldId id="285" r:id="rId17"/>
-    <p:sldId id="280" r:id="rId18"/>
+    <p:sldId id="287" r:id="rId13"/>
+    <p:sldId id="278" r:id="rId14"/>
+    <p:sldId id="279" r:id="rId15"/>
+    <p:sldId id="281" r:id="rId16"/>
+    <p:sldId id="286" r:id="rId17"/>
+    <p:sldId id="285" r:id="rId18"/>
     <p:sldId id="282" r:id="rId19"/>
     <p:sldId id="270" r:id="rId20"/>
     <p:sldId id="268" r:id="rId21"/>
@@ -141,6 +141,16 @@
 </p:presentation>
 </file>
 
+<file path=ppt/revisionInfo.xml><?xml version="1.0" encoding="utf-8"?>
+<p1510:revInfo xmlns:a="http://schemas.openxmlformats.org/drawingml/2006/main" xmlns:r="http://schemas.openxmlformats.org/officeDocument/2006/relationships" xmlns:p1510="http://schemas.microsoft.com/office/powerpoint/2015/10/main">
+  <p1510:revLst>
+    <p1510:client id="{87E8D9EF-151D-C0AF-FD62-01ED04B54185}" v="290" dt="2026-06-23T16:04:39.193"/>
+    <p1510:client id="{AD8E74BE-A737-2340-F74B-D225C784332A}" v="239" dt="2026-06-22T18:50:55.720"/>
+    <p1510:client id="{DD2898B8-EB7D-7DD6-7886-E401E840CD2F}" v="39" dt="2026-06-22T18:21:20.701"/>
+  </p1510:revLst>
+</p1510:revInfo>
+</file>
+
 <file path=ppt/notesMasters/notesMaster1.xml><?xml version="1.0" encoding="utf-8"?>
 <p:notesMaster xmlns:a="http://schemas.openxmlformats.org/drawingml/2006/main" xmlns:r="http://schemas.openxmlformats.org/officeDocument/2006/relationships" xmlns:p="http://schemas.openxmlformats.org/presentationml/2006/main">
   <p:cSld>
@@ -223,7 +233,7 @@
           <a:p>
             <a:fld id="{25690DA4-8E7E-0941-AA18-ABC55D37EF0E}" type="datetimeFigureOut">
               <a:rPr lang="de-DE" smtClean="0"/>
-              <a:t>19.06.26</a:t>
+              <a:t>23.06.26</a:t>
             </a:fld>
             <a:endParaRPr lang="de-DE"/>
           </a:p>
@@ -534,7 +544,10 @@
           <a:bodyPr/>
           <a:lstStyle/>
           <a:p>
-            <a:endParaRPr lang="de-DE" dirty="0"/>
+            <a:r>
+              <a:rPr lang="de-DE" dirty="0"/>
+              <a:t>Vielleicht kennen Sie dieses Bild….</a:t>
+            </a:r>
           </a:p>
         </p:txBody>
       </p:sp>
@@ -777,7 +790,7 @@
           <a:p>
             <a:fld id="{BA036D80-E674-C74A-9C41-C7D9BE4A5ABE}" type="slidenum">
               <a:rPr lang="de-DE" smtClean="0"/>
-              <a:t>12</a:t>
+              <a:t>13</a:t>
             </a:fld>
             <a:endParaRPr lang="de-DE"/>
           </a:p>
@@ -888,7 +901,7 @@
           <a:p>
             <a:fld id="{BA036D80-E674-C74A-9C41-C7D9BE4A5ABE}" type="slidenum">
               <a:rPr lang="de-DE" smtClean="0"/>
-              <a:t>15</a:t>
+              <a:t>16</a:t>
             </a:fld>
             <a:endParaRPr lang="de-DE"/>
           </a:p>
@@ -908,117 +921,6 @@
 </file>
 
 <file path=ppt/notesSlides/notesSlide13.xml><?xml version="1.0" encoding="utf-8"?>
-<p:notes xmlns:a="http://schemas.openxmlformats.org/drawingml/2006/main" xmlns:r="http://schemas.openxmlformats.org/officeDocument/2006/relationships" xmlns:p="http://schemas.openxmlformats.org/presentationml/2006/main">
-  <p:cSld>
-    <p:spTree>
-      <p:nvGrpSpPr>
-        <p:cNvPr id="1" name="">
-          <a:extLst>
-            <a:ext uri="{FF2B5EF4-FFF2-40B4-BE49-F238E27FC236}">
-              <a16:creationId xmlns:a16="http://schemas.microsoft.com/office/drawing/2014/main" id="{22BBB2B2-F221-7669-5B48-35869E18781E}"/>
-            </a:ext>
-          </a:extLst>
-        </p:cNvPr>
-        <p:cNvGrpSpPr/>
-        <p:nvPr/>
-      </p:nvGrpSpPr>
-      <p:grpSpPr>
-        <a:xfrm>
-          <a:off x="0" y="0"/>
-          <a:ext cx="0" cy="0"/>
-          <a:chOff x="0" y="0"/>
-          <a:chExt cx="0" cy="0"/>
-        </a:xfrm>
-      </p:grpSpPr>
-      <p:sp>
-        <p:nvSpPr>
-          <p:cNvPr id="2" name="Folienbildplatzhalter 1">
-            <a:extLst>
-              <a:ext uri="{FF2B5EF4-FFF2-40B4-BE49-F238E27FC236}">
-                <a16:creationId xmlns:a16="http://schemas.microsoft.com/office/drawing/2014/main" id="{A3EEB85D-612D-D8B7-C592-08FA2D629950}"/>
-              </a:ext>
-            </a:extLst>
-          </p:cNvPr>
-          <p:cNvSpPr>
-            <a:spLocks noGrp="1" noRot="1" noChangeAspect="1"/>
-          </p:cNvSpPr>
-          <p:nvPr>
-            <p:ph type="sldImg"/>
-          </p:nvPr>
-        </p:nvSpPr>
-        <p:spPr/>
-      </p:sp>
-      <p:sp>
-        <p:nvSpPr>
-          <p:cNvPr id="3" name="Notizenplatzhalter 2">
-            <a:extLst>
-              <a:ext uri="{FF2B5EF4-FFF2-40B4-BE49-F238E27FC236}">
-                <a16:creationId xmlns:a16="http://schemas.microsoft.com/office/drawing/2014/main" id="{4AECDE8D-4B4D-79EF-119E-31138BE1705C}"/>
-              </a:ext>
-            </a:extLst>
-          </p:cNvPr>
-          <p:cNvSpPr>
-            <a:spLocks noGrp="1"/>
-          </p:cNvSpPr>
-          <p:nvPr>
-            <p:ph type="body" idx="1"/>
-          </p:nvPr>
-        </p:nvSpPr>
-        <p:spPr/>
-        <p:txBody>
-          <a:bodyPr/>
-          <a:lstStyle/>
-          <a:p>
-            <a:r>
-              <a:rPr lang="de-DE" dirty="0"/>
-              <a:t>Entspricht der Gliederung</a:t>
-            </a:r>
-          </a:p>
-        </p:txBody>
-      </p:sp>
-      <p:sp>
-        <p:nvSpPr>
-          <p:cNvPr id="4" name="Foliennummernplatzhalter 3">
-            <a:extLst>
-              <a:ext uri="{FF2B5EF4-FFF2-40B4-BE49-F238E27FC236}">
-                <a16:creationId xmlns:a16="http://schemas.microsoft.com/office/drawing/2014/main" id="{7B424F95-8B32-A310-36E3-6E9690EC49FC}"/>
-              </a:ext>
-            </a:extLst>
-          </p:cNvPr>
-          <p:cNvSpPr>
-            <a:spLocks noGrp="1"/>
-          </p:cNvSpPr>
-          <p:nvPr>
-            <p:ph type="sldNum" sz="quarter" idx="5"/>
-          </p:nvPr>
-        </p:nvSpPr>
-        <p:spPr/>
-        <p:txBody>
-          <a:bodyPr/>
-          <a:lstStyle/>
-          <a:p>
-            <a:fld id="{BA036D80-E674-C74A-9C41-C7D9BE4A5ABE}" type="slidenum">
-              <a:rPr lang="de-DE" smtClean="0"/>
-              <a:t>17</a:t>
-            </a:fld>
-            <a:endParaRPr lang="de-DE"/>
-          </a:p>
-        </p:txBody>
-      </p:sp>
-    </p:spTree>
-    <p:extLst>
-      <p:ext uri="{BB962C8B-B14F-4D97-AF65-F5344CB8AC3E}">
-        <p14:creationId xmlns:p14="http://schemas.microsoft.com/office/powerpoint/2010/main" val="768810871"/>
-      </p:ext>
-    </p:extLst>
-  </p:cSld>
-  <p:clrMapOvr>
-    <a:masterClrMapping/>
-  </p:clrMapOvr>
-</p:notes>
-</file>
-
-<file path=ppt/notesSlides/notesSlide14.xml><?xml version="1.0" encoding="utf-8"?>
 <p:notes xmlns:a="http://schemas.openxmlformats.org/drawingml/2006/main" xmlns:r="http://schemas.openxmlformats.org/officeDocument/2006/relationships" xmlns:p="http://schemas.openxmlformats.org/presentationml/2006/main">
   <p:cSld>
     <p:spTree>
@@ -1129,7 +1031,7 @@
 </p:notes>
 </file>
 
-<file path=ppt/notesSlides/notesSlide15.xml><?xml version="1.0" encoding="utf-8"?>
+<file path=ppt/notesSlides/notesSlide14.xml><?xml version="1.0" encoding="utf-8"?>
 <p:notes xmlns:a="http://schemas.openxmlformats.org/drawingml/2006/main" xmlns:r="http://schemas.openxmlformats.org/officeDocument/2006/relationships" xmlns:p="http://schemas.openxmlformats.org/presentationml/2006/main">
   <p:cSld>
     <p:spTree>
@@ -1223,7 +1125,7 @@
 </p:notes>
 </file>
 
-<file path=ppt/notesSlides/notesSlide16.xml><?xml version="1.0" encoding="utf-8"?>
+<file path=ppt/notesSlides/notesSlide15.xml><?xml version="1.0" encoding="utf-8"?>
 <p:notes xmlns:a="http://schemas.openxmlformats.org/drawingml/2006/main" xmlns:r="http://schemas.openxmlformats.org/officeDocument/2006/relationships" xmlns:p="http://schemas.openxmlformats.org/presentationml/2006/main">
   <p:cSld>
     <p:spTree>
@@ -1334,7 +1236,7 @@
 </p:notes>
 </file>
 
-<file path=ppt/notesSlides/notesSlide17.xml><?xml version="1.0" encoding="utf-8"?>
+<file path=ppt/notesSlides/notesSlide16.xml><?xml version="1.0" encoding="utf-8"?>
 <p:notes xmlns:a="http://schemas.openxmlformats.org/drawingml/2006/main" xmlns:r="http://schemas.openxmlformats.org/officeDocument/2006/relationships" xmlns:p="http://schemas.openxmlformats.org/presentationml/2006/main">
   <p:cSld>
     <p:spTree>
@@ -1418,7 +1320,7 @@
 </p:notes>
 </file>
 
-<file path=ppt/notesSlides/notesSlide18.xml><?xml version="1.0" encoding="utf-8"?>
+<file path=ppt/notesSlides/notesSlide17.xml><?xml version="1.0" encoding="utf-8"?>
 <p:notes xmlns:a="http://schemas.openxmlformats.org/drawingml/2006/main" xmlns:r="http://schemas.openxmlformats.org/officeDocument/2006/relationships" xmlns:p="http://schemas.openxmlformats.org/presentationml/2006/main">
   <p:cSld>
     <p:spTree>
@@ -2435,7 +2337,7 @@
           <a:p>
             <a:fld id="{E6DFA5A1-A813-7B43-85D4-C153DE6EEC5D}" type="datetime1">
               <a:rPr lang="de-DE" smtClean="0"/>
-              <a:t>19.06.26</a:t>
+              <a:t>23.06.26</a:t>
             </a:fld>
             <a:endParaRPr lang="de-DE"/>
           </a:p>
@@ -2633,7 +2535,7 @@
           <a:p>
             <a:fld id="{85A7F633-92B1-A640-B682-55DDF7097609}" type="datetime1">
               <a:rPr lang="de-DE" smtClean="0"/>
-              <a:t>19.06.26</a:t>
+              <a:t>23.06.26</a:t>
             </a:fld>
             <a:endParaRPr lang="de-DE"/>
           </a:p>
@@ -2841,7 +2743,7 @@
           <a:p>
             <a:fld id="{6B0DB9B7-7C2A-CA43-A176-0C82CB77F997}" type="datetime1">
               <a:rPr lang="de-DE" smtClean="0"/>
-              <a:t>19.06.26</a:t>
+              <a:t>23.06.26</a:t>
             </a:fld>
             <a:endParaRPr lang="de-DE"/>
           </a:p>
@@ -3044,7 +2946,7 @@
           <a:p>
             <a:fld id="{04634442-C186-E94E-B304-D4E0857BF857}" type="datetime1">
               <a:rPr lang="de-DE" smtClean="0"/>
-              <a:t>19.06.26</a:t>
+              <a:t>23.06.26</a:t>
             </a:fld>
             <a:endParaRPr lang="de-DE"/>
           </a:p>
@@ -3329,7 +3231,7 @@
           <a:p>
             <a:fld id="{3ACE65F1-39AD-D942-81CC-A8B185C49E41}" type="datetime1">
               <a:rPr lang="de-DE" smtClean="0"/>
-              <a:t>19.06.26</a:t>
+              <a:t>23.06.26</a:t>
             </a:fld>
             <a:endParaRPr lang="de-DE"/>
           </a:p>
@@ -3594,7 +3496,7 @@
           <a:p>
             <a:fld id="{15B311CB-D684-6D4F-A48A-21B70AE7BE5E}" type="datetime1">
               <a:rPr lang="de-DE" smtClean="0"/>
-              <a:t>19.06.26</a:t>
+              <a:t>23.06.26</a:t>
             </a:fld>
             <a:endParaRPr lang="de-DE"/>
           </a:p>
@@ -4006,7 +3908,7 @@
           <a:p>
             <a:fld id="{1F54E48E-21DA-704B-B06E-619E9794DDDC}" type="datetime1">
               <a:rPr lang="de-DE" smtClean="0"/>
-              <a:t>19.06.26</a:t>
+              <a:t>23.06.26</a:t>
             </a:fld>
             <a:endParaRPr lang="de-DE"/>
           </a:p>
@@ -4147,7 +4049,7 @@
           <a:p>
             <a:fld id="{4DB5E8C2-ED39-FA4A-892C-5D69F297ACBF}" type="datetime1">
               <a:rPr lang="de-DE" smtClean="0"/>
-              <a:t>19.06.26</a:t>
+              <a:t>23.06.26</a:t>
             </a:fld>
             <a:endParaRPr lang="de-DE"/>
           </a:p>
@@ -4260,7 +4162,7 @@
           <a:p>
             <a:fld id="{ECC4A7F1-D4D8-1545-AA93-BB835A9F7A8B}" type="datetime1">
               <a:rPr lang="de-DE" smtClean="0"/>
-              <a:t>19.06.26</a:t>
+              <a:t>23.06.26</a:t>
             </a:fld>
             <a:endParaRPr lang="de-DE"/>
           </a:p>
@@ -4571,7 +4473,7 @@
           <a:p>
             <a:fld id="{A04B4EF1-1BB5-A140-8507-2D8B6A510087}" type="datetime1">
               <a:rPr lang="de-DE" smtClean="0"/>
-              <a:t>19.06.26</a:t>
+              <a:t>23.06.26</a:t>
             </a:fld>
             <a:endParaRPr lang="de-DE"/>
           </a:p>
@@ -4859,7 +4761,7 @@
           <a:p>
             <a:fld id="{C33BA3A3-CA4A-E644-9084-D797594CB804}" type="datetime1">
               <a:rPr lang="de-DE" smtClean="0"/>
-              <a:t>19.06.26</a:t>
+              <a:t>23.06.26</a:t>
             </a:fld>
             <a:endParaRPr lang="de-DE"/>
           </a:p>
@@ -5100,7 +5002,7 @@
           <a:p>
             <a:fld id="{A7D163E4-7209-8D4B-B12D-5159794EF612}" type="datetime1">
               <a:rPr lang="de-DE" smtClean="0"/>
-              <a:t>19.06.26</a:t>
+              <a:t>23.06.26</a:t>
             </a:fld>
             <a:endParaRPr lang="de-DE"/>
           </a:p>
@@ -5981,7 +5883,7 @@
           <a:p>
             <a:r>
               <a:rPr lang="de-DE"/>
-              <a:t>PLATZHALTER FOLIEN THOMAS</a:t>
+              <a:t>Farbcodierung</a:t>
             </a:r>
           </a:p>
         </p:txBody>
@@ -6002,14 +5904,90 @@
             <p:ph idx="1"/>
           </p:nvPr>
         </p:nvSpPr>
-        <p:spPr/>
+        <p:spPr>
+          <a:xfrm>
+            <a:off x="968829" y="1985282"/>
+            <a:ext cx="5283201" cy="3524024"/>
+          </a:xfrm>
+        </p:spPr>
         <p:txBody>
-          <a:bodyPr/>
+          <a:bodyPr vert="horz" lIns="91440" tIns="45720" rIns="91440" bIns="45720" rtlCol="0" anchor="t">
+            <a:normAutofit/>
+          </a:bodyPr>
           <a:lstStyle/>
           <a:p>
             <a:r>
-              <a:rPr lang="de-DE"/>
-              <a:t>PLATZHALTER FOLIEN THOMAS</a:t>
+              <a:rPr lang="de-DE" sz="2100"/>
+              <a:t>Cores berechnen nur die Iterationsanzahl </a:t>
+            </a:r>
+            <a:endParaRPr lang="de-DE" sz="2100" dirty="0"/>
+          </a:p>
+          <a:p>
+            <a:r>
+              <a:rPr lang="de-DE" sz="2100"/>
+              <a:t>Farbcodierung erfolgt erst bei der Ausgabe</a:t>
+            </a:r>
+          </a:p>
+          <a:p>
+            <a:r>
+              <a:rPr lang="de-DE" sz="2100"/>
+              <a:t>Farbschema zur Laufzeit wechselbar</a:t>
+            </a:r>
+            <a:endParaRPr lang="de-DE"/>
+          </a:p>
+          <a:p>
+            <a:pPr marL="0" indent="0">
+              <a:buNone/>
+            </a:pPr>
+            <a:endParaRPr lang="de-DE" sz="2100" dirty="0"/>
+          </a:p>
+          <a:p>
+            <a:pPr marL="0" indent="0">
+              <a:buNone/>
+            </a:pPr>
+            <a:r>
+              <a:rPr lang="de-DE" sz="2100"/>
+              <a:t>Farbschemata: </a:t>
+            </a:r>
+          </a:p>
+          <a:p>
+            <a:pPr lvl="1">
+              <a:buFont typeface="Courier New" panose="020B0604020202020204" pitchFamily="34" charset="0"/>
+              <a:buChar char="o"/>
+            </a:pPr>
+            <a:r>
+              <a:rPr lang="de-DE" sz="2100"/>
+              <a:t>Graustufen </a:t>
+            </a:r>
+          </a:p>
+          <a:p>
+            <a:pPr lvl="1">
+              <a:buFont typeface="Courier New" panose="020B0604020202020204" pitchFamily="34" charset="0"/>
+              <a:buChar char="o"/>
+            </a:pPr>
+            <a:r>
+              <a:rPr lang="de-DE" sz="2100"/>
+              <a:t>Schwarz-Weiß </a:t>
+            </a:r>
+          </a:p>
+          <a:p>
+            <a:pPr lvl="1">
+              <a:buFont typeface="Courier New" panose="020B0604020202020204" pitchFamily="34" charset="0"/>
+              <a:buChar char="o"/>
+            </a:pPr>
+            <a:r>
+              <a:rPr lang="de-DE" sz="2100"/>
+              <a:t>Blau → Grün → Gelb → Rot </a:t>
+            </a:r>
+          </a:p>
+          <a:p>
+            <a:pPr lvl="1">
+              <a:buFont typeface="Courier New" panose="020B0604020202020204" pitchFamily="34" charset="0"/>
+              <a:buChar char="o"/>
+            </a:pPr>
+            <a:r>
+              <a:rPr lang="de-DE" sz="2100"/>
+              <a:t>Feuer </a:t>
             </a:r>
           </a:p>
         </p:txBody>
@@ -6043,6 +6021,226 @@
           </a:p>
         </p:txBody>
       </p:sp>
+      <p:sp>
+        <p:nvSpPr>
+          <p:cNvPr id="6" name="Rechteck 5">
+            <a:extLst>
+              <a:ext uri="{FF2B5EF4-FFF2-40B4-BE49-F238E27FC236}">
+                <a16:creationId xmlns:a16="http://schemas.microsoft.com/office/drawing/2014/main" id="{AF244251-AF87-C7E8-0D42-FBE2E569C8F7}"/>
+              </a:ext>
+            </a:extLst>
+          </p:cNvPr>
+          <p:cNvSpPr/>
+          <p:nvPr/>
+        </p:nvSpPr>
+        <p:spPr>
+          <a:xfrm>
+            <a:off x="838200" y="1833655"/>
+            <a:ext cx="5664200" cy="3800325"/>
+          </a:xfrm>
+          <a:prstGeom prst="rect">
+            <a:avLst/>
+          </a:prstGeom>
+          <a:noFill/>
+          <a:ln w="38100">
+            <a:solidFill>
+              <a:schemeClr val="accent1"/>
+            </a:solidFill>
+          </a:ln>
+        </p:spPr>
+        <p:style>
+          <a:lnRef idx="2">
+            <a:schemeClr val="accent1">
+              <a:shade val="15000"/>
+            </a:schemeClr>
+          </a:lnRef>
+          <a:fillRef idx="1">
+            <a:schemeClr val="accent1"/>
+          </a:fillRef>
+          <a:effectRef idx="0">
+            <a:schemeClr val="accent1"/>
+          </a:effectRef>
+          <a:fontRef idx="minor">
+            <a:schemeClr val="lt1"/>
+          </a:fontRef>
+        </p:style>
+        <p:txBody>
+          <a:bodyPr rtlCol="0" anchor="ctr"/>
+          <a:lstStyle/>
+          <a:p>
+            <a:pPr algn="ctr"/>
+            <a:endParaRPr lang="de-DE"/>
+          </a:p>
+        </p:txBody>
+      </p:sp>
+      <p:pic>
+        <p:nvPicPr>
+          <p:cNvPr id="4" name="Picture 3" descr="A yellow fractal on a white wall&#10;&#10;AI-generated content may be incorrect.">
+            <a:extLst>
+              <a:ext uri="{FF2B5EF4-FFF2-40B4-BE49-F238E27FC236}">
+                <a16:creationId xmlns:a16="http://schemas.microsoft.com/office/drawing/2014/main" id="{948290E0-8DAF-5876-411A-9435CB7CAEF4}"/>
+              </a:ext>
+            </a:extLst>
+          </p:cNvPr>
+          <p:cNvPicPr>
+            <a:picLocks noChangeAspect="1"/>
+          </p:cNvPicPr>
+          <p:nvPr/>
+        </p:nvPicPr>
+        <p:blipFill>
+          <a:blip r:embed="rId2"/>
+          <a:srcRect l="8765" t="14767" r="17849" b="25770"/>
+          <a:stretch>
+            <a:fillRect/>
+          </a:stretch>
+        </p:blipFill>
+        <p:spPr>
+          <a:xfrm>
+            <a:off x="7499413" y="692315"/>
+            <a:ext cx="3738674" cy="2273888"/>
+          </a:xfrm>
+          <a:prstGeom prst="rect">
+            <a:avLst/>
+          </a:prstGeom>
+        </p:spPr>
+      </p:pic>
+      <p:pic>
+        <p:nvPicPr>
+          <p:cNvPr id="7" name="Picture 6">
+            <a:extLst>
+              <a:ext uri="{FF2B5EF4-FFF2-40B4-BE49-F238E27FC236}">
+                <a16:creationId xmlns:a16="http://schemas.microsoft.com/office/drawing/2014/main" id="{32CC3D92-7CA7-8830-D9D4-E9B66893DC95}"/>
+              </a:ext>
+            </a:extLst>
+          </p:cNvPr>
+          <p:cNvPicPr>
+            <a:picLocks noChangeAspect="1"/>
+          </p:cNvPicPr>
+          <p:nvPr/>
+        </p:nvPicPr>
+        <p:blipFill>
+          <a:blip r:embed="rId3"/>
+          <a:srcRect l="18884" t="19048" r="12032" b="21998"/>
+          <a:stretch>
+            <a:fillRect/>
+          </a:stretch>
+        </p:blipFill>
+        <p:spPr>
+          <a:xfrm>
+            <a:off x="7500149" y="3519715"/>
+            <a:ext cx="3723077" cy="2388445"/>
+          </a:xfrm>
+          <a:prstGeom prst="rect">
+            <a:avLst/>
+          </a:prstGeom>
+        </p:spPr>
+      </p:pic>
+      <p:sp>
+        <p:nvSpPr>
+          <p:cNvPr id="9" name="Rechteck 7">
+            <a:extLst>
+              <a:ext uri="{FF2B5EF4-FFF2-40B4-BE49-F238E27FC236}">
+                <a16:creationId xmlns:a16="http://schemas.microsoft.com/office/drawing/2014/main" id="{78AD52B8-C231-6058-F3B7-05333290DE7A}"/>
+              </a:ext>
+            </a:extLst>
+          </p:cNvPr>
+          <p:cNvSpPr/>
+          <p:nvPr/>
+        </p:nvSpPr>
+        <p:spPr>
+          <a:xfrm>
+            <a:off x="7286824" y="2608779"/>
+            <a:ext cx="4167200" cy="524038"/>
+          </a:xfrm>
+          <a:prstGeom prst="rect">
+            <a:avLst/>
+          </a:prstGeom>
+          <a:ln>
+            <a:noFill/>
+          </a:ln>
+        </p:spPr>
+        <p:style>
+          <a:lnRef idx="2">
+            <a:schemeClr val="accent1">
+              <a:shade val="15000"/>
+            </a:schemeClr>
+          </a:lnRef>
+          <a:fillRef idx="1">
+            <a:schemeClr val="accent1"/>
+          </a:fillRef>
+          <a:effectRef idx="0">
+            <a:schemeClr val="accent1"/>
+          </a:effectRef>
+          <a:fontRef idx="minor">
+            <a:schemeClr val="lt1"/>
+          </a:fontRef>
+        </p:style>
+        <p:txBody>
+          <a:bodyPr lIns="91440" tIns="45720" rIns="91440" bIns="45720" rtlCol="0" anchor="ctr"/>
+          <a:lstStyle/>
+          <a:p>
+            <a:pPr algn="ctr"/>
+            <a:r>
+              <a:rPr lang="de-DE" sz="2100"/>
+              <a:t>Farbschema: Feuer</a:t>
+            </a:r>
+            <a:endParaRPr lang="de-DE" sz="2100" dirty="0"/>
+          </a:p>
+        </p:txBody>
+      </p:sp>
+      <p:sp>
+        <p:nvSpPr>
+          <p:cNvPr id="10" name="Rechteck 7">
+            <a:extLst>
+              <a:ext uri="{FF2B5EF4-FFF2-40B4-BE49-F238E27FC236}">
+                <a16:creationId xmlns:a16="http://schemas.microsoft.com/office/drawing/2014/main" id="{94772185-235B-C03A-824F-A449A186BE3C}"/>
+              </a:ext>
+            </a:extLst>
+          </p:cNvPr>
+          <p:cNvSpPr/>
+          <p:nvPr/>
+        </p:nvSpPr>
+        <p:spPr>
+          <a:xfrm>
+            <a:off x="7286823" y="5381007"/>
+            <a:ext cx="4167200" cy="524038"/>
+          </a:xfrm>
+          <a:prstGeom prst="rect">
+            <a:avLst/>
+          </a:prstGeom>
+          <a:ln>
+            <a:noFill/>
+          </a:ln>
+        </p:spPr>
+        <p:style>
+          <a:lnRef idx="2">
+            <a:schemeClr val="accent1">
+              <a:shade val="15000"/>
+            </a:schemeClr>
+          </a:lnRef>
+          <a:fillRef idx="1">
+            <a:schemeClr val="accent1"/>
+          </a:fillRef>
+          <a:effectRef idx="0">
+            <a:schemeClr val="accent1"/>
+          </a:effectRef>
+          <a:fontRef idx="minor">
+            <a:schemeClr val="lt1"/>
+          </a:fontRef>
+        </p:style>
+        <p:txBody>
+          <a:bodyPr lIns="91440" tIns="45720" rIns="91440" bIns="45720" rtlCol="0" anchor="ctr"/>
+          <a:lstStyle/>
+          <a:p>
+            <a:pPr algn="ctr"/>
+            <a:r>
+              <a:rPr lang="de-DE" sz="2100"/>
+              <a:t>Farbschema: Graustufen</a:t>
+            </a:r>
+            <a:endParaRPr lang="de-DE" sz="2100" dirty="0"/>
+          </a:p>
+        </p:txBody>
+      </p:sp>
     </p:spTree>
     <p:extLst>
       <p:ext uri="{BB962C8B-B14F-4D97-AF65-F5344CB8AC3E}">
@@ -6057,6 +6255,545 @@
 </file>
 
 <file path=ppt/slides/slide12.xml><?xml version="1.0" encoding="utf-8"?>
+<p:sld xmlns:a="http://schemas.openxmlformats.org/drawingml/2006/main" xmlns:r="http://schemas.openxmlformats.org/officeDocument/2006/relationships" xmlns:p="http://schemas.openxmlformats.org/presentationml/2006/main">
+  <p:cSld>
+    <p:spTree>
+      <p:nvGrpSpPr>
+        <p:cNvPr id="1" name=""/>
+        <p:cNvGrpSpPr/>
+        <p:nvPr/>
+      </p:nvGrpSpPr>
+      <p:grpSpPr>
+        <a:xfrm>
+          <a:off x="0" y="0"/>
+          <a:ext cx="0" cy="0"/>
+          <a:chOff x="0" y="0"/>
+          <a:chExt cx="0" cy="0"/>
+        </a:xfrm>
+      </p:grpSpPr>
+      <p:sp>
+        <p:nvSpPr>
+          <p:cNvPr id="2" name="Titel 1">
+            <a:extLst>
+              <a:ext uri="{FF2B5EF4-FFF2-40B4-BE49-F238E27FC236}">
+                <a16:creationId xmlns:a16="http://schemas.microsoft.com/office/drawing/2014/main" id="{AC483806-A22C-85D9-5174-72B7867699BD}"/>
+              </a:ext>
+            </a:extLst>
+          </p:cNvPr>
+          <p:cNvSpPr>
+            <a:spLocks noGrp="1"/>
+          </p:cNvSpPr>
+          <p:nvPr>
+            <p:ph type="title"/>
+          </p:nvPr>
+        </p:nvSpPr>
+        <p:spPr/>
+        <p:txBody>
+          <a:bodyPr/>
+          <a:lstStyle/>
+          <a:p>
+            <a:r>
+              <a:rPr lang="de-DE">
+                <a:ea typeface="+mj-lt"/>
+                <a:cs typeface="+mj-lt"/>
+              </a:rPr>
+              <a:t>Speicheroptimierung und Bildausgabe</a:t>
+            </a:r>
+            <a:endParaRPr lang="de-DE"/>
+          </a:p>
+        </p:txBody>
+      </p:sp>
+      <p:sp>
+        <p:nvSpPr>
+          <p:cNvPr id="4" name="Foliennummernplatzhalter 3">
+            <a:extLst>
+              <a:ext uri="{FF2B5EF4-FFF2-40B4-BE49-F238E27FC236}">
+                <a16:creationId xmlns:a16="http://schemas.microsoft.com/office/drawing/2014/main" id="{AA9CB8E1-C601-4295-2AA1-6F2F1788F9BC}"/>
+              </a:ext>
+            </a:extLst>
+          </p:cNvPr>
+          <p:cNvSpPr>
+            <a:spLocks noGrp="1"/>
+          </p:cNvSpPr>
+          <p:nvPr>
+            <p:ph type="sldNum" sz="quarter" idx="12"/>
+          </p:nvPr>
+        </p:nvSpPr>
+        <p:spPr/>
+        <p:txBody>
+          <a:bodyPr/>
+          <a:lstStyle/>
+          <a:p>
+            <a:fld id="{6C43980B-2C02-594B-9C73-A951FE425682}" type="slidenum">
+              <a:rPr lang="de-DE" smtClean="0"/>
+              <a:t>12</a:t>
+            </a:fld>
+            <a:endParaRPr lang="de-DE" dirty="0"/>
+          </a:p>
+        </p:txBody>
+      </p:sp>
+      <p:sp>
+        <p:nvSpPr>
+          <p:cNvPr id="6" name="Textfeld 5">
+            <a:extLst>
+              <a:ext uri="{FF2B5EF4-FFF2-40B4-BE49-F238E27FC236}">
+                <a16:creationId xmlns:a16="http://schemas.microsoft.com/office/drawing/2014/main" id="{A73AB165-E14E-B53F-C964-6095C65C6108}"/>
+              </a:ext>
+            </a:extLst>
+          </p:cNvPr>
+          <p:cNvSpPr txBox="1"/>
+          <p:nvPr/>
+        </p:nvSpPr>
+        <p:spPr>
+          <a:xfrm>
+            <a:off x="1042388" y="2331522"/>
+            <a:ext cx="3596574" cy="945101"/>
+          </a:xfrm>
+          <a:prstGeom prst="rect">
+            <a:avLst/>
+          </a:prstGeom>
+          <a:noFill/>
+        </p:spPr>
+        <p:txBody>
+          <a:bodyPr rot="0" spcFirstLastPara="0" vertOverflow="overflow" horzOverflow="overflow" vert="horz" wrap="square" lIns="91440" tIns="45720" rIns="91440" bIns="45720" numCol="1" spcCol="0" rtlCol="0" fromWordArt="0" anchor="t" anchorCtr="0" forceAA="0" compatLnSpc="1">
+            <a:prstTxWarp prst="textNoShape">
+              <a:avLst/>
+            </a:prstTxWarp>
+            <a:spAutoFit/>
+          </a:bodyPr>
+          <a:lstStyle/>
+          <a:p>
+            <a:r>
+              <a:rPr lang="de-DE" dirty="0" err="1">
+                <a:ea typeface="+mn-lt"/>
+                <a:cs typeface="+mn-lt"/>
+              </a:rPr>
+              <a:t>Framebuffer</a:t>
+            </a:r>
+            <a:r>
+              <a:rPr lang="de-DE" dirty="0">
+                <a:ea typeface="+mn-lt"/>
+                <a:cs typeface="+mn-lt"/>
+              </a:rPr>
+              <a:t> speichert RGB-Werte</a:t>
+            </a:r>
+            <a:endParaRPr lang="de-DE" dirty="0"/>
+          </a:p>
+          <a:p>
+            <a:r>
+              <a:rPr lang="de-DE">
+                <a:ea typeface="+mn-lt"/>
+                <a:cs typeface="+mn-lt"/>
+              </a:rPr>
+              <a:t>640 × 480 × 12 Bit</a:t>
+            </a:r>
+            <a:endParaRPr lang="de-DE"/>
+          </a:p>
+          <a:p>
+            <a:r>
+              <a:rPr lang="de-DE">
+                <a:ea typeface="+mn-lt"/>
+                <a:cs typeface="+mn-lt"/>
+              </a:rPr>
+              <a:t>= 3.686.400 Bit</a:t>
+            </a:r>
+            <a:endParaRPr lang="de-DE"/>
+          </a:p>
+        </p:txBody>
+      </p:sp>
+      <p:sp>
+        <p:nvSpPr>
+          <p:cNvPr id="9" name="Textfeld 8">
+            <a:extLst>
+              <a:ext uri="{FF2B5EF4-FFF2-40B4-BE49-F238E27FC236}">
+                <a16:creationId xmlns:a16="http://schemas.microsoft.com/office/drawing/2014/main" id="{C0041C89-578B-64BF-DA30-93E186870194}"/>
+              </a:ext>
+            </a:extLst>
+          </p:cNvPr>
+          <p:cNvSpPr txBox="1"/>
+          <p:nvPr/>
+        </p:nvSpPr>
+        <p:spPr>
+          <a:xfrm>
+            <a:off x="1044038" y="4655127"/>
+            <a:ext cx="3912589" cy="923330"/>
+          </a:xfrm>
+          <a:prstGeom prst="rect">
+            <a:avLst/>
+          </a:prstGeom>
+          <a:noFill/>
+        </p:spPr>
+        <p:txBody>
+          <a:bodyPr rot="0" spcFirstLastPara="0" vertOverflow="overflow" horzOverflow="overflow" vert="horz" wrap="square" lIns="91440" tIns="45720" rIns="91440" bIns="45720" numCol="1" spcCol="0" rtlCol="0" fromWordArt="0" anchor="t" anchorCtr="0" forceAA="0" compatLnSpc="1">
+            <a:prstTxWarp prst="textNoShape">
+              <a:avLst/>
+            </a:prstTxWarp>
+            <a:spAutoFit/>
+          </a:bodyPr>
+          <a:lstStyle/>
+          <a:p>
+            <a:r>
+              <a:rPr lang="de-DE" dirty="0" err="1">
+                <a:ea typeface="+mn-lt"/>
+                <a:cs typeface="+mn-lt"/>
+              </a:rPr>
+              <a:t>Framebuffer</a:t>
+            </a:r>
+            <a:r>
+              <a:rPr lang="de-DE" dirty="0">
+                <a:ea typeface="+mn-lt"/>
+                <a:cs typeface="+mn-lt"/>
+              </a:rPr>
+              <a:t> speichert Iterationen</a:t>
+            </a:r>
+            <a:endParaRPr lang="de-DE" dirty="0"/>
+          </a:p>
+          <a:p>
+            <a:r>
+              <a:rPr lang="de-DE">
+                <a:ea typeface="+mn-lt"/>
+                <a:cs typeface="+mn-lt"/>
+              </a:rPr>
+              <a:t>640 × 480 × 9 Bit</a:t>
+            </a:r>
+            <a:endParaRPr lang="de-DE"/>
+          </a:p>
+          <a:p>
+            <a:r>
+              <a:rPr lang="de-DE">
+                <a:ea typeface="+mn-lt"/>
+                <a:cs typeface="+mn-lt"/>
+              </a:rPr>
+              <a:t>= 2.764.800 Bit</a:t>
+            </a:r>
+            <a:endParaRPr lang="de-DE"/>
+          </a:p>
+        </p:txBody>
+      </p:sp>
+      <p:sp>
+        <p:nvSpPr>
+          <p:cNvPr id="10" name="Textfeld 9">
+            <a:extLst>
+              <a:ext uri="{FF2B5EF4-FFF2-40B4-BE49-F238E27FC236}">
+                <a16:creationId xmlns:a16="http://schemas.microsoft.com/office/drawing/2014/main" id="{121F7F0C-91FB-6E2C-3856-908B6E411239}"/>
+              </a:ext>
+            </a:extLst>
+          </p:cNvPr>
+          <p:cNvSpPr txBox="1"/>
+          <p:nvPr/>
+        </p:nvSpPr>
+        <p:spPr>
+          <a:xfrm>
+            <a:off x="6167912" y="3546434"/>
+            <a:ext cx="4057732" cy="923330"/>
+          </a:xfrm>
+          <a:prstGeom prst="rect">
+            <a:avLst/>
+          </a:prstGeom>
+          <a:noFill/>
+        </p:spPr>
+        <p:txBody>
+          <a:bodyPr rot="0" spcFirstLastPara="0" vertOverflow="overflow" horzOverflow="overflow" vert="horz" wrap="square" lIns="91440" tIns="45720" rIns="91440" bIns="45720" numCol="1" spcCol="0" rtlCol="0" fromWordArt="0" anchor="t" anchorCtr="0" forceAA="0" compatLnSpc="1">
+            <a:prstTxWarp prst="textNoShape">
+              <a:avLst/>
+            </a:prstTxWarp>
+            <a:spAutoFit/>
+          </a:bodyPr>
+          <a:lstStyle/>
+          <a:p>
+            <a:pPr marL="285750" indent="-285750">
+              <a:buFont typeface="Arial"/>
+              <a:buChar char="•"/>
+            </a:pPr>
+            <a:r>
+              <a:rPr lang="de-DE">
+                <a:ea typeface="+mn-lt"/>
+                <a:cs typeface="+mn-lt"/>
+              </a:rPr>
+              <a:t>~25 % weniger Speicherbedarf </a:t>
+            </a:r>
+            <a:endParaRPr lang="de-DE"/>
+          </a:p>
+          <a:p>
+            <a:pPr marL="285750" indent="-285750">
+              <a:buFont typeface="Arial"/>
+              <a:buChar char="•"/>
+            </a:pPr>
+            <a:r>
+              <a:rPr lang="de-DE">
+                <a:ea typeface="+mn-lt"/>
+                <a:cs typeface="+mn-lt"/>
+              </a:rPr>
+              <a:t>VGA-Ausgabe mit 640×480 @ 60 Hz </a:t>
+            </a:r>
+            <a:endParaRPr lang="de-DE"/>
+          </a:p>
+          <a:p>
+            <a:pPr marL="285750" indent="-285750">
+              <a:buFont typeface="Arial"/>
+              <a:buChar char="•"/>
+            </a:pPr>
+            <a:r>
+              <a:rPr lang="de-DE">
+                <a:ea typeface="+mn-lt"/>
+                <a:cs typeface="+mn-lt"/>
+              </a:rPr>
+              <a:t>Pixeltakt ca. 25 MHz</a:t>
+            </a:r>
+            <a:endParaRPr lang="de-DE"/>
+          </a:p>
+        </p:txBody>
+      </p:sp>
+      <p:sp>
+        <p:nvSpPr>
+          <p:cNvPr id="12" name="Rechteck 11">
+            <a:extLst>
+              <a:ext uri="{FF2B5EF4-FFF2-40B4-BE49-F238E27FC236}">
+                <a16:creationId xmlns:a16="http://schemas.microsoft.com/office/drawing/2014/main" id="{CF7C5772-FFAB-9045-9EAC-9D83431A99B2}"/>
+              </a:ext>
+            </a:extLst>
+          </p:cNvPr>
+          <p:cNvSpPr/>
+          <p:nvPr/>
+        </p:nvSpPr>
+        <p:spPr>
+          <a:xfrm>
+            <a:off x="6048829" y="3372169"/>
+            <a:ext cx="4220029" cy="1282097"/>
+          </a:xfrm>
+          <a:prstGeom prst="rect">
+            <a:avLst/>
+          </a:prstGeom>
+          <a:noFill/>
+          <a:ln w="38100">
+            <a:solidFill>
+              <a:schemeClr val="accent1"/>
+            </a:solidFill>
+          </a:ln>
+        </p:spPr>
+        <p:style>
+          <a:lnRef idx="2">
+            <a:schemeClr val="accent1">
+              <a:shade val="15000"/>
+            </a:schemeClr>
+          </a:lnRef>
+          <a:fillRef idx="1">
+            <a:schemeClr val="accent1"/>
+          </a:fillRef>
+          <a:effectRef idx="0">
+            <a:schemeClr val="accent1"/>
+          </a:effectRef>
+          <a:fontRef idx="minor">
+            <a:schemeClr val="lt1"/>
+          </a:fontRef>
+        </p:style>
+        <p:txBody>
+          <a:bodyPr rtlCol="0" anchor="ctr"/>
+          <a:lstStyle/>
+          <a:p>
+            <a:pPr algn="ctr"/>
+            <a:endParaRPr lang="de-DE"/>
+          </a:p>
+        </p:txBody>
+      </p:sp>
+      <p:sp>
+        <p:nvSpPr>
+          <p:cNvPr id="14" name="Rechteck 13">
+            <a:extLst>
+              <a:ext uri="{FF2B5EF4-FFF2-40B4-BE49-F238E27FC236}">
+                <a16:creationId xmlns:a16="http://schemas.microsoft.com/office/drawing/2014/main" id="{FAF53C63-EA9C-9251-1BA2-AD50EAF31496}"/>
+              </a:ext>
+            </a:extLst>
+          </p:cNvPr>
+          <p:cNvSpPr/>
+          <p:nvPr/>
+        </p:nvSpPr>
+        <p:spPr>
+          <a:xfrm>
+            <a:off x="925286" y="2116684"/>
+            <a:ext cx="4053114" cy="1601410"/>
+          </a:xfrm>
+          <a:prstGeom prst="rect">
+            <a:avLst/>
+          </a:prstGeom>
+          <a:noFill/>
+          <a:ln w="38100">
+            <a:solidFill>
+              <a:schemeClr val="accent1"/>
+            </a:solidFill>
+          </a:ln>
+        </p:spPr>
+        <p:style>
+          <a:lnRef idx="2">
+            <a:schemeClr val="accent1">
+              <a:shade val="15000"/>
+            </a:schemeClr>
+          </a:lnRef>
+          <a:fillRef idx="1">
+            <a:schemeClr val="accent1"/>
+          </a:fillRef>
+          <a:effectRef idx="0">
+            <a:schemeClr val="accent1"/>
+          </a:effectRef>
+          <a:fontRef idx="minor">
+            <a:schemeClr val="lt1"/>
+          </a:fontRef>
+        </p:style>
+        <p:txBody>
+          <a:bodyPr rtlCol="0" anchor="ctr"/>
+          <a:lstStyle/>
+          <a:p>
+            <a:pPr algn="ctr"/>
+            <a:endParaRPr lang="de-DE"/>
+          </a:p>
+        </p:txBody>
+      </p:sp>
+      <p:sp>
+        <p:nvSpPr>
+          <p:cNvPr id="7" name="Textfeld 6">
+            <a:extLst>
+              <a:ext uri="{FF2B5EF4-FFF2-40B4-BE49-F238E27FC236}">
+                <a16:creationId xmlns:a16="http://schemas.microsoft.com/office/drawing/2014/main" id="{340FB149-009D-C044-D194-94C0430590E1}"/>
+              </a:ext>
+            </a:extLst>
+          </p:cNvPr>
+          <p:cNvSpPr txBox="1"/>
+          <p:nvPr/>
+        </p:nvSpPr>
+        <p:spPr>
+          <a:xfrm>
+            <a:off x="1039748" y="1877291"/>
+            <a:ext cx="2821710" cy="461665"/>
+          </a:xfrm>
+          <a:prstGeom prst="rect">
+            <a:avLst/>
+          </a:prstGeom>
+          <a:solidFill>
+            <a:schemeClr val="bg1"/>
+          </a:solidFill>
+        </p:spPr>
+        <p:txBody>
+          <a:bodyPr rot="0" spcFirstLastPara="0" vertOverflow="overflow" horzOverflow="overflow" vert="horz" wrap="square" lIns="91440" tIns="45720" rIns="91440" bIns="45720" numCol="1" spcCol="0" rtlCol="0" fromWordArt="0" anchor="t" anchorCtr="0" forceAA="0" compatLnSpc="1">
+            <a:prstTxWarp prst="textNoShape">
+              <a:avLst/>
+            </a:prstTxWarp>
+            <a:spAutoFit/>
+          </a:bodyPr>
+          <a:lstStyle/>
+          <a:p>
+            <a:r>
+              <a:rPr lang="de-DE" sz="2400" b="1"/>
+              <a:t>Ursprüngliche Idee</a:t>
+            </a:r>
+          </a:p>
+        </p:txBody>
+      </p:sp>
+      <p:sp>
+        <p:nvSpPr>
+          <p:cNvPr id="16" name="Rechteck 15">
+            <a:extLst>
+              <a:ext uri="{FF2B5EF4-FFF2-40B4-BE49-F238E27FC236}">
+                <a16:creationId xmlns:a16="http://schemas.microsoft.com/office/drawing/2014/main" id="{4AA8CB4E-3139-D985-7A4A-FF4AFEB7FAD2}"/>
+              </a:ext>
+            </a:extLst>
+          </p:cNvPr>
+          <p:cNvSpPr/>
+          <p:nvPr/>
+        </p:nvSpPr>
+        <p:spPr>
+          <a:xfrm>
+            <a:off x="925285" y="4380912"/>
+            <a:ext cx="4045858" cy="1601411"/>
+          </a:xfrm>
+          <a:prstGeom prst="rect">
+            <a:avLst/>
+          </a:prstGeom>
+          <a:noFill/>
+          <a:ln w="38100">
+            <a:solidFill>
+              <a:schemeClr val="accent1"/>
+            </a:solidFill>
+          </a:ln>
+        </p:spPr>
+        <p:style>
+          <a:lnRef idx="2">
+            <a:schemeClr val="accent1">
+              <a:shade val="15000"/>
+            </a:schemeClr>
+          </a:lnRef>
+          <a:fillRef idx="1">
+            <a:schemeClr val="accent1"/>
+          </a:fillRef>
+          <a:effectRef idx="0">
+            <a:schemeClr val="accent1"/>
+          </a:effectRef>
+          <a:fontRef idx="minor">
+            <a:schemeClr val="lt1"/>
+          </a:fontRef>
+        </p:style>
+        <p:txBody>
+          <a:bodyPr rtlCol="0" anchor="ctr"/>
+          <a:lstStyle/>
+          <a:p>
+            <a:pPr algn="ctr"/>
+            <a:endParaRPr lang="de-DE"/>
+          </a:p>
+        </p:txBody>
+      </p:sp>
+      <p:sp>
+        <p:nvSpPr>
+          <p:cNvPr id="8" name="Textfeld 7">
+            <a:extLst>
+              <a:ext uri="{FF2B5EF4-FFF2-40B4-BE49-F238E27FC236}">
+                <a16:creationId xmlns:a16="http://schemas.microsoft.com/office/drawing/2014/main" id="{A9FDF06F-5F41-909A-19C0-502FA12CC67E}"/>
+              </a:ext>
+            </a:extLst>
+          </p:cNvPr>
+          <p:cNvSpPr txBox="1"/>
+          <p:nvPr/>
+        </p:nvSpPr>
+        <p:spPr>
+          <a:xfrm>
+            <a:off x="1040740" y="4146797"/>
+            <a:ext cx="2921660" cy="461665"/>
+          </a:xfrm>
+          <a:prstGeom prst="rect">
+            <a:avLst/>
+          </a:prstGeom>
+          <a:solidFill>
+            <a:schemeClr val="bg1"/>
+          </a:solidFill>
+        </p:spPr>
+        <p:txBody>
+          <a:bodyPr rot="0" spcFirstLastPara="0" vertOverflow="overflow" horzOverflow="overflow" vert="horz" wrap="square" lIns="91440" tIns="45720" rIns="91440" bIns="45720" numCol="1" spcCol="0" rtlCol="0" fromWordArt="0" anchor="t" anchorCtr="0" forceAA="0" compatLnSpc="1">
+            <a:prstTxWarp prst="textNoShape">
+              <a:avLst/>
+            </a:prstTxWarp>
+            <a:spAutoFit/>
+          </a:bodyPr>
+          <a:lstStyle/>
+          <a:p>
+            <a:r>
+              <a:rPr lang="de-DE" sz="2400" b="1"/>
+              <a:t>Umgesetzte Lösung</a:t>
+            </a:r>
+          </a:p>
+        </p:txBody>
+      </p:sp>
+    </p:spTree>
+    <p:extLst>
+      <p:ext uri="{BB962C8B-B14F-4D97-AF65-F5344CB8AC3E}">
+        <p14:creationId xmlns:p14="http://schemas.microsoft.com/office/powerpoint/2010/main" val="1977590359"/>
+      </p:ext>
+    </p:extLst>
+  </p:cSld>
+  <p:clrMapOvr>
+    <a:masterClrMapping/>
+  </p:clrMapOvr>
+</p:sld>
+</file>
+
+<file path=ppt/slides/slide13.xml><?xml version="1.0" encoding="utf-8"?>
 <p:sld xmlns:a="http://schemas.openxmlformats.org/drawingml/2006/main" xmlns:r="http://schemas.openxmlformats.org/officeDocument/2006/relationships" xmlns:p="http://schemas.openxmlformats.org/presentationml/2006/main">
   <p:cSld>
     <p:spTree>
@@ -6159,7 +6896,7 @@
           <a:p>
             <a:fld id="{6C43980B-2C02-594B-9C73-A951FE425682}" type="slidenum">
               <a:rPr lang="de-DE" smtClean="0"/>
-              <a:t>12</a:t>
+              <a:t>13</a:t>
             </a:fld>
             <a:endParaRPr lang="de-DE" dirty="0"/>
           </a:p>
@@ -6178,7 +6915,7 @@
 </p:sld>
 </file>
 
-<file path=ppt/slides/slide13.xml><?xml version="1.0" encoding="utf-8"?>
+<file path=ppt/slides/slide14.xml><?xml version="1.0" encoding="utf-8"?>
 <p:sld xmlns:a="http://schemas.openxmlformats.org/drawingml/2006/main" xmlns:r="http://schemas.openxmlformats.org/officeDocument/2006/relationships" xmlns:p="http://schemas.openxmlformats.org/presentationml/2006/main">
   <p:cSld>
     <p:spTree>
@@ -6223,36 +6960,25 @@
           <a:lstStyle/>
           <a:p>
             <a:r>
-              <a:rPr lang="de-DE"/>
-              <a:t>PLATZHALTER FOLIEN THOMAS</a:t>
+              <a:rPr lang="de-DE" dirty="0">
+                <a:ea typeface="+mj-lt"/>
+                <a:cs typeface="+mj-lt"/>
+              </a:rPr>
+              <a:t>Steuerung über </a:t>
             </a:r>
-          </a:p>
-        </p:txBody>
-      </p:sp>
-      <p:sp>
-        <p:nvSpPr>
-          <p:cNvPr id="3" name="Inhaltsplatzhalter 2">
-            <a:extLst>
-              <a:ext uri="{FF2B5EF4-FFF2-40B4-BE49-F238E27FC236}">
-                <a16:creationId xmlns:a16="http://schemas.microsoft.com/office/drawing/2014/main" id="{B2943D88-2FB6-CF78-A587-C0A5A330EEA0}"/>
-              </a:ext>
-            </a:extLst>
-          </p:cNvPr>
-          <p:cNvSpPr>
-            <a:spLocks noGrp="1"/>
-          </p:cNvSpPr>
-          <p:nvPr>
-            <p:ph idx="1"/>
-          </p:nvPr>
-        </p:nvSpPr>
-        <p:spPr/>
-        <p:txBody>
-          <a:bodyPr/>
-          <a:lstStyle/>
-          <a:p>
             <a:r>
-              <a:rPr lang="de-DE"/>
-              <a:t>PLATZHALTER FOLIEN THOMAS</a:t>
+              <a:rPr lang="de-DE" dirty="0" err="1">
+                <a:ea typeface="+mj-lt"/>
+                <a:cs typeface="+mj-lt"/>
+              </a:rPr>
+              <a:t>MicroBlaze</a:t>
+            </a:r>
+            <a:r>
+              <a:rPr lang="de-DE" dirty="0">
+                <a:ea typeface="+mj-lt"/>
+                <a:cs typeface="+mj-lt"/>
+              </a:rPr>
+              <a:t> und UART</a:t>
             </a:r>
           </a:p>
         </p:txBody>
@@ -6280,9 +7006,1046 @@
           <a:p>
             <a:fld id="{6C43980B-2C02-594B-9C73-A951FE425682}" type="slidenum">
               <a:rPr lang="de-DE" smtClean="0"/>
-              <a:t>13</a:t>
+              <a:t>14</a:t>
             </a:fld>
             <a:endParaRPr lang="de-DE" dirty="0"/>
+          </a:p>
+        </p:txBody>
+      </p:sp>
+      <p:sp>
+        <p:nvSpPr>
+          <p:cNvPr id="7" name="Textfeld 6">
+            <a:extLst>
+              <a:ext uri="{FF2B5EF4-FFF2-40B4-BE49-F238E27FC236}">
+                <a16:creationId xmlns:a16="http://schemas.microsoft.com/office/drawing/2014/main" id="{49D0F191-4538-4A13-DB2D-864D7511E53C}"/>
+              </a:ext>
+            </a:extLst>
+          </p:cNvPr>
+          <p:cNvSpPr txBox="1"/>
+          <p:nvPr/>
+        </p:nvSpPr>
+        <p:spPr>
+          <a:xfrm>
+            <a:off x="1128486" y="1604818"/>
+            <a:ext cx="1524000" cy="369332"/>
+          </a:xfrm>
+          <a:prstGeom prst="rect">
+            <a:avLst/>
+          </a:prstGeom>
+          <a:noFill/>
+        </p:spPr>
+        <p:txBody>
+          <a:bodyPr rot="0" spcFirstLastPara="0" vertOverflow="overflow" horzOverflow="overflow" vert="horz" wrap="square" lIns="91440" tIns="45720" rIns="91440" bIns="45720" numCol="1" spcCol="0" rtlCol="0" fromWordArt="0" anchor="t" anchorCtr="0" forceAA="0" compatLnSpc="1">
+            <a:prstTxWarp prst="textNoShape">
+              <a:avLst/>
+            </a:prstTxWarp>
+            <a:spAutoFit/>
+          </a:bodyPr>
+          <a:lstStyle/>
+          <a:p>
+            <a:pPr algn="ctr"/>
+            <a:r>
+              <a:rPr lang="de-DE"/>
+              <a:t>Benutzer</a:t>
+            </a:r>
+            <a:endParaRPr lang="en-US"/>
+          </a:p>
+        </p:txBody>
+      </p:sp>
+      <p:sp>
+        <p:nvSpPr>
+          <p:cNvPr id="8" name="Textfeld 7">
+            <a:extLst>
+              <a:ext uri="{FF2B5EF4-FFF2-40B4-BE49-F238E27FC236}">
+                <a16:creationId xmlns:a16="http://schemas.microsoft.com/office/drawing/2014/main" id="{13CB833B-F55D-D02B-2E1E-BC75CF3AD960}"/>
+              </a:ext>
+            </a:extLst>
+          </p:cNvPr>
+          <p:cNvSpPr txBox="1"/>
+          <p:nvPr/>
+        </p:nvSpPr>
+        <p:spPr>
+          <a:xfrm>
+            <a:off x="1033813" y="2645558"/>
+            <a:ext cx="1743363" cy="369332"/>
+          </a:xfrm>
+          <a:prstGeom prst="rect">
+            <a:avLst/>
+          </a:prstGeom>
+          <a:noFill/>
+        </p:spPr>
+        <p:txBody>
+          <a:bodyPr rot="0" spcFirstLastPara="0" vertOverflow="overflow" horzOverflow="overflow" vert="horz" wrap="square" lIns="91440" tIns="45720" rIns="91440" bIns="45720" numCol="1" spcCol="0" rtlCol="0" fromWordArt="0" anchor="t" anchorCtr="0" forceAA="0" compatLnSpc="1">
+            <a:prstTxWarp prst="textNoShape">
+              <a:avLst/>
+            </a:prstTxWarp>
+            <a:spAutoFit/>
+          </a:bodyPr>
+          <a:lstStyle/>
+          <a:p>
+            <a:pPr algn="ctr"/>
+            <a:r>
+              <a:rPr lang="de-DE"/>
+              <a:t>UART-Konsole</a:t>
+            </a:r>
+            <a:endParaRPr lang="en-US"/>
+          </a:p>
+        </p:txBody>
+      </p:sp>
+      <p:sp>
+        <p:nvSpPr>
+          <p:cNvPr id="9" name="Textfeld 8">
+            <a:extLst>
+              <a:ext uri="{FF2B5EF4-FFF2-40B4-BE49-F238E27FC236}">
+                <a16:creationId xmlns:a16="http://schemas.microsoft.com/office/drawing/2014/main" id="{FA67A4BF-8D46-EC08-9548-7A6DD24EA469}"/>
+              </a:ext>
+            </a:extLst>
+          </p:cNvPr>
+          <p:cNvSpPr txBox="1"/>
+          <p:nvPr/>
+        </p:nvSpPr>
+        <p:spPr>
+          <a:xfrm>
+            <a:off x="1117600" y="3705430"/>
+            <a:ext cx="1537524" cy="369332"/>
+          </a:xfrm>
+          <a:prstGeom prst="rect">
+            <a:avLst/>
+          </a:prstGeom>
+          <a:noFill/>
+        </p:spPr>
+        <p:txBody>
+          <a:bodyPr rot="0" spcFirstLastPara="0" vertOverflow="overflow" horzOverflow="overflow" vert="horz" wrap="square" lIns="91440" tIns="45720" rIns="91440" bIns="45720" numCol="1" spcCol="0" rtlCol="0" fromWordArt="0" anchor="t" anchorCtr="0" forceAA="0" compatLnSpc="1">
+            <a:prstTxWarp prst="textNoShape">
+              <a:avLst/>
+            </a:prstTxWarp>
+            <a:spAutoFit/>
+          </a:bodyPr>
+          <a:lstStyle/>
+          <a:p>
+            <a:pPr algn="ctr"/>
+            <a:r>
+              <a:rPr lang="de-DE" dirty="0" err="1"/>
+              <a:t>MicroBla</a:t>
+            </a:r>
+            <a:r>
+              <a:rPr lang="de-DE" dirty="0" err="1">
+                <a:solidFill>
+                  <a:srgbClr val="000000"/>
+                </a:solidFill>
+                <a:latin typeface="Aptos"/>
+              </a:rPr>
+              <a:t>ze</a:t>
+            </a:r>
+            <a:endParaRPr lang="de-DE" dirty="0" err="1"/>
+          </a:p>
+        </p:txBody>
+      </p:sp>
+      <p:sp>
+        <p:nvSpPr>
+          <p:cNvPr id="10" name="Textfeld 9">
+            <a:extLst>
+              <a:ext uri="{FF2B5EF4-FFF2-40B4-BE49-F238E27FC236}">
+                <a16:creationId xmlns:a16="http://schemas.microsoft.com/office/drawing/2014/main" id="{D5FCAC23-7F6D-C180-317C-BC578C9974A2}"/>
+              </a:ext>
+            </a:extLst>
+          </p:cNvPr>
+          <p:cNvSpPr txBox="1"/>
+          <p:nvPr/>
+        </p:nvSpPr>
+        <p:spPr>
+          <a:xfrm>
+            <a:off x="734621" y="4755078"/>
+            <a:ext cx="2309090" cy="369332"/>
+          </a:xfrm>
+          <a:prstGeom prst="rect">
+            <a:avLst/>
+          </a:prstGeom>
+          <a:noFill/>
+        </p:spPr>
+        <p:txBody>
+          <a:bodyPr rot="0" spcFirstLastPara="0" vertOverflow="overflow" horzOverflow="overflow" vert="horz" wrap="square" lIns="91440" tIns="45720" rIns="91440" bIns="45720" numCol="1" spcCol="0" rtlCol="0" fromWordArt="0" anchor="t" anchorCtr="0" forceAA="0" compatLnSpc="1">
+            <a:prstTxWarp prst="textNoShape">
+              <a:avLst/>
+            </a:prstTxWarp>
+            <a:spAutoFit/>
+          </a:bodyPr>
+          <a:lstStyle/>
+          <a:p>
+            <a:pPr algn="ctr"/>
+            <a:r>
+              <a:rPr lang="de-DE"/>
+              <a:t>AXI-Lite Register</a:t>
+            </a:r>
+            <a:endParaRPr lang="en-US"/>
+          </a:p>
+        </p:txBody>
+      </p:sp>
+      <p:sp>
+        <p:nvSpPr>
+          <p:cNvPr id="11" name="Textfeld 10">
+            <a:extLst>
+              <a:ext uri="{FF2B5EF4-FFF2-40B4-BE49-F238E27FC236}">
+                <a16:creationId xmlns:a16="http://schemas.microsoft.com/office/drawing/2014/main" id="{758792F2-3ACB-C6DA-A7F2-0C36E07EA4D9}"/>
+              </a:ext>
+            </a:extLst>
+          </p:cNvPr>
+          <p:cNvSpPr txBox="1"/>
+          <p:nvPr/>
+        </p:nvSpPr>
+        <p:spPr>
+          <a:xfrm>
+            <a:off x="300511" y="5725886"/>
+            <a:ext cx="1905000" cy="369332"/>
+          </a:xfrm>
+          <a:prstGeom prst="rect">
+            <a:avLst/>
+          </a:prstGeom>
+          <a:noFill/>
+        </p:spPr>
+        <p:txBody>
+          <a:bodyPr rot="0" spcFirstLastPara="0" vertOverflow="overflow" horzOverflow="overflow" vert="horz" wrap="square" lIns="91440" tIns="45720" rIns="91440" bIns="45720" numCol="1" spcCol="0" rtlCol="0" fromWordArt="0" anchor="t" anchorCtr="0" forceAA="0" compatLnSpc="1">
+            <a:prstTxWarp prst="textNoShape">
+              <a:avLst/>
+            </a:prstTxWarp>
+            <a:spAutoFit/>
+          </a:bodyPr>
+          <a:lstStyle/>
+          <a:p>
+            <a:pPr algn="ctr"/>
+            <a:r>
+              <a:rPr lang="de-DE" dirty="0"/>
+              <a:t>Init</a:t>
+            </a:r>
+            <a:r>
+              <a:rPr lang="de-DE"/>
+              <a:t>ialwerte</a:t>
+            </a:r>
+            <a:endParaRPr lang="en-US"/>
+          </a:p>
+        </p:txBody>
+      </p:sp>
+      <p:sp>
+        <p:nvSpPr>
+          <p:cNvPr id="12" name="Textfeld 11">
+            <a:extLst>
+              <a:ext uri="{FF2B5EF4-FFF2-40B4-BE49-F238E27FC236}">
+                <a16:creationId xmlns:a16="http://schemas.microsoft.com/office/drawing/2014/main" id="{5F31B198-17AF-4490-699A-5D8661C92EE0}"/>
+              </a:ext>
+            </a:extLst>
+          </p:cNvPr>
+          <p:cNvSpPr txBox="1"/>
+          <p:nvPr/>
+        </p:nvSpPr>
+        <p:spPr>
+          <a:xfrm>
+            <a:off x="2903186" y="5724566"/>
+            <a:ext cx="1685306" cy="369332"/>
+          </a:xfrm>
+          <a:prstGeom prst="rect">
+            <a:avLst/>
+          </a:prstGeom>
+          <a:noFill/>
+        </p:spPr>
+        <p:txBody>
+          <a:bodyPr rot="0" spcFirstLastPara="0" vertOverflow="overflow" horzOverflow="overflow" vert="horz" wrap="square" lIns="91440" tIns="45720" rIns="91440" bIns="45720" numCol="1" spcCol="0" rtlCol="0" fromWordArt="0" anchor="t" anchorCtr="0" forceAA="0" compatLnSpc="1">
+            <a:prstTxWarp prst="textNoShape">
+              <a:avLst/>
+            </a:prstTxWarp>
+            <a:spAutoFit/>
+          </a:bodyPr>
+          <a:lstStyle/>
+          <a:p>
+            <a:pPr algn="ctr"/>
+            <a:r>
+              <a:rPr lang="de-DE" dirty="0"/>
+              <a:t>Farb</a:t>
+            </a:r>
+            <a:r>
+              <a:rPr lang="de-DE"/>
+              <a:t>schema</a:t>
+            </a:r>
+            <a:endParaRPr lang="en-US"/>
+          </a:p>
+        </p:txBody>
+      </p:sp>
+      <p:sp>
+        <p:nvSpPr>
+          <p:cNvPr id="13" name="Textfeld 12">
+            <a:extLst>
+              <a:ext uri="{FF2B5EF4-FFF2-40B4-BE49-F238E27FC236}">
+                <a16:creationId xmlns:a16="http://schemas.microsoft.com/office/drawing/2014/main" id="{B176685B-4E8A-FD7E-41CD-66F0D9BF111C}"/>
+              </a:ext>
+            </a:extLst>
+          </p:cNvPr>
+          <p:cNvSpPr txBox="1"/>
+          <p:nvPr/>
+        </p:nvSpPr>
+        <p:spPr>
+          <a:xfrm>
+            <a:off x="5579754" y="2373744"/>
+            <a:ext cx="4820061" cy="1477328"/>
+          </a:xfrm>
+          <a:prstGeom prst="rect">
+            <a:avLst/>
+          </a:prstGeom>
+          <a:noFill/>
+        </p:spPr>
+        <p:txBody>
+          <a:bodyPr rot="0" spcFirstLastPara="0" vertOverflow="overflow" horzOverflow="overflow" vert="horz" wrap="square" lIns="91440" tIns="45720" rIns="91440" bIns="45720" numCol="1" spcCol="0" rtlCol="0" fromWordArt="0" anchor="t" anchorCtr="0" forceAA="0" compatLnSpc="1">
+            <a:prstTxWarp prst="textNoShape">
+              <a:avLst/>
+            </a:prstTxWarp>
+            <a:spAutoFit/>
+          </a:bodyPr>
+          <a:lstStyle/>
+          <a:p>
+            <a:pPr marL="285750" indent="-285750">
+              <a:buFont typeface="Arial"/>
+              <a:buChar char="•"/>
+            </a:pPr>
+            <a:r>
+              <a:rPr lang="de-DE">
+                <a:ea typeface="+mn-lt"/>
+                <a:cs typeface="+mn-lt"/>
+              </a:rPr>
+              <a:t>Laufzeitkonfiguration ohne neue Synthese </a:t>
+            </a:r>
+            <a:endParaRPr lang="de-DE"/>
+          </a:p>
+          <a:p>
+            <a:pPr marL="285750" indent="-285750">
+              <a:buFont typeface="Arial"/>
+              <a:buChar char="•"/>
+            </a:pPr>
+            <a:r>
+              <a:rPr lang="de-DE">
+                <a:ea typeface="+mn-lt"/>
+                <a:cs typeface="+mn-lt"/>
+              </a:rPr>
+              <a:t>Auswahl von Mandelbrot- und Julia-Modi </a:t>
+            </a:r>
+            <a:endParaRPr lang="de-DE"/>
+          </a:p>
+          <a:p>
+            <a:pPr marL="285750" indent="-285750">
+              <a:buFont typeface="Arial"/>
+              <a:buChar char="•"/>
+            </a:pPr>
+            <a:r>
+              <a:rPr lang="de-DE">
+                <a:ea typeface="+mn-lt"/>
+                <a:cs typeface="+mn-lt"/>
+              </a:rPr>
+              <a:t>Zoom und Animationsgeschwindigkeit </a:t>
+            </a:r>
+            <a:endParaRPr lang="de-DE"/>
+          </a:p>
+          <a:p>
+            <a:pPr marL="285750" indent="-285750">
+              <a:buFont typeface="Arial"/>
+              <a:buChar char="•"/>
+            </a:pPr>
+            <a:r>
+              <a:rPr lang="de-DE">
+                <a:ea typeface="+mn-lt"/>
+                <a:cs typeface="+mn-lt"/>
+              </a:rPr>
+              <a:t>LFSR- und Diamond-Parameter </a:t>
+            </a:r>
+            <a:endParaRPr lang="de-DE"/>
+          </a:p>
+          <a:p>
+            <a:pPr marL="285750" indent="-285750">
+              <a:buFont typeface="Arial"/>
+              <a:buChar char="•"/>
+            </a:pPr>
+            <a:r>
+              <a:rPr lang="de-DE">
+                <a:ea typeface="+mn-lt"/>
+                <a:cs typeface="+mn-lt"/>
+              </a:rPr>
+              <a:t>Farbschema konfigurierbar</a:t>
+            </a:r>
+            <a:endParaRPr lang="de-DE"/>
+          </a:p>
+        </p:txBody>
+      </p:sp>
+      <p:cxnSp>
+        <p:nvCxnSpPr>
+          <p:cNvPr id="15" name="Verbinder: gewinkelt 14">
+            <a:extLst>
+              <a:ext uri="{FF2B5EF4-FFF2-40B4-BE49-F238E27FC236}">
+                <a16:creationId xmlns:a16="http://schemas.microsoft.com/office/drawing/2014/main" id="{576E06BB-FFC1-F4B9-D321-913A938C9B47}"/>
+              </a:ext>
+            </a:extLst>
+          </p:cNvPr>
+          <p:cNvCxnSpPr/>
+          <p:nvPr/>
+        </p:nvCxnSpPr>
+        <p:spPr>
+          <a:xfrm>
+            <a:off x="1895763" y="2011549"/>
+            <a:ext cx="2968" cy="548904"/>
+          </a:xfrm>
+          <a:prstGeom prst="bentConnector3">
+            <a:avLst/>
+          </a:prstGeom>
+          <a:ln>
+            <a:tailEnd type="triangle"/>
+          </a:ln>
+        </p:spPr>
+        <p:style>
+          <a:lnRef idx="1">
+            <a:schemeClr val="dk1"/>
+          </a:lnRef>
+          <a:fillRef idx="0">
+            <a:schemeClr val="dk1"/>
+          </a:fillRef>
+          <a:effectRef idx="0">
+            <a:schemeClr val="dk1"/>
+          </a:effectRef>
+          <a:fontRef idx="minor">
+            <a:schemeClr val="tx1"/>
+          </a:fontRef>
+        </p:style>
+      </p:cxnSp>
+      <p:sp>
+        <p:nvSpPr>
+          <p:cNvPr id="4" name="Rechteck 13">
+            <a:extLst>
+              <a:ext uri="{FF2B5EF4-FFF2-40B4-BE49-F238E27FC236}">
+                <a16:creationId xmlns:a16="http://schemas.microsoft.com/office/drawing/2014/main" id="{FD42E074-B764-F01B-15CF-D78A9396F2F5}"/>
+              </a:ext>
+            </a:extLst>
+          </p:cNvPr>
+          <p:cNvSpPr/>
+          <p:nvPr/>
+        </p:nvSpPr>
+        <p:spPr>
+          <a:xfrm>
+            <a:off x="1026886" y="1557884"/>
+            <a:ext cx="1752600" cy="462039"/>
+          </a:xfrm>
+          <a:prstGeom prst="rect">
+            <a:avLst/>
+          </a:prstGeom>
+          <a:noFill/>
+          <a:ln w="38100">
+            <a:solidFill>
+              <a:schemeClr val="accent1"/>
+            </a:solidFill>
+          </a:ln>
+        </p:spPr>
+        <p:style>
+          <a:lnRef idx="2">
+            <a:schemeClr val="accent1">
+              <a:shade val="15000"/>
+            </a:schemeClr>
+          </a:lnRef>
+          <a:fillRef idx="1">
+            <a:schemeClr val="accent1"/>
+          </a:fillRef>
+          <a:effectRef idx="0">
+            <a:schemeClr val="accent1"/>
+          </a:effectRef>
+          <a:fontRef idx="minor">
+            <a:schemeClr val="lt1"/>
+          </a:fontRef>
+        </p:style>
+        <p:txBody>
+          <a:bodyPr rtlCol="0" anchor="ctr"/>
+          <a:lstStyle/>
+          <a:p>
+            <a:pPr algn="ctr"/>
+            <a:endParaRPr lang="de-DE"/>
+          </a:p>
+        </p:txBody>
+      </p:sp>
+      <p:sp>
+        <p:nvSpPr>
+          <p:cNvPr id="6" name="Rechteck 13">
+            <a:extLst>
+              <a:ext uri="{FF2B5EF4-FFF2-40B4-BE49-F238E27FC236}">
+                <a16:creationId xmlns:a16="http://schemas.microsoft.com/office/drawing/2014/main" id="{ED73F2AA-F415-EE8C-CE19-A6C73D61A472}"/>
+              </a:ext>
+            </a:extLst>
+          </p:cNvPr>
+          <p:cNvSpPr/>
+          <p:nvPr/>
+        </p:nvSpPr>
+        <p:spPr>
+          <a:xfrm>
+            <a:off x="1026885" y="2595655"/>
+            <a:ext cx="1752600" cy="462039"/>
+          </a:xfrm>
+          <a:prstGeom prst="rect">
+            <a:avLst/>
+          </a:prstGeom>
+          <a:noFill/>
+          <a:ln w="38100">
+            <a:solidFill>
+              <a:schemeClr val="accent1"/>
+            </a:solidFill>
+          </a:ln>
+        </p:spPr>
+        <p:style>
+          <a:lnRef idx="2">
+            <a:schemeClr val="accent1">
+              <a:shade val="15000"/>
+            </a:schemeClr>
+          </a:lnRef>
+          <a:fillRef idx="1">
+            <a:schemeClr val="accent1"/>
+          </a:fillRef>
+          <a:effectRef idx="0">
+            <a:schemeClr val="accent1"/>
+          </a:effectRef>
+          <a:fontRef idx="minor">
+            <a:schemeClr val="lt1"/>
+          </a:fontRef>
+        </p:style>
+        <p:txBody>
+          <a:bodyPr rtlCol="0" anchor="ctr"/>
+          <a:lstStyle/>
+          <a:p>
+            <a:pPr algn="ctr"/>
+            <a:endParaRPr lang="de-DE"/>
+          </a:p>
+        </p:txBody>
+      </p:sp>
+      <p:sp>
+        <p:nvSpPr>
+          <p:cNvPr id="16" name="Rechteck 13">
+            <a:extLst>
+              <a:ext uri="{FF2B5EF4-FFF2-40B4-BE49-F238E27FC236}">
+                <a16:creationId xmlns:a16="http://schemas.microsoft.com/office/drawing/2014/main" id="{0861E76F-2588-E727-D744-50A190E44B14}"/>
+              </a:ext>
+            </a:extLst>
+          </p:cNvPr>
+          <p:cNvSpPr/>
+          <p:nvPr/>
+        </p:nvSpPr>
+        <p:spPr>
+          <a:xfrm>
+            <a:off x="1005113" y="3655196"/>
+            <a:ext cx="1752600" cy="462039"/>
+          </a:xfrm>
+          <a:prstGeom prst="rect">
+            <a:avLst/>
+          </a:prstGeom>
+          <a:noFill/>
+          <a:ln w="38100">
+            <a:solidFill>
+              <a:schemeClr val="accent1"/>
+            </a:solidFill>
+          </a:ln>
+        </p:spPr>
+        <p:style>
+          <a:lnRef idx="2">
+            <a:schemeClr val="accent1">
+              <a:shade val="15000"/>
+            </a:schemeClr>
+          </a:lnRef>
+          <a:fillRef idx="1">
+            <a:schemeClr val="accent1"/>
+          </a:fillRef>
+          <a:effectRef idx="0">
+            <a:schemeClr val="accent1"/>
+          </a:effectRef>
+          <a:fontRef idx="minor">
+            <a:schemeClr val="lt1"/>
+          </a:fontRef>
+        </p:style>
+        <p:txBody>
+          <a:bodyPr rtlCol="0" anchor="ctr"/>
+          <a:lstStyle/>
+          <a:p>
+            <a:pPr algn="ctr"/>
+            <a:endParaRPr lang="de-DE"/>
+          </a:p>
+        </p:txBody>
+      </p:sp>
+      <p:sp>
+        <p:nvSpPr>
+          <p:cNvPr id="18" name="Rechteck 13">
+            <a:extLst>
+              <a:ext uri="{FF2B5EF4-FFF2-40B4-BE49-F238E27FC236}">
+                <a16:creationId xmlns:a16="http://schemas.microsoft.com/office/drawing/2014/main" id="{9C15B6C7-0EC5-58BA-7129-9ED3B013C193}"/>
+              </a:ext>
+            </a:extLst>
+          </p:cNvPr>
+          <p:cNvSpPr/>
+          <p:nvPr/>
+        </p:nvSpPr>
+        <p:spPr>
+          <a:xfrm>
+            <a:off x="939797" y="4707481"/>
+            <a:ext cx="1883228" cy="440268"/>
+          </a:xfrm>
+          <a:prstGeom prst="rect">
+            <a:avLst/>
+          </a:prstGeom>
+          <a:noFill/>
+          <a:ln w="38100">
+            <a:solidFill>
+              <a:schemeClr val="accent1"/>
+            </a:solidFill>
+          </a:ln>
+        </p:spPr>
+        <p:style>
+          <a:lnRef idx="2">
+            <a:schemeClr val="accent1">
+              <a:shade val="15000"/>
+            </a:schemeClr>
+          </a:lnRef>
+          <a:fillRef idx="1">
+            <a:schemeClr val="accent1"/>
+          </a:fillRef>
+          <a:effectRef idx="0">
+            <a:schemeClr val="accent1"/>
+          </a:effectRef>
+          <a:fontRef idx="minor">
+            <a:schemeClr val="lt1"/>
+          </a:fontRef>
+        </p:style>
+        <p:txBody>
+          <a:bodyPr rtlCol="0" anchor="ctr"/>
+          <a:lstStyle/>
+          <a:p>
+            <a:pPr algn="ctr"/>
+            <a:endParaRPr lang="de-DE"/>
+          </a:p>
+        </p:txBody>
+      </p:sp>
+      <p:cxnSp>
+        <p:nvCxnSpPr>
+          <p:cNvPr id="21" name="Verbinder: gewinkelt 14">
+            <a:extLst>
+              <a:ext uri="{FF2B5EF4-FFF2-40B4-BE49-F238E27FC236}">
+                <a16:creationId xmlns:a16="http://schemas.microsoft.com/office/drawing/2014/main" id="{B822ECD4-D887-FD4E-78F7-80ECE03535E2}"/>
+              </a:ext>
+            </a:extLst>
+          </p:cNvPr>
+          <p:cNvCxnSpPr>
+            <a:cxnSpLocks/>
+          </p:cNvCxnSpPr>
+          <p:nvPr/>
+        </p:nvCxnSpPr>
+        <p:spPr>
+          <a:xfrm>
+            <a:off x="1881248" y="3063834"/>
+            <a:ext cx="2968" cy="548904"/>
+          </a:xfrm>
+          <a:prstGeom prst="bentConnector3">
+            <a:avLst/>
+          </a:prstGeom>
+          <a:ln>
+            <a:tailEnd type="triangle"/>
+          </a:ln>
+        </p:spPr>
+        <p:style>
+          <a:lnRef idx="1">
+            <a:schemeClr val="dk1"/>
+          </a:lnRef>
+          <a:fillRef idx="0">
+            <a:schemeClr val="dk1"/>
+          </a:fillRef>
+          <a:effectRef idx="0">
+            <a:schemeClr val="dk1"/>
+          </a:effectRef>
+          <a:fontRef idx="minor">
+            <a:schemeClr val="tx1"/>
+          </a:fontRef>
+        </p:style>
+      </p:cxnSp>
+      <p:cxnSp>
+        <p:nvCxnSpPr>
+          <p:cNvPr id="22" name="Verbinder: gewinkelt 14">
+            <a:extLst>
+              <a:ext uri="{FF2B5EF4-FFF2-40B4-BE49-F238E27FC236}">
+                <a16:creationId xmlns:a16="http://schemas.microsoft.com/office/drawing/2014/main" id="{A49E6884-DA81-E522-5838-8FDD36325344}"/>
+              </a:ext>
+            </a:extLst>
+          </p:cNvPr>
+          <p:cNvCxnSpPr>
+            <a:cxnSpLocks/>
+          </p:cNvCxnSpPr>
+          <p:nvPr/>
+        </p:nvCxnSpPr>
+        <p:spPr>
+          <a:xfrm>
+            <a:off x="1873990" y="4123376"/>
+            <a:ext cx="2968" cy="548904"/>
+          </a:xfrm>
+          <a:prstGeom prst="bentConnector3">
+            <a:avLst/>
+          </a:prstGeom>
+          <a:ln>
+            <a:tailEnd type="triangle"/>
+          </a:ln>
+        </p:spPr>
+        <p:style>
+          <a:lnRef idx="1">
+            <a:schemeClr val="dk1"/>
+          </a:lnRef>
+          <a:fillRef idx="0">
+            <a:schemeClr val="dk1"/>
+          </a:fillRef>
+          <a:effectRef idx="0">
+            <a:schemeClr val="dk1"/>
+          </a:effectRef>
+          <a:fontRef idx="minor">
+            <a:schemeClr val="tx1"/>
+          </a:fontRef>
+        </p:style>
+      </p:cxnSp>
+      <p:sp>
+        <p:nvSpPr>
+          <p:cNvPr id="24" name="Rechteck 13">
+            <a:extLst>
+              <a:ext uri="{FF2B5EF4-FFF2-40B4-BE49-F238E27FC236}">
+                <a16:creationId xmlns:a16="http://schemas.microsoft.com/office/drawing/2014/main" id="{6B4C3D0B-8671-9870-0155-BCB4F2E4C955}"/>
+              </a:ext>
+            </a:extLst>
+          </p:cNvPr>
+          <p:cNvSpPr/>
+          <p:nvPr/>
+        </p:nvSpPr>
+        <p:spPr>
+          <a:xfrm>
+            <a:off x="373741" y="5679938"/>
+            <a:ext cx="1752600" cy="462039"/>
+          </a:xfrm>
+          <a:prstGeom prst="rect">
+            <a:avLst/>
+          </a:prstGeom>
+          <a:noFill/>
+          <a:ln w="38100">
+            <a:solidFill>
+              <a:schemeClr val="accent1"/>
+            </a:solidFill>
+          </a:ln>
+        </p:spPr>
+        <p:style>
+          <a:lnRef idx="2">
+            <a:schemeClr val="accent1">
+              <a:shade val="15000"/>
+            </a:schemeClr>
+          </a:lnRef>
+          <a:fillRef idx="1">
+            <a:schemeClr val="accent1"/>
+          </a:fillRef>
+          <a:effectRef idx="0">
+            <a:schemeClr val="accent1"/>
+          </a:effectRef>
+          <a:fontRef idx="minor">
+            <a:schemeClr val="lt1"/>
+          </a:fontRef>
+        </p:style>
+        <p:txBody>
+          <a:bodyPr rtlCol="0" anchor="ctr"/>
+          <a:lstStyle/>
+          <a:p>
+            <a:pPr algn="ctr"/>
+            <a:endParaRPr lang="de-DE"/>
+          </a:p>
+        </p:txBody>
+      </p:sp>
+      <p:sp>
+        <p:nvSpPr>
+          <p:cNvPr id="25" name="Rechteck 13">
+            <a:extLst>
+              <a:ext uri="{FF2B5EF4-FFF2-40B4-BE49-F238E27FC236}">
+                <a16:creationId xmlns:a16="http://schemas.microsoft.com/office/drawing/2014/main" id="{92BF46CA-F953-A77B-F497-5C179B5BEB25}"/>
+              </a:ext>
+            </a:extLst>
+          </p:cNvPr>
+          <p:cNvSpPr/>
+          <p:nvPr/>
+        </p:nvSpPr>
+        <p:spPr>
+          <a:xfrm>
+            <a:off x="2870198" y="5679938"/>
+            <a:ext cx="1752600" cy="462039"/>
+          </a:xfrm>
+          <a:prstGeom prst="rect">
+            <a:avLst/>
+          </a:prstGeom>
+          <a:noFill/>
+          <a:ln w="38100">
+            <a:solidFill>
+              <a:schemeClr val="accent1"/>
+            </a:solidFill>
+          </a:ln>
+        </p:spPr>
+        <p:style>
+          <a:lnRef idx="2">
+            <a:schemeClr val="accent1">
+              <a:shade val="15000"/>
+            </a:schemeClr>
+          </a:lnRef>
+          <a:fillRef idx="1">
+            <a:schemeClr val="accent1"/>
+          </a:fillRef>
+          <a:effectRef idx="0">
+            <a:schemeClr val="accent1"/>
+          </a:effectRef>
+          <a:fontRef idx="minor">
+            <a:schemeClr val="lt1"/>
+          </a:fontRef>
+        </p:style>
+        <p:txBody>
+          <a:bodyPr rtlCol="0" anchor="ctr"/>
+          <a:lstStyle/>
+          <a:p>
+            <a:pPr algn="ctr"/>
+            <a:endParaRPr lang="de-DE"/>
+          </a:p>
+        </p:txBody>
+      </p:sp>
+      <p:cxnSp>
+        <p:nvCxnSpPr>
+          <p:cNvPr id="29" name="Straight Arrow Connector 28">
+            <a:extLst>
+              <a:ext uri="{FF2B5EF4-FFF2-40B4-BE49-F238E27FC236}">
+                <a16:creationId xmlns:a16="http://schemas.microsoft.com/office/drawing/2014/main" id="{485C3814-DB70-C604-B766-ED15D50DF305}"/>
+              </a:ext>
+            </a:extLst>
+          </p:cNvPr>
+          <p:cNvCxnSpPr/>
+          <p:nvPr/>
+        </p:nvCxnSpPr>
+        <p:spPr>
+          <a:xfrm>
+            <a:off x="1886197" y="5168075"/>
+            <a:ext cx="1384" cy="270823"/>
+          </a:xfrm>
+          <a:prstGeom prst="straightConnector1">
+            <a:avLst/>
+          </a:prstGeom>
+        </p:spPr>
+        <p:style>
+          <a:lnRef idx="1">
+            <a:schemeClr val="dk1"/>
+          </a:lnRef>
+          <a:fillRef idx="0">
+            <a:schemeClr val="dk1"/>
+          </a:fillRef>
+          <a:effectRef idx="0">
+            <a:schemeClr val="dk1"/>
+          </a:effectRef>
+          <a:fontRef idx="minor">
+            <a:schemeClr val="tx1"/>
+          </a:fontRef>
+        </p:style>
+      </p:cxnSp>
+      <p:cxnSp>
+        <p:nvCxnSpPr>
+          <p:cNvPr id="30" name="Straight Arrow Connector 29">
+            <a:extLst>
+              <a:ext uri="{FF2B5EF4-FFF2-40B4-BE49-F238E27FC236}">
+                <a16:creationId xmlns:a16="http://schemas.microsoft.com/office/drawing/2014/main" id="{80C42D7A-0C16-33E7-AF2A-6CE5BFEC53C0}"/>
+              </a:ext>
+            </a:extLst>
+          </p:cNvPr>
+          <p:cNvCxnSpPr/>
+          <p:nvPr/>
+        </p:nvCxnSpPr>
+        <p:spPr>
+          <a:xfrm>
+            <a:off x="1217221" y="5446815"/>
+            <a:ext cx="2562821" cy="11545"/>
+          </a:xfrm>
+          <a:prstGeom prst="straightConnector1">
+            <a:avLst/>
+          </a:prstGeom>
+        </p:spPr>
+        <p:style>
+          <a:lnRef idx="1">
+            <a:schemeClr val="dk1"/>
+          </a:lnRef>
+          <a:fillRef idx="0">
+            <a:schemeClr val="dk1"/>
+          </a:fillRef>
+          <a:effectRef idx="0">
+            <a:schemeClr val="dk1"/>
+          </a:effectRef>
+          <a:fontRef idx="minor">
+            <a:schemeClr val="tx1"/>
+          </a:fontRef>
+        </p:style>
+      </p:cxnSp>
+      <p:cxnSp>
+        <p:nvCxnSpPr>
+          <p:cNvPr id="31" name="Straight Arrow Connector 30">
+            <a:extLst>
+              <a:ext uri="{FF2B5EF4-FFF2-40B4-BE49-F238E27FC236}">
+                <a16:creationId xmlns:a16="http://schemas.microsoft.com/office/drawing/2014/main" id="{645A3372-D29F-C2AE-2492-6EBE021A50B6}"/>
+              </a:ext>
+            </a:extLst>
+          </p:cNvPr>
+          <p:cNvCxnSpPr/>
+          <p:nvPr/>
+        </p:nvCxnSpPr>
+        <p:spPr>
+          <a:xfrm flipH="1">
+            <a:off x="1218077" y="5449454"/>
+            <a:ext cx="5740" cy="219363"/>
+          </a:xfrm>
+          <a:prstGeom prst="straightConnector1">
+            <a:avLst/>
+          </a:prstGeom>
+          <a:ln>
+            <a:tailEnd type="triangle"/>
+          </a:ln>
+        </p:spPr>
+        <p:style>
+          <a:lnRef idx="1">
+            <a:schemeClr val="dk1"/>
+          </a:lnRef>
+          <a:fillRef idx="0">
+            <a:schemeClr val="dk1"/>
+          </a:fillRef>
+          <a:effectRef idx="0">
+            <a:schemeClr val="dk1"/>
+          </a:effectRef>
+          <a:fontRef idx="minor">
+            <a:schemeClr val="tx1"/>
+          </a:fontRef>
+        </p:style>
+      </p:cxnSp>
+      <p:cxnSp>
+        <p:nvCxnSpPr>
+          <p:cNvPr id="32" name="Straight Arrow Connector 31">
+            <a:extLst>
+              <a:ext uri="{FF2B5EF4-FFF2-40B4-BE49-F238E27FC236}">
+                <a16:creationId xmlns:a16="http://schemas.microsoft.com/office/drawing/2014/main" id="{D3766EFB-9D8C-90A0-32F8-BC082C6AECA2}"/>
+              </a:ext>
+            </a:extLst>
+          </p:cNvPr>
+          <p:cNvCxnSpPr>
+            <a:cxnSpLocks/>
+          </p:cNvCxnSpPr>
+          <p:nvPr/>
+        </p:nvCxnSpPr>
+        <p:spPr>
+          <a:xfrm flipH="1">
+            <a:off x="3772590" y="5449453"/>
+            <a:ext cx="5740" cy="219363"/>
+          </a:xfrm>
+          <a:prstGeom prst="straightConnector1">
+            <a:avLst/>
+          </a:prstGeom>
+          <a:ln>
+            <a:tailEnd type="triangle"/>
+          </a:ln>
+        </p:spPr>
+        <p:style>
+          <a:lnRef idx="1">
+            <a:schemeClr val="dk1"/>
+          </a:lnRef>
+          <a:fillRef idx="0">
+            <a:schemeClr val="dk1"/>
+          </a:fillRef>
+          <a:effectRef idx="0">
+            <a:schemeClr val="dk1"/>
+          </a:effectRef>
+          <a:fontRef idx="minor">
+            <a:schemeClr val="tx1"/>
+          </a:fontRef>
+        </p:style>
+      </p:cxnSp>
+      <p:sp>
+        <p:nvSpPr>
+          <p:cNvPr id="33" name="Rechteck 13">
+            <a:extLst>
+              <a:ext uri="{FF2B5EF4-FFF2-40B4-BE49-F238E27FC236}">
+                <a16:creationId xmlns:a16="http://schemas.microsoft.com/office/drawing/2014/main" id="{C9BA192F-3C47-31E0-2FD2-79EC6AB4DC6B}"/>
+              </a:ext>
+            </a:extLst>
+          </p:cNvPr>
+          <p:cNvSpPr/>
+          <p:nvPr/>
+        </p:nvSpPr>
+        <p:spPr>
+          <a:xfrm>
+            <a:off x="5301342" y="2145711"/>
+            <a:ext cx="5090885" cy="1913468"/>
+          </a:xfrm>
+          <a:prstGeom prst="rect">
+            <a:avLst/>
+          </a:prstGeom>
+          <a:noFill/>
+          <a:ln w="38100">
+            <a:solidFill>
+              <a:schemeClr val="accent1"/>
+            </a:solidFill>
+          </a:ln>
+        </p:spPr>
+        <p:style>
+          <a:lnRef idx="2">
+            <a:schemeClr val="accent1">
+              <a:shade val="15000"/>
+            </a:schemeClr>
+          </a:lnRef>
+          <a:fillRef idx="1">
+            <a:schemeClr val="accent1"/>
+          </a:fillRef>
+          <a:effectRef idx="0">
+            <a:schemeClr val="accent1"/>
+          </a:effectRef>
+          <a:fontRef idx="minor">
+            <a:schemeClr val="lt1"/>
+          </a:fontRef>
+        </p:style>
+        <p:txBody>
+          <a:bodyPr rtlCol="0" anchor="ctr"/>
+          <a:lstStyle/>
+          <a:p>
+            <a:pPr algn="ctr"/>
+            <a:endParaRPr lang="de-DE"/>
+          </a:p>
+        </p:txBody>
+      </p:sp>
+      <p:sp>
+        <p:nvSpPr>
+          <p:cNvPr id="35" name="Textfeld 6">
+            <a:extLst>
+              <a:ext uri="{FF2B5EF4-FFF2-40B4-BE49-F238E27FC236}">
+                <a16:creationId xmlns:a16="http://schemas.microsoft.com/office/drawing/2014/main" id="{B6EFF2CD-FC2E-D778-4611-90F6CF2BD840}"/>
+              </a:ext>
+            </a:extLst>
+          </p:cNvPr>
+          <p:cNvSpPr txBox="1"/>
+          <p:nvPr/>
+        </p:nvSpPr>
+        <p:spPr>
+          <a:xfrm>
+            <a:off x="5488377" y="1906319"/>
+            <a:ext cx="2074225" cy="461665"/>
+          </a:xfrm>
+          <a:prstGeom prst="rect">
+            <a:avLst/>
+          </a:prstGeom>
+          <a:solidFill>
+            <a:schemeClr val="bg1"/>
+          </a:solidFill>
+        </p:spPr>
+        <p:txBody>
+          <a:bodyPr rot="0" spcFirstLastPara="0" vertOverflow="overflow" horzOverflow="overflow" vert="horz" wrap="square" lIns="91440" tIns="45720" rIns="91440" bIns="45720" numCol="1" spcCol="0" rtlCol="0" fromWordArt="0" anchor="t" anchorCtr="0" forceAA="0" compatLnSpc="1">
+            <a:prstTxWarp prst="textNoShape">
+              <a:avLst/>
+            </a:prstTxWarp>
+            <a:spAutoFit/>
+          </a:bodyPr>
+          <a:lstStyle/>
+          <a:p>
+            <a:r>
+              <a:rPr lang="de-DE" sz="2400" b="1"/>
+              <a:t>Konfiguration</a:t>
+            </a:r>
+            <a:endParaRPr lang="en-US"/>
           </a:p>
         </p:txBody>
       </p:sp>
@@ -6299,7 +8062,7 @@
 </p:sld>
 </file>
 
-<file path=ppt/slides/slide14.xml><?xml version="1.0" encoding="utf-8"?>
+<file path=ppt/slides/slide15.xml><?xml version="1.0" encoding="utf-8"?>
 <p:sld xmlns:a="http://schemas.openxmlformats.org/drawingml/2006/main" xmlns:r="http://schemas.openxmlformats.org/officeDocument/2006/relationships" xmlns:p="http://schemas.openxmlformats.org/presentationml/2006/main">
   <p:cSld>
     <p:spTree>
@@ -6569,7 +8332,7 @@
           <a:p>
             <a:fld id="{6C43980B-2C02-594B-9C73-A951FE425682}" type="slidenum">
               <a:rPr lang="de-DE" smtClean="0"/>
-              <a:t>14</a:t>
+              <a:t>15</a:t>
             </a:fld>
             <a:endParaRPr lang="de-DE" dirty="0"/>
           </a:p>
@@ -6588,7 +8351,7 @@
 </p:sld>
 </file>
 
-<file path=ppt/slides/slide15.xml><?xml version="1.0" encoding="utf-8"?>
+<file path=ppt/slides/slide16.xml><?xml version="1.0" encoding="utf-8"?>
 <p:sld xmlns:a="http://schemas.openxmlformats.org/drawingml/2006/main" xmlns:r="http://schemas.openxmlformats.org/officeDocument/2006/relationships" xmlns:p="http://schemas.openxmlformats.org/presentationml/2006/main">
   <p:cSld>
     <p:spTree>
@@ -6747,7 +8510,7 @@
 </p:sld>
 </file>
 
-<file path=ppt/slides/slide16.xml><?xml version="1.0" encoding="utf-8"?>
+<file path=ppt/slides/slide17.xml><?xml version="1.0" encoding="utf-8"?>
 <p:sld xmlns:a="http://schemas.openxmlformats.org/drawingml/2006/main" xmlns:r="http://schemas.openxmlformats.org/officeDocument/2006/relationships" xmlns:p="http://schemas.openxmlformats.org/presentationml/2006/main">
   <p:cSld>
     <p:spTree>
@@ -6840,7 +8603,7 @@
           <a:p>
             <a:fld id="{6C43980B-2C02-594B-9C73-A951FE425682}" type="slidenum">
               <a:rPr lang="de-DE" smtClean="0"/>
-              <a:t>16</a:t>
+              <a:t>17</a:t>
             </a:fld>
             <a:endParaRPr lang="de-DE" dirty="0"/>
           </a:p>
@@ -6850,128 +8613,6 @@
     <p:extLst>
       <p:ext uri="{BB962C8B-B14F-4D97-AF65-F5344CB8AC3E}">
         <p14:creationId xmlns:p14="http://schemas.microsoft.com/office/powerpoint/2010/main" val="716613756"/>
-      </p:ext>
-    </p:extLst>
-  </p:cSld>
-  <p:clrMapOvr>
-    <a:masterClrMapping/>
-  </p:clrMapOvr>
-</p:sld>
-</file>
-
-<file path=ppt/slides/slide17.xml><?xml version="1.0" encoding="utf-8"?>
-<p:sld xmlns:a="http://schemas.openxmlformats.org/drawingml/2006/main" xmlns:r="http://schemas.openxmlformats.org/officeDocument/2006/relationships" xmlns:p="http://schemas.openxmlformats.org/presentationml/2006/main">
-  <p:cSld>
-    <p:spTree>
-      <p:nvGrpSpPr>
-        <p:cNvPr id="1" name="">
-          <a:extLst>
-            <a:ext uri="{FF2B5EF4-FFF2-40B4-BE49-F238E27FC236}">
-              <a16:creationId xmlns:a16="http://schemas.microsoft.com/office/drawing/2014/main" id="{26499C9D-4180-7793-68ED-0A35743B1BED}"/>
-            </a:ext>
-          </a:extLst>
-        </p:cNvPr>
-        <p:cNvGrpSpPr/>
-        <p:nvPr/>
-      </p:nvGrpSpPr>
-      <p:grpSpPr>
-        <a:xfrm>
-          <a:off x="0" y="0"/>
-          <a:ext cx="0" cy="0"/>
-          <a:chOff x="0" y="0"/>
-          <a:chExt cx="0" cy="0"/>
-        </a:xfrm>
-      </p:grpSpPr>
-      <p:sp>
-        <p:nvSpPr>
-          <p:cNvPr id="2" name="Titel 1">
-            <a:extLst>
-              <a:ext uri="{FF2B5EF4-FFF2-40B4-BE49-F238E27FC236}">
-                <a16:creationId xmlns:a16="http://schemas.microsoft.com/office/drawing/2014/main" id="{0454727B-560E-EEFD-64B8-6F3327E30EDB}"/>
-              </a:ext>
-            </a:extLst>
-          </p:cNvPr>
-          <p:cNvSpPr>
-            <a:spLocks noGrp="1"/>
-          </p:cNvSpPr>
-          <p:nvPr>
-            <p:ph type="title"/>
-          </p:nvPr>
-        </p:nvSpPr>
-        <p:spPr/>
-        <p:txBody>
-          <a:bodyPr/>
-          <a:lstStyle/>
-          <a:p>
-            <a:r>
-              <a:rPr lang="de-DE" dirty="0"/>
-              <a:t>Arty A7 vs. Arty Z7</a:t>
-            </a:r>
-          </a:p>
-        </p:txBody>
-      </p:sp>
-      <p:pic>
-        <p:nvPicPr>
-          <p:cNvPr id="5" name="Grafik 4">
-            <a:extLst>
-              <a:ext uri="{FF2B5EF4-FFF2-40B4-BE49-F238E27FC236}">
-                <a16:creationId xmlns:a16="http://schemas.microsoft.com/office/drawing/2014/main" id="{8CF37E60-1E0C-2D5E-A7B2-745001B55E1E}"/>
-              </a:ext>
-            </a:extLst>
-          </p:cNvPr>
-          <p:cNvPicPr>
-            <a:picLocks noChangeAspect="1"/>
-          </p:cNvPicPr>
-          <p:nvPr/>
-        </p:nvPicPr>
-        <p:blipFill>
-          <a:blip r:embed="rId3"/>
-          <a:srcRect/>
-          <a:stretch/>
-        </p:blipFill>
-        <p:spPr>
-          <a:xfrm>
-            <a:off x="1755370" y="1489586"/>
-            <a:ext cx="8681259" cy="4998775"/>
-          </a:xfrm>
-          <a:prstGeom prst="rect">
-            <a:avLst/>
-          </a:prstGeom>
-        </p:spPr>
-      </p:pic>
-      <p:sp>
-        <p:nvSpPr>
-          <p:cNvPr id="4" name="Foliennummernplatzhalter 3">
-            <a:extLst>
-              <a:ext uri="{FF2B5EF4-FFF2-40B4-BE49-F238E27FC236}">
-                <a16:creationId xmlns:a16="http://schemas.microsoft.com/office/drawing/2014/main" id="{AD0DF6EF-19CE-71AE-3430-75A215A3AC09}"/>
-              </a:ext>
-            </a:extLst>
-          </p:cNvPr>
-          <p:cNvSpPr>
-            <a:spLocks noGrp="1"/>
-          </p:cNvSpPr>
-          <p:nvPr>
-            <p:ph type="sldNum" sz="quarter" idx="12"/>
-          </p:nvPr>
-        </p:nvSpPr>
-        <p:spPr/>
-        <p:txBody>
-          <a:bodyPr/>
-          <a:lstStyle/>
-          <a:p>
-            <a:fld id="{6C43980B-2C02-594B-9C73-A951FE425682}" type="slidenum">
-              <a:rPr lang="de-DE" smtClean="0"/>
-              <a:t>17</a:t>
-            </a:fld>
-            <a:endParaRPr lang="de-DE" dirty="0"/>
-          </a:p>
-        </p:txBody>
-      </p:sp>
-    </p:spTree>
-    <p:extLst>
-      <p:ext uri="{BB962C8B-B14F-4D97-AF65-F5344CB8AC3E}">
-        <p14:creationId xmlns:p14="http://schemas.microsoft.com/office/powerpoint/2010/main" val="1160231224"/>
       </p:ext>
     </p:extLst>
   </p:cSld>
@@ -22208,8 +23849,8 @@
           </a:p>
         </p:txBody>
       </p:sp>
-      <mc:AlternateContent xmlns:mc="http://schemas.openxmlformats.org/markup-compatibility/2006">
-        <mc:Choice xmlns:a14="http://schemas.microsoft.com/office/drawing/2010/main" Requires="a14">
+      <mc:AlternateContent xmlns:mc="http://schemas.openxmlformats.org/markup-compatibility/2006" xmlns:a14="http://schemas.microsoft.com/office/drawing/2010/main">
+        <mc:Choice Requires="a14">
           <p:sp>
             <p:nvSpPr>
               <p:cNvPr id="3" name="Inhaltsplatzhalter 2">
@@ -22516,7 +24157,7 @@
             </p:txBody>
           </p:sp>
         </mc:Choice>
-        <mc:Fallback>
+        <mc:Fallback xmlns="">
           <p:sp>
             <p:nvSpPr>
               <p:cNvPr id="3" name="Inhaltsplatzhalter 2">

</xml_diff>